<commit_message>
Matrix 23486: update to new version of the document, justify text
Co-Authored-By: Claude Opus 5.5 <noreply@anthropic.com>
Claude-Session: https://claude.ai/code/session_01F1WXR13Nv8neEtLhaK3ELa
</commit_message>
<xml_diff>
--- a/supervision-gobierno-corporativo/Matriz_Requerimientos_DS-SABAO-BCS-BC-23486.pptx
+++ b/supervision-gobierno-corporativo/Matriz_Requerimientos_DS-SABAO-BCS-BC-23486.pptx
@@ -1243,7 +1243,7 @@
                     <a:bodyPr/>
                     <a:lstStyle/>
                     <a:p>
-                      <a:pPr indent="0" marL="0">
+                      <a:pPr algn="just" indent="0" marL="0">
                         <a:buNone/>
                       </a:pPr>
                       <a:r>
@@ -1293,7 +1293,7 @@
                     <a:bodyPr/>
                     <a:lstStyle/>
                     <a:p>
-                      <a:pPr indent="0" marL="0">
+                      <a:pPr algn="just" indent="0" marL="0">
                         <a:buNone/>
                       </a:pPr>
                       <a:r>
@@ -1343,7 +1343,7 @@
                     <a:bodyPr/>
                     <a:lstStyle/>
                     <a:p>
-                      <a:pPr indent="0" marL="0">
+                      <a:pPr algn="just" indent="0" marL="0">
                         <a:buNone/>
                       </a:pPr>
                       <a:r>
@@ -1364,7 +1364,7 @@
                       </a:endParaRPr>
                     </a:p>
                     <a:p>
-                      <a:pPr indent="0" marL="0">
+                      <a:pPr algn="just" indent="0" marL="0">
                         <a:buNone/>
                       </a:pPr>
                       <a:r>
@@ -1416,7 +1416,7 @@
                     <a:bodyPr/>
                     <a:lstStyle/>
                     <a:p>
-                      <a:pPr indent="0" marL="0">
+                      <a:pPr algn="just" indent="0" marL="0">
                         <a:buNone/>
                       </a:pPr>
                       <a:r>
@@ -1474,7 +1474,7 @@
                     <a:bodyPr/>
                     <a:lstStyle/>
                     <a:p>
-                      <a:pPr indent="0" marL="0">
+                      <a:pPr algn="just" indent="0" marL="0">
                         <a:buNone/>
                       </a:pPr>
                       <a:r>
@@ -1524,7 +1524,7 @@
                     <a:bodyPr/>
                     <a:lstStyle/>
                     <a:p>
-                      <a:pPr indent="0" marL="0">
+                      <a:pPr algn="just" indent="0" marL="0">
                         <a:buNone/>
                       </a:pPr>
                       <a:r>
@@ -1571,7 +1571,7 @@
                     <a:bodyPr/>
                     <a:lstStyle/>
                     <a:p>
-                      <a:pPr indent="0" marL="0">
+                      <a:pPr algn="l" indent="0" marL="0">
                         <a:buNone/>
                       </a:pPr>
                       <a:r>
@@ -1620,7 +1620,7 @@
                     <a:bodyPr/>
                     <a:lstStyle/>
                     <a:p>
-                      <a:pPr indent="0" marL="0">
+                      <a:pPr algn="just" indent="0" marL="0">
                         <a:buNone/>
                       </a:pPr>
                       <a:r>
@@ -1670,7 +1670,7 @@
                     <a:bodyPr/>
                     <a:lstStyle/>
                     <a:p>
-                      <a:pPr indent="0" marL="0">
+                      <a:pPr algn="just" indent="0" marL="0">
                         <a:buNone/>
                       </a:pPr>
                       <a:r>
@@ -1717,7 +1717,7 @@
                     <a:bodyPr/>
                     <a:lstStyle/>
                     <a:p>
-                      <a:pPr indent="0" marL="0">
+                      <a:pPr algn="l" indent="0" marL="0">
                         <a:buNone/>
                       </a:pPr>
                       <a:r>
@@ -1766,7 +1766,7 @@
                     <a:bodyPr/>
                     <a:lstStyle/>
                     <a:p>
-                      <a:pPr indent="0" marL="0">
+                      <a:pPr algn="just" indent="0" marL="0">
                         <a:buNone/>
                       </a:pPr>
                       <a:r>
@@ -1824,7 +1824,7 @@
                     <a:bodyPr/>
                     <a:lstStyle/>
                     <a:p>
-                      <a:pPr indent="0" marL="0">
+                      <a:pPr algn="just" indent="0" marL="0">
                         <a:buNone/>
                       </a:pPr>
                       <a:r>
@@ -1874,7 +1874,7 @@
                     <a:bodyPr/>
                     <a:lstStyle/>
                     <a:p>
-                      <a:pPr indent="0" marL="0">
+                      <a:pPr algn="just" indent="0" marL="0">
                         <a:buNone/>
                       </a:pPr>
                       <a:r>
@@ -1921,7 +1921,7 @@
                     <a:bodyPr/>
                     <a:lstStyle/>
                     <a:p>
-                      <a:pPr indent="0" marL="0">
+                      <a:pPr algn="l" indent="0" marL="0">
                         <a:buNone/>
                       </a:pPr>
                       <a:r>
@@ -1970,7 +1970,7 @@
                     <a:bodyPr/>
                     <a:lstStyle/>
                     <a:p>
-                      <a:pPr indent="0" marL="0">
+                      <a:pPr algn="just" indent="0" marL="0">
                         <a:buNone/>
                       </a:pPr>
                       <a:r>
@@ -2020,7 +2020,7 @@
                     <a:bodyPr/>
                     <a:lstStyle/>
                     <a:p>
-                      <a:pPr indent="0" marL="0">
+                      <a:pPr algn="just" indent="0" marL="0">
                         <a:buNone/>
                       </a:pPr>
                       <a:r>
@@ -2067,7 +2067,7 @@
                     <a:bodyPr/>
                     <a:lstStyle/>
                     <a:p>
-                      <a:pPr indent="0" marL="0">
+                      <a:pPr algn="l" indent="0" marL="0">
                         <a:buNone/>
                       </a:pPr>
                       <a:r>
@@ -2116,7 +2116,7 @@
                     <a:bodyPr/>
                     <a:lstStyle/>
                     <a:p>
-                      <a:pPr indent="0" marL="0">
+                      <a:pPr algn="just" indent="0" marL="0">
                         <a:buNone/>
                       </a:pPr>
                       <a:r>
@@ -2166,7 +2166,7 @@
                     <a:bodyPr/>
                     <a:lstStyle/>
                     <a:p>
-                      <a:pPr indent="0" marL="0">
+                      <a:pPr algn="just" indent="0" marL="0">
                         <a:buNone/>
                       </a:pPr>
                       <a:r>
@@ -2213,7 +2213,7 @@
                     <a:bodyPr/>
                     <a:lstStyle/>
                     <a:p>
-                      <a:pPr indent="0" marL="0">
+                      <a:pPr algn="l" indent="0" marL="0">
                         <a:buNone/>
                       </a:pPr>
                       <a:r>
@@ -2262,7 +2262,7 @@
                     <a:bodyPr/>
                     <a:lstStyle/>
                     <a:p>
-                      <a:pPr indent="0" marL="0">
+                      <a:pPr algn="just" indent="0" marL="0">
                         <a:buNone/>
                       </a:pPr>
                       <a:r>
@@ -2312,7 +2312,7 @@
                     <a:bodyPr/>
                     <a:lstStyle/>
                     <a:p>
-                      <a:pPr indent="0" marL="0">
+                      <a:pPr algn="just" indent="0" marL="0">
                         <a:buNone/>
                       </a:pPr>
                       <a:r>
@@ -2359,7 +2359,7 @@
                     <a:bodyPr/>
                     <a:lstStyle/>
                     <a:p>
-                      <a:pPr indent="0" marL="0">
+                      <a:pPr algn="l" indent="0" marL="0">
                         <a:buNone/>
                       </a:pPr>
                       <a:r>
@@ -2408,7 +2408,7 @@
                     <a:bodyPr/>
                     <a:lstStyle/>
                     <a:p>
-                      <a:pPr indent="0" marL="0">
+                      <a:pPr algn="just" indent="0" marL="0">
                         <a:buNone/>
                       </a:pPr>
                       <a:r>
@@ -2458,7 +2458,7 @@
                     <a:bodyPr/>
                     <a:lstStyle/>
                     <a:p>
-                      <a:pPr indent="0" marL="0">
+                      <a:pPr algn="just" indent="0" marL="0">
                         <a:buNone/>
                       </a:pPr>
                       <a:r>
@@ -2505,7 +2505,7 @@
                     <a:bodyPr/>
                     <a:lstStyle/>
                     <a:p>
-                      <a:pPr indent="0" marL="0">
+                      <a:pPr algn="l" indent="0" marL="0">
                         <a:buNone/>
                       </a:pPr>
                       <a:r>
@@ -2554,7 +2554,7 @@
                     <a:bodyPr/>
                     <a:lstStyle/>
                     <a:p>
-                      <a:pPr indent="0" marL="0">
+                      <a:pPr algn="just" indent="0" marL="0">
                         <a:buNone/>
                       </a:pPr>
                       <a:r>
@@ -2604,7 +2604,7 @@
                     <a:bodyPr/>
                     <a:lstStyle/>
                     <a:p>
-                      <a:pPr indent="0" marL="0">
+                      <a:pPr algn="just" indent="0" marL="0">
                         <a:buNone/>
                       </a:pPr>
                       <a:r>
@@ -2616,7 +2616,7 @@
                           <a:ea typeface="Calibri" pitchFamily="34" charset="-122"/>
                           <a:cs typeface="Calibri" pitchFamily="34" charset="-120"/>
                         </a:rPr>
-                        <a:t>Comentario CA: 14/10/2026 Compromiso</a:t>
+                        <a:t>Se anexa informe elaborado en fecha 13 de diciembre de 2024, sobre proyecto de implementación de un nuevo sistema de monitoreo de LDA/FT/FPADM y del sistema de fraude de canales digitales.</a:t>
                       </a:r>
                       <a:endParaRPr lang="en-US" sz="750" dirty="0">
                         <a:latin typeface="Calibri" charset="0"/>
@@ -2624,55 +2624,34 @@
                         <a:cs typeface="Calibri" charset="0"/>
                       </a:endParaRPr>
                     </a:p>
-                    <a:p>
-                      <a:pPr indent="0" marL="0">
-                        <a:buNone/>
-                      </a:pPr>
-                      <a:r>
-                        <a:rPr lang="en-US" sz="750" dirty="0">
-                          <a:solidFill>
-                            <a:schemeClr val="tx1"/>
-                          </a:solidFill>
-                          <a:latin typeface="Calibri" pitchFamily="34" charset="0"/>
-                          <a:ea typeface="Calibri" pitchFamily="34" charset="-122"/>
-                          <a:cs typeface="Calibri" pitchFamily="34" charset="-120"/>
-                        </a:rPr>
-                        <a:t>Adjuntar evidencia de fecha de matriz de riesgos.</a:t>
-                      </a:r>
-                      <a:endParaRPr lang="en-US" sz="750" dirty="0">
-                        <a:latin typeface="Calibri" charset="0"/>
-                        <a:ea typeface="Calibri" charset="0"/>
-                        <a:cs typeface="Calibri" charset="0"/>
-                      </a:endParaRPr>
-                    </a:p>
-                  </a:txBody>
-                  <a:tcPr marL="54864" marR="54864" marT="18288" marB="18288" anchor="ctr">
-                    <a:lnL w="0" cap="flat" cmpd="sng" algn="ctr">
-                      <a:noFill/>
-                    </a:lnL>
-                    <a:lnR w="0" cap="flat" cmpd="sng" algn="ctr">
-                      <a:noFill/>
-                    </a:lnR>
-                    <a:lnT w="0" cap="flat" cmpd="sng" algn="ctr">
-                      <a:noFill/>
-                    </a:lnT>
-                    <a:lnB w="9525" cap="flat" cmpd="sng" algn="ctr">
-                      <a:solidFill>
-                        <a:srgbClr val="D9E0EA"/>
-                      </a:solidFill>
-                      <a:prstDash val="solid"/>
-                      <a:round/>
-                      <a:headEnd type="none" w="med" len="med"/>
-                      <a:tailEnd type="none" w="med" len="med"/>
-                    </a:lnB>
-                  </a:tcPr>
-                </a:tc>
-                <a:tc>
-                  <a:txBody>
-                    <a:bodyPr/>
-                    <a:lstStyle/>
-                    <a:p>
-                      <a:pPr indent="0" marL="0">
+                  </a:txBody>
+                  <a:tcPr marL="54864" marR="54864" marT="18288" marB="18288" anchor="ctr">
+                    <a:lnL w="0" cap="flat" cmpd="sng" algn="ctr">
+                      <a:noFill/>
+                    </a:lnL>
+                    <a:lnR w="0" cap="flat" cmpd="sng" algn="ctr">
+                      <a:noFill/>
+                    </a:lnR>
+                    <a:lnT w="0" cap="flat" cmpd="sng" algn="ctr">
+                      <a:noFill/>
+                    </a:lnT>
+                    <a:lnB w="9525" cap="flat" cmpd="sng" algn="ctr">
+                      <a:solidFill>
+                        <a:srgbClr val="D9E0EA"/>
+                      </a:solidFill>
+                      <a:prstDash val="solid"/>
+                      <a:round/>
+                      <a:headEnd type="none" w="med" len="med"/>
+                      <a:tailEnd type="none" w="med" len="med"/>
+                    </a:lnB>
+                  </a:tcPr>
+                </a:tc>
+                <a:tc>
+                  <a:txBody>
+                    <a:bodyPr/>
+                    <a:lstStyle/>
+                    <a:p>
+                      <a:pPr algn="l" indent="0" marL="0">
                         <a:buNone/>
                       </a:pPr>
                       <a:r>
@@ -2721,7 +2700,7 @@
                     <a:bodyPr/>
                     <a:lstStyle/>
                     <a:p>
-                      <a:pPr indent="0" marL="0">
+                      <a:pPr algn="just" indent="0" marL="0">
                         <a:buNone/>
                       </a:pPr>
                       <a:r>
@@ -2771,7 +2750,7 @@
                     <a:bodyPr/>
                     <a:lstStyle/>
                     <a:p>
-                      <a:pPr indent="0" marL="0">
+                      <a:pPr algn="just" indent="0" marL="0">
                         <a:buNone/>
                       </a:pPr>
                       <a:r>
@@ -2792,7 +2771,7 @@
                       </a:endParaRPr>
                     </a:p>
                     <a:p>
-                      <a:pPr indent="0" marL="0">
+                      <a:pPr algn="just" indent="0" marL="0">
                         <a:buNone/>
                       </a:pPr>
                       <a:r>
@@ -2839,7 +2818,7 @@
                     <a:bodyPr/>
                     <a:lstStyle/>
                     <a:p>
-                      <a:pPr indent="0" marL="0">
+                      <a:pPr algn="l" indent="0" marL="0">
                         <a:buNone/>
                       </a:pPr>
                       <a:r>
@@ -2860,7 +2839,7 @@
                       </a:endParaRPr>
                     </a:p>
                     <a:p>
-                      <a:pPr indent="0" marL="0">
+                      <a:pPr algn="l" indent="0" marL="0">
                         <a:buNone/>
                       </a:pPr>
                       <a:r>
@@ -2909,7 +2888,7 @@
                     <a:bodyPr/>
                     <a:lstStyle/>
                     <a:p>
-                      <a:pPr indent="0" marL="0">
+                      <a:pPr algn="just" indent="0" marL="0">
                         <a:buNone/>
                       </a:pPr>
                       <a:r>
@@ -2959,7 +2938,7 @@
                     <a:bodyPr/>
                     <a:lstStyle/>
                     <a:p>
-                      <a:pPr indent="0" marL="0">
+                      <a:pPr algn="just" indent="0" marL="0">
                         <a:buNone/>
                       </a:pPr>
                       <a:r>
@@ -2980,7 +2959,7 @@
                       </a:endParaRPr>
                     </a:p>
                     <a:p>
-                      <a:pPr indent="0" marL="0">
+                      <a:pPr algn="just" indent="0" marL="0">
                         <a:buNone/>
                       </a:pPr>
                       <a:r>
@@ -3000,34 +2979,55 @@
                         <a:cs typeface="Calibri" charset="0"/>
                       </a:endParaRPr>
                     </a:p>
-                  </a:txBody>
-                  <a:tcPr marL="54864" marR="54864" marT="18288" marB="18288" anchor="ctr">
-                    <a:lnL w="0" cap="flat" cmpd="sng" algn="ctr">
-                      <a:noFill/>
-                    </a:lnL>
-                    <a:lnR w="0" cap="flat" cmpd="sng" algn="ctr">
-                      <a:noFill/>
-                    </a:lnR>
-                    <a:lnT w="0" cap="flat" cmpd="sng" algn="ctr">
-                      <a:noFill/>
-                    </a:lnT>
-                    <a:lnB w="9525" cap="flat" cmpd="sng" algn="ctr">
-                      <a:solidFill>
-                        <a:srgbClr val="D9E0EA"/>
-                      </a:solidFill>
-                      <a:prstDash val="solid"/>
-                      <a:round/>
-                      <a:headEnd type="none" w="med" len="med"/>
-                      <a:tailEnd type="none" w="med" len="med"/>
-                    </a:lnB>
-                  </a:tcPr>
-                </a:tc>
-                <a:tc>
-                  <a:txBody>
-                    <a:bodyPr/>
-                    <a:lstStyle/>
-                    <a:p>
-                      <a:pPr indent="0" marL="0">
+                    <a:p>
+                      <a:pPr algn="just" indent="0" marL="0">
+                        <a:buNone/>
+                      </a:pPr>
+                      <a:r>
+                        <a:rPr lang="en-US" sz="750" dirty="0">
+                          <a:solidFill>
+                            <a:schemeClr val="tx1"/>
+                          </a:solidFill>
+                          <a:latin typeface="Calibri" pitchFamily="34" charset="0"/>
+                          <a:ea typeface="Calibri" pitchFamily="34" charset="-122"/>
+                          <a:cs typeface="Calibri" pitchFamily="34" charset="-120"/>
+                        </a:rPr>
+                        <a:t>Se identificarán los servicios tecnológicos tercerizados críticos y se incorporarán en el alcance de las pruebas de continuidad del negocio. Asimismo, se solicitarán a los proveedores los resultados y evidencias de las pruebas realizadas, con el fin de validar la efectividad de los controles implementados.</a:t>
+                      </a:r>
+                      <a:endParaRPr lang="en-US" sz="750" dirty="0">
+                        <a:latin typeface="Calibri" charset="0"/>
+                        <a:ea typeface="Calibri" charset="0"/>
+                        <a:cs typeface="Calibri" charset="0"/>
+                      </a:endParaRPr>
+                    </a:p>
+                  </a:txBody>
+                  <a:tcPr marL="54864" marR="54864" marT="18288" marB="18288" anchor="ctr">
+                    <a:lnL w="0" cap="flat" cmpd="sng" algn="ctr">
+                      <a:noFill/>
+                    </a:lnL>
+                    <a:lnR w="0" cap="flat" cmpd="sng" algn="ctr">
+                      <a:noFill/>
+                    </a:lnR>
+                    <a:lnT w="0" cap="flat" cmpd="sng" algn="ctr">
+                      <a:noFill/>
+                    </a:lnT>
+                    <a:lnB w="9525" cap="flat" cmpd="sng" algn="ctr">
+                      <a:solidFill>
+                        <a:srgbClr val="D9E0EA"/>
+                      </a:solidFill>
+                      <a:prstDash val="solid"/>
+                      <a:round/>
+                      <a:headEnd type="none" w="med" len="med"/>
+                      <a:tailEnd type="none" w="med" len="med"/>
+                    </a:lnB>
+                  </a:tcPr>
+                </a:tc>
+                <a:tc>
+                  <a:txBody>
+                    <a:bodyPr/>
+                    <a:lstStyle/>
+                    <a:p>
+                      <a:pPr algn="l" indent="0" marL="0">
                         <a:buNone/>
                       </a:pPr>
                       <a:r>
@@ -3039,7 +3039,7 @@
                           <a:ea typeface="Calibri" pitchFamily="34" charset="-122"/>
                           <a:cs typeface="Calibri" pitchFamily="34" charset="-120"/>
                         </a:rPr>
-                        <a:t>Seguridad de la información</a:t>
+                        <a:t>Administración de Riesgos/Gerencia de sistemas/Seguridad de la información</a:t>
                       </a:r>
                       <a:endParaRPr lang="en-US" sz="750" dirty="0">
                         <a:latin typeface="Calibri" charset="0"/>
@@ -3076,7 +3076,7 @@
                     <a:bodyPr/>
                     <a:lstStyle/>
                     <a:p>
-                      <a:pPr indent="0" marL="0">
+                      <a:pPr algn="just" indent="0" marL="0">
                         <a:buNone/>
                       </a:pPr>
                       <a:r>
@@ -3126,7 +3126,7 @@
                     <a:bodyPr/>
                     <a:lstStyle/>
                     <a:p>
-                      <a:pPr indent="0" marL="0">
+                      <a:pPr algn="just" indent="0" marL="0">
                         <a:buNone/>
                       </a:pPr>
                       <a:r>
@@ -3147,7 +3147,7 @@
                       </a:endParaRPr>
                     </a:p>
                     <a:p>
-                      <a:pPr indent="0" marL="0">
+                      <a:pPr algn="just" indent="0" marL="0">
                         <a:buNone/>
                       </a:pPr>
                       <a:r>
@@ -3194,7 +3194,7 @@
                     <a:bodyPr/>
                     <a:lstStyle/>
                     <a:p>
-                      <a:pPr indent="0" marL="0">
+                      <a:pPr algn="l" indent="0" marL="0">
                         <a:buNone/>
                       </a:pPr>
                       <a:r>
@@ -3215,7 +3215,7 @@
                       </a:endParaRPr>
                     </a:p>
                     <a:p>
-                      <a:pPr indent="0" marL="0">
+                      <a:pPr algn="l" indent="0" marL="0">
                         <a:buNone/>
                       </a:pPr>
                       <a:r>
@@ -3264,7 +3264,7 @@
                     <a:bodyPr/>
                     <a:lstStyle/>
                     <a:p>
-                      <a:pPr indent="0" marL="0">
+                      <a:pPr algn="just" indent="0" marL="0">
                         <a:buNone/>
                       </a:pPr>
                       <a:r>
@@ -3314,7 +3314,7 @@
                     <a:bodyPr/>
                     <a:lstStyle/>
                     <a:p>
-                      <a:pPr indent="0" marL="0">
+                      <a:pPr algn="just" indent="0" marL="0">
                         <a:buNone/>
                       </a:pPr>
                       <a:r>
@@ -3335,7 +3335,7 @@
                       </a:endParaRPr>
                     </a:p>
                     <a:p>
-                      <a:pPr indent="0" marL="0">
+                      <a:pPr algn="just" indent="0" marL="0">
                         <a:buNone/>
                       </a:pPr>
                       <a:r>
@@ -3382,7 +3382,7 @@
                     <a:bodyPr/>
                     <a:lstStyle/>
                     <a:p>
-                      <a:pPr indent="0" marL="0">
+                      <a:pPr algn="l" indent="0" marL="0">
                         <a:buNone/>
                       </a:pPr>
                       <a:r>
@@ -3431,7 +3431,7 @@
                     <a:bodyPr/>
                     <a:lstStyle/>
                     <a:p>
-                      <a:pPr indent="0" marL="0">
+                      <a:pPr algn="just" indent="0" marL="0">
                         <a:buNone/>
                       </a:pPr>
                       <a:r>
@@ -3481,7 +3481,7 @@
                     <a:bodyPr/>
                     <a:lstStyle/>
                     <a:p>
-                      <a:pPr indent="0" marL="0">
+                      <a:pPr algn="just" indent="0" marL="0">
                         <a:buNone/>
                       </a:pPr>
                       <a:r>
@@ -3502,7 +3502,7 @@
                       </a:endParaRPr>
                     </a:p>
                     <a:p>
-                      <a:pPr indent="0" marL="0">
+                      <a:pPr algn="just" indent="0" marL="0">
                         <a:buNone/>
                       </a:pPr>
                       <a:r>
@@ -3549,7 +3549,7 @@
                     <a:bodyPr/>
                     <a:lstStyle/>
                     <a:p>
-                      <a:pPr indent="0" marL="0">
+                      <a:pPr algn="l" indent="0" marL="0">
                         <a:buNone/>
                       </a:pPr>
                       <a:r>
@@ -3598,7 +3598,7 @@
                     <a:bodyPr/>
                     <a:lstStyle/>
                     <a:p>
-                      <a:pPr indent="0" marL="0">
+                      <a:pPr algn="just" indent="0" marL="0">
                         <a:buNone/>
                       </a:pPr>
                       <a:r>
@@ -3648,7 +3648,7 @@
                     <a:bodyPr/>
                     <a:lstStyle/>
                     <a:p>
-                      <a:pPr indent="0" marL="0">
+                      <a:pPr algn="just" indent="0" marL="0">
                         <a:buNone/>
                       </a:pPr>
                       <a:r>
@@ -3669,7 +3669,7 @@
                       </a:endParaRPr>
                     </a:p>
                     <a:p>
-                      <a:pPr indent="0" marL="0">
+                      <a:pPr algn="just" indent="0" marL="0">
                         <a:buNone/>
                       </a:pPr>
                       <a:r>
@@ -3716,7 +3716,7 @@
                     <a:bodyPr/>
                     <a:lstStyle/>
                     <a:p>
-                      <a:pPr indent="0" marL="0">
+                      <a:pPr algn="l" indent="0" marL="0">
                         <a:buNone/>
                       </a:pPr>
                       <a:r>
@@ -3737,7 +3737,7 @@
                       </a:endParaRPr>
                     </a:p>
                     <a:p>
-                      <a:pPr indent="0" marL="0">
+                      <a:pPr algn="l" indent="0" marL="0">
                         <a:buNone/>
                       </a:pPr>
                       <a:r>
@@ -3786,7 +3786,7 @@
                     <a:bodyPr/>
                     <a:lstStyle/>
                     <a:p>
-                      <a:pPr indent="0" marL="0">
+                      <a:pPr algn="just" indent="0" marL="0">
                         <a:buNone/>
                       </a:pPr>
                       <a:r>
@@ -3836,7 +3836,7 @@
                     <a:bodyPr/>
                     <a:lstStyle/>
                     <a:p>
-                      <a:pPr indent="0" marL="0">
+                      <a:pPr algn="just" indent="0" marL="0">
                         <a:buNone/>
                       </a:pPr>
                       <a:r>
@@ -3883,7 +3883,7 @@
                     <a:bodyPr/>
                     <a:lstStyle/>
                     <a:p>
-                      <a:pPr indent="0" marL="0">
+                      <a:pPr algn="l" indent="0" marL="0">
                         <a:buNone/>
                       </a:pPr>
                       <a:r>
@@ -3904,7 +3904,7 @@
                       </a:endParaRPr>
                     </a:p>
                     <a:p>
-                      <a:pPr indent="0" marL="0">
+                      <a:pPr algn="l" indent="0" marL="0">
                         <a:buNone/>
                       </a:pPr>
                       <a:r>
@@ -3953,7 +3953,7 @@
                     <a:bodyPr/>
                     <a:lstStyle/>
                     <a:p>
-                      <a:pPr indent="0" marL="0">
+                      <a:pPr algn="just" indent="0" marL="0">
                         <a:buNone/>
                       </a:pPr>
                       <a:r>
@@ -4003,7 +4003,7 @@
                     <a:bodyPr/>
                     <a:lstStyle/>
                     <a:p>
-                      <a:pPr indent="0" marL="0">
+                      <a:pPr algn="just" indent="0" marL="0">
                         <a:buNone/>
                       </a:pPr>
                       <a:r>
@@ -4024,7 +4024,7 @@
                       </a:endParaRPr>
                     </a:p>
                     <a:p>
-                      <a:pPr indent="0" marL="0">
+                      <a:pPr algn="just" indent="0" marL="0">
                         <a:buNone/>
                       </a:pPr>
                       <a:r>
@@ -4071,7 +4071,7 @@
                     <a:bodyPr/>
                     <a:lstStyle/>
                     <a:p>
-                      <a:pPr indent="0" marL="0">
+                      <a:pPr algn="l" indent="0" marL="0">
                         <a:buNone/>
                       </a:pPr>
                       <a:r>
@@ -4092,7 +4092,7 @@
                       </a:endParaRPr>
                     </a:p>
                     <a:p>
-                      <a:pPr indent="0" marL="0">
+                      <a:pPr algn="l" indent="0" marL="0">
                         <a:buNone/>
                       </a:pPr>
                       <a:r>
@@ -4141,7 +4141,7 @@
                     <a:bodyPr/>
                     <a:lstStyle/>
                     <a:p>
-                      <a:pPr indent="0" marL="0">
+                      <a:pPr algn="just" indent="0" marL="0">
                         <a:buNone/>
                       </a:pPr>
                       <a:r>
@@ -4191,7 +4191,7 @@
                     <a:bodyPr/>
                     <a:lstStyle/>
                     <a:p>
-                      <a:pPr indent="0" marL="0">
+                      <a:pPr algn="just" indent="0" marL="0">
                         <a:buNone/>
                       </a:pPr>
                       <a:r>
@@ -4212,7 +4212,7 @@
                       </a:endParaRPr>
                     </a:p>
                     <a:p>
-                      <a:pPr indent="0" marL="0">
+                      <a:pPr algn="just" indent="0" marL="0">
                         <a:buNone/>
                       </a:pPr>
                       <a:r>
@@ -4233,7 +4233,7 @@
                       </a:endParaRPr>
                     </a:p>
                     <a:p>
-                      <a:pPr indent="0" marL="0">
+                      <a:pPr algn="just" indent="0" marL="0">
                         <a:buNone/>
                       </a:pPr>
                       <a:r>
@@ -4254,7 +4254,7 @@
                       </a:endParaRPr>
                     </a:p>
                     <a:p>
-                      <a:pPr indent="0" marL="0">
+                      <a:pPr algn="just" indent="0" marL="0">
                         <a:buNone/>
                       </a:pPr>
                       <a:r>
@@ -4301,7 +4301,7 @@
                     <a:bodyPr/>
                     <a:lstStyle/>
                     <a:p>
-                      <a:pPr indent="0" marL="0">
+                      <a:pPr algn="l" indent="0" marL="0">
                         <a:buNone/>
                       </a:pPr>
                       <a:r>
@@ -4322,7 +4322,7 @@
                       </a:endParaRPr>
                     </a:p>
                     <a:p>
-                      <a:pPr indent="0" marL="0">
+                      <a:pPr algn="l" indent="0" marL="0">
                         <a:buNone/>
                       </a:pPr>
                       <a:r>
@@ -4513,7 +4513,7 @@
                     <a:bodyPr/>
                     <a:lstStyle/>
                     <a:p>
-                      <a:pPr indent="0" marL="0">
+                      <a:pPr algn="just" indent="0" marL="0">
                         <a:buNone/>
                       </a:pPr>
                       <a:r>
@@ -4563,7 +4563,7 @@
                     <a:bodyPr/>
                     <a:lstStyle/>
                     <a:p>
-                      <a:pPr indent="0" marL="0">
+                      <a:pPr algn="just" indent="0" marL="0">
                         <a:buNone/>
                       </a:pPr>
                       <a:r>
@@ -4613,7 +4613,7 @@
                     <a:bodyPr/>
                     <a:lstStyle/>
                     <a:p>
-                      <a:pPr indent="0" marL="0">
+                      <a:pPr algn="just" indent="0" marL="0">
                         <a:buNone/>
                       </a:pPr>
                       <a:r>
@@ -4634,7 +4634,7 @@
                       </a:endParaRPr>
                     </a:p>
                     <a:p>
-                      <a:pPr indent="0" marL="0">
+                      <a:pPr algn="just" indent="0" marL="0">
                         <a:buNone/>
                       </a:pPr>
                       <a:r>
@@ -4686,7 +4686,7 @@
                     <a:bodyPr/>
                     <a:lstStyle/>
                     <a:p>
-                      <a:pPr indent="0" marL="0">
+                      <a:pPr algn="just" indent="0" marL="0">
                         <a:buNone/>
                       </a:pPr>
                       <a:r>
@@ -4707,7 +4707,7 @@
                       </a:endParaRPr>
                     </a:p>
                     <a:p>
-                      <a:pPr indent="0" marL="0">
+                      <a:pPr algn="just" indent="0" marL="0">
                         <a:buNone/>
                       </a:pPr>
                       <a:r>
@@ -4728,7 +4728,7 @@
                       </a:endParaRPr>
                     </a:p>
                     <a:p>
-                      <a:pPr indent="0" marL="0">
+                      <a:pPr algn="just" indent="0" marL="0">
                         <a:buNone/>
                       </a:pPr>
                       <a:r>
@@ -4786,7 +4786,7 @@
                     <a:bodyPr/>
                     <a:lstStyle/>
                     <a:p>
-                      <a:pPr indent="0" marL="0">
+                      <a:pPr algn="just" indent="0" marL="0">
                         <a:buNone/>
                       </a:pPr>
                       <a:r>
@@ -4807,7 +4807,7 @@
                       </a:endParaRPr>
                     </a:p>
                     <a:p>
-                      <a:pPr indent="0" marL="0">
+                      <a:pPr algn="just" indent="0" marL="0">
                         <a:buNone/>
                       </a:pPr>
                       <a:r>
@@ -4828,7 +4828,7 @@
                       </a:endParaRPr>
                     </a:p>
                     <a:p>
-                      <a:pPr indent="0" marL="0">
+                      <a:pPr algn="just" indent="0" marL="0">
                         <a:buNone/>
                       </a:pPr>
                       <a:r>
@@ -4849,7 +4849,7 @@
                       </a:endParaRPr>
                     </a:p>
                     <a:p>
-                      <a:pPr indent="0" marL="0">
+                      <a:pPr algn="just" indent="0" marL="0">
                         <a:buNone/>
                       </a:pPr>
                       <a:r>
@@ -4899,7 +4899,7 @@
                     <a:bodyPr/>
                     <a:lstStyle/>
                     <a:p>
-                      <a:pPr indent="0" marL="0">
+                      <a:pPr algn="just" indent="0" marL="0">
                         <a:buNone/>
                       </a:pPr>
                       <a:r>
@@ -4920,7 +4920,7 @@
                       </a:endParaRPr>
                     </a:p>
                     <a:p>
-                      <a:pPr indent="0" marL="0">
+                      <a:pPr algn="just" indent="0" marL="0">
                         <a:buNone/>
                       </a:pPr>
                       <a:r>
@@ -4941,7 +4941,7 @@
                       </a:endParaRPr>
                     </a:p>
                     <a:p>
-                      <a:pPr indent="0" marL="0">
+                      <a:pPr algn="just" indent="0" marL="0">
                         <a:buNone/>
                       </a:pPr>
                       <a:r>
@@ -4962,7 +4962,7 @@
                       </a:endParaRPr>
                     </a:p>
                     <a:p>
-                      <a:pPr indent="0" marL="0">
+                      <a:pPr algn="just" indent="0" marL="0">
                         <a:buNone/>
                       </a:pPr>
                       <a:r>
@@ -4983,7 +4983,7 @@
                       </a:endParaRPr>
                     </a:p>
                     <a:p>
-                      <a:pPr indent="0" marL="0">
+                      <a:pPr algn="just" indent="0" marL="0">
                         <a:buNone/>
                       </a:pPr>
                       <a:r>
@@ -5004,7 +5004,7 @@
                       </a:endParaRPr>
                     </a:p>
                     <a:p>
-                      <a:pPr indent="0" marL="0">
+                      <a:pPr algn="just" indent="0" marL="0">
                         <a:buNone/>
                       </a:pPr>
                       <a:r>
@@ -5025,7 +5025,7 @@
                       </a:endParaRPr>
                     </a:p>
                     <a:p>
-                      <a:pPr indent="0" marL="0">
+                      <a:pPr algn="just" indent="0" marL="0">
                         <a:buNone/>
                       </a:pPr>
                       <a:r>
@@ -5072,7 +5072,7 @@
                     <a:bodyPr/>
                     <a:lstStyle/>
                     <a:p>
-                      <a:pPr indent="0" marL="0">
+                      <a:pPr algn="l" indent="0" marL="0">
                         <a:buNone/>
                       </a:pPr>
                       <a:r>
@@ -5121,7 +5121,7 @@
                     <a:bodyPr/>
                     <a:lstStyle/>
                     <a:p>
-                      <a:pPr indent="0" marL="0">
+                      <a:pPr algn="just" indent="0" marL="0">
                         <a:buNone/>
                       </a:pPr>
                       <a:r>
@@ -5142,7 +5142,7 @@
                       </a:endParaRPr>
                     </a:p>
                     <a:p>
-                      <a:pPr indent="0" marL="0">
+                      <a:pPr algn="just" indent="0" marL="0">
                         <a:buNone/>
                       </a:pPr>
                       <a:r>
@@ -5163,7 +5163,7 @@
                       </a:endParaRPr>
                     </a:p>
                     <a:p>
-                      <a:pPr indent="0" marL="0">
+                      <a:pPr algn="just" indent="0" marL="0">
                         <a:buNone/>
                       </a:pPr>
                       <a:r>
@@ -5184,7 +5184,7 @@
                       </a:endParaRPr>
                     </a:p>
                     <a:p>
-                      <a:pPr indent="0" marL="0">
+                      <a:pPr algn="just" indent="0" marL="0">
                         <a:buNone/>
                       </a:pPr>
                       <a:r>
@@ -5234,7 +5234,7 @@
                     <a:bodyPr/>
                     <a:lstStyle/>
                     <a:p>
-                      <a:pPr indent="0" marL="0">
+                      <a:pPr algn="just" indent="0" marL="0">
                         <a:buNone/>
                       </a:pPr>
                       <a:r>
@@ -5255,7 +5255,7 @@
                       </a:endParaRPr>
                     </a:p>
                     <a:p>
-                      <a:pPr indent="0" marL="0">
+                      <a:pPr algn="just" indent="0" marL="0">
                         <a:buNone/>
                       </a:pPr>
                       <a:r>
@@ -5302,7 +5302,7 @@
                     <a:bodyPr/>
                     <a:lstStyle/>
                     <a:p>
-                      <a:pPr indent="0" marL="0">
+                      <a:pPr algn="l" indent="0" marL="0">
                         <a:buNone/>
                       </a:pPr>
                       <a:r>
@@ -5351,7 +5351,7 @@
                     <a:bodyPr/>
                     <a:lstStyle/>
                     <a:p>
-                      <a:pPr indent="0" marL="0">
+                      <a:pPr algn="just" indent="0" marL="0">
                         <a:buNone/>
                       </a:pPr>
                       <a:r>
@@ -5409,7 +5409,7 @@
                     <a:bodyPr/>
                     <a:lstStyle/>
                     <a:p>
-                      <a:pPr indent="0" marL="0">
+                      <a:pPr algn="just" indent="0" marL="0">
                         <a:buNone/>
                       </a:pPr>
                       <a:r>
@@ -5430,7 +5430,7 @@
                       </a:endParaRPr>
                     </a:p>
                     <a:p>
-                      <a:pPr indent="0" marL="0">
+                      <a:pPr algn="just" indent="0" marL="0">
                         <a:buNone/>
                       </a:pPr>
                       <a:r>
@@ -5480,7 +5480,7 @@
                     <a:bodyPr/>
                     <a:lstStyle/>
                     <a:p>
-                      <a:pPr indent="0" marL="0">
+                      <a:pPr algn="just" indent="0" marL="0">
                         <a:buNone/>
                       </a:pPr>
                       <a:r>
@@ -5501,7 +5501,7 @@
                       </a:endParaRPr>
                     </a:p>
                     <a:p>
-                      <a:pPr indent="0" marL="0">
+                      <a:pPr algn="just" indent="0" marL="0">
                         <a:buNone/>
                       </a:pPr>
                       <a:r>
@@ -5548,7 +5548,7 @@
                     <a:bodyPr/>
                     <a:lstStyle/>
                     <a:p>
-                      <a:pPr indent="0" marL="0">
+                      <a:pPr algn="l" indent="0" marL="0">
                         <a:buNone/>
                       </a:pPr>
                       <a:r>
@@ -5597,7 +5597,7 @@
                     <a:bodyPr/>
                     <a:lstStyle/>
                     <a:p>
-                      <a:pPr indent="0" marL="0">
+                      <a:pPr algn="just" indent="0" marL="0">
                         <a:buNone/>
                       </a:pPr>
                       <a:r>
@@ -5655,7 +5655,7 @@
                     <a:bodyPr/>
                     <a:lstStyle/>
                     <a:p>
-                      <a:pPr indent="0" marL="0">
+                      <a:pPr algn="just" indent="0" marL="0">
                         <a:buNone/>
                       </a:pPr>
                       <a:r>
@@ -5676,7 +5676,7 @@
                       </a:endParaRPr>
                     </a:p>
                     <a:p>
-                      <a:pPr indent="0" marL="0">
+                      <a:pPr algn="just" indent="0" marL="0">
                         <a:buNone/>
                       </a:pPr>
                       <a:r>
@@ -5697,7 +5697,7 @@
                       </a:endParaRPr>
                     </a:p>
                     <a:p>
-                      <a:pPr indent="0" marL="0">
+                      <a:pPr algn="just" indent="0" marL="0">
                         <a:buNone/>
                       </a:pPr>
                       <a:r>
@@ -5747,7 +5747,7 @@
                     <a:bodyPr/>
                     <a:lstStyle/>
                     <a:p>
-                      <a:pPr indent="0" marL="0">
+                      <a:pPr algn="just" indent="0" marL="0">
                         <a:buNone/>
                       </a:pPr>
                       <a:r>
@@ -5794,7 +5794,7 @@
                     <a:bodyPr/>
                     <a:lstStyle/>
                     <a:p>
-                      <a:pPr indent="0" marL="0">
+                      <a:pPr algn="l" indent="0" marL="0">
                         <a:buNone/>
                       </a:pPr>
                       <a:r>
@@ -5843,7 +5843,7 @@
                     <a:bodyPr/>
                     <a:lstStyle/>
                     <a:p>
-                      <a:pPr indent="0" marL="0">
+                      <a:pPr algn="just" indent="0" marL="0">
                         <a:buNone/>
                       </a:pPr>
                       <a:r>
@@ -5864,7 +5864,7 @@
                       </a:endParaRPr>
                     </a:p>
                     <a:p>
-                      <a:pPr indent="0" marL="0">
+                      <a:pPr algn="just" indent="0" marL="0">
                         <a:buNone/>
                       </a:pPr>
                       <a:r>
@@ -5885,7 +5885,7 @@
                       </a:endParaRPr>
                     </a:p>
                     <a:p>
-                      <a:pPr indent="0" marL="0">
+                      <a:pPr algn="just" indent="0" marL="0">
                         <a:buNone/>
                       </a:pPr>
                       <a:r>
@@ -5935,7 +5935,7 @@
                     <a:bodyPr/>
                     <a:lstStyle/>
                     <a:p>
-                      <a:pPr indent="0" marL="0">
+                      <a:pPr algn="just" indent="0" marL="0">
                         <a:buNone/>
                       </a:pPr>
                       <a:r>
@@ -5982,7 +5982,7 @@
                     <a:bodyPr/>
                     <a:lstStyle/>
                     <a:p>
-                      <a:pPr indent="0" marL="0">
+                      <a:pPr algn="l" indent="0" marL="0">
                         <a:buNone/>
                       </a:pPr>
                       <a:r>
@@ -6031,7 +6031,7 @@
                     <a:bodyPr/>
                     <a:lstStyle/>
                     <a:p>
-                      <a:pPr indent="0" marL="0">
+                      <a:pPr algn="just" indent="0" marL="0">
                         <a:buNone/>
                       </a:pPr>
                       <a:r>
@@ -6089,7 +6089,7 @@
                     <a:bodyPr/>
                     <a:lstStyle/>
                     <a:p>
-                      <a:pPr indent="0" marL="0">
+                      <a:pPr algn="just" indent="0" marL="0">
                         <a:buNone/>
                       </a:pPr>
                       <a:r>
@@ -6147,7 +6147,7 @@
                     <a:bodyPr/>
                     <a:lstStyle/>
                     <a:p>
-                      <a:pPr indent="0" marL="0">
+                      <a:pPr algn="just" indent="0" marL="0">
                         <a:buNone/>
                       </a:pPr>
                       <a:r>
@@ -6168,7 +6168,7 @@
                       </a:endParaRPr>
                     </a:p>
                     <a:p>
-                      <a:pPr indent="0" marL="0">
+                      <a:pPr algn="just" indent="0" marL="0">
                         <a:buNone/>
                       </a:pPr>
                       <a:r>
@@ -6189,7 +6189,7 @@
                       </a:endParaRPr>
                     </a:p>
                     <a:p>
-                      <a:pPr indent="0" marL="0">
+                      <a:pPr algn="just" indent="0" marL="0">
                         <a:buNone/>
                       </a:pPr>
                       <a:r>
@@ -6239,7 +6239,7 @@
                     <a:bodyPr/>
                     <a:lstStyle/>
                     <a:p>
-                      <a:pPr indent="0" marL="0">
+                      <a:pPr algn="just" indent="0" marL="0">
                         <a:buNone/>
                       </a:pPr>
                       <a:r>
@@ -6260,7 +6260,7 @@
                       </a:endParaRPr>
                     </a:p>
                     <a:p>
-                      <a:pPr indent="0" marL="0">
+                      <a:pPr algn="just" indent="0" marL="0">
                         <a:buNone/>
                       </a:pPr>
                       <a:r>
@@ -6307,7 +6307,7 @@
                     <a:bodyPr/>
                     <a:lstStyle/>
                     <a:p>
-                      <a:pPr indent="0" marL="0">
+                      <a:pPr algn="l" indent="0" marL="0">
                         <a:buNone/>
                       </a:pPr>
                       <a:r>
@@ -6356,7 +6356,7 @@
                     <a:bodyPr/>
                     <a:lstStyle/>
                     <a:p>
-                      <a:pPr indent="0" marL="0">
+                      <a:pPr algn="just" indent="0" marL="0">
                         <a:buNone/>
                       </a:pPr>
                       <a:r>
@@ -6377,7 +6377,7 @@
                       </a:endParaRPr>
                     </a:p>
                     <a:p>
-                      <a:pPr indent="0" marL="0">
+                      <a:pPr algn="just" indent="0" marL="0">
                         <a:buNone/>
                       </a:pPr>
                       <a:r>
@@ -6427,7 +6427,7 @@
                     <a:bodyPr/>
                     <a:lstStyle/>
                     <a:p>
-                      <a:pPr indent="0" marL="0">
+                      <a:pPr algn="just" indent="0" marL="0">
                         <a:buNone/>
                       </a:pPr>
                       <a:r>
@@ -6448,7 +6448,7 @@
                       </a:endParaRPr>
                     </a:p>
                     <a:p>
-                      <a:pPr indent="0" marL="0">
+                      <a:pPr algn="just" indent="0" marL="0">
                         <a:buNone/>
                       </a:pPr>
                       <a:r>
@@ -6495,7 +6495,7 @@
                     <a:bodyPr/>
                     <a:lstStyle/>
                     <a:p>
-                      <a:pPr indent="0" marL="0">
+                      <a:pPr algn="l" indent="0" marL="0">
                         <a:buNone/>
                       </a:pPr>
                       <a:r>
@@ -6544,7 +6544,7 @@
                     <a:bodyPr/>
                     <a:lstStyle/>
                     <a:p>
-                      <a:pPr indent="0" marL="0">
+                      <a:pPr algn="just" indent="0" marL="0">
                         <a:buNone/>
                       </a:pPr>
                       <a:r>
@@ -6602,7 +6602,7 @@
                     <a:bodyPr/>
                     <a:lstStyle/>
                     <a:p>
-                      <a:pPr indent="0" marL="0">
+                      <a:pPr algn="just" indent="0" marL="0">
                         <a:buNone/>
                       </a:pPr>
                       <a:r>
@@ -6623,7 +6623,7 @@
                       </a:endParaRPr>
                     </a:p>
                     <a:p>
-                      <a:pPr indent="0" marL="0">
+                      <a:pPr algn="just" indent="0" marL="0">
                         <a:buNone/>
                       </a:pPr>
                       <a:r>
@@ -6644,7 +6644,7 @@
                       </a:endParaRPr>
                     </a:p>
                     <a:p>
-                      <a:pPr indent="0" marL="0">
+                      <a:pPr algn="just" indent="0" marL="0">
                         <a:buNone/>
                       </a:pPr>
                       <a:r>
@@ -6694,7 +6694,7 @@
                     <a:bodyPr/>
                     <a:lstStyle/>
                     <a:p>
-                      <a:pPr indent="0" marL="0">
+                      <a:pPr algn="just" indent="0" marL="0">
                         <a:buNone/>
                       </a:pPr>
                       <a:r>
@@ -6715,7 +6715,7 @@
                       </a:endParaRPr>
                     </a:p>
                     <a:p>
-                      <a:pPr indent="0" marL="0">
+                      <a:pPr algn="just" indent="0" marL="0">
                         <a:buNone/>
                       </a:pPr>
                       <a:r>
@@ -6736,7 +6736,7 @@
                       </a:endParaRPr>
                     </a:p>
                     <a:p>
-                      <a:pPr indent="0" marL="0">
+                      <a:pPr algn="just" indent="0" marL="0">
                         <a:buNone/>
                       </a:pPr>
                       <a:r>
@@ -6757,7 +6757,7 @@
                       </a:endParaRPr>
                     </a:p>
                     <a:p>
-                      <a:pPr indent="0" marL="0">
+                      <a:pPr algn="just" indent="0" marL="0">
                         <a:buNone/>
                       </a:pPr>
                       <a:r>
@@ -6804,7 +6804,7 @@
                     <a:bodyPr/>
                     <a:lstStyle/>
                     <a:p>
-                      <a:pPr indent="0" marL="0">
+                      <a:pPr algn="l" indent="0" marL="0">
                         <a:buNone/>
                       </a:pPr>
                       <a:r>
@@ -6853,7 +6853,7 @@
                     <a:bodyPr/>
                     <a:lstStyle/>
                     <a:p>
-                      <a:pPr indent="0" marL="0">
+                      <a:pPr algn="just" indent="0" marL="0">
                         <a:buNone/>
                       </a:pPr>
                       <a:r>
@@ -6874,7 +6874,7 @@
                       </a:endParaRPr>
                     </a:p>
                     <a:p>
-                      <a:pPr indent="0" marL="0">
+                      <a:pPr algn="just" indent="0" marL="0">
                         <a:buNone/>
                       </a:pPr>
                       <a:r>
@@ -6924,7 +6924,7 @@
                     <a:bodyPr/>
                     <a:lstStyle/>
                     <a:p>
-                      <a:pPr indent="0" marL="0">
+                      <a:pPr algn="just" indent="0" marL="0">
                         <a:buNone/>
                       </a:pPr>
                       <a:r>
@@ -6971,7 +6971,7 @@
                     <a:bodyPr/>
                     <a:lstStyle/>
                     <a:p>
-                      <a:pPr indent="0" marL="0">
+                      <a:pPr algn="l" indent="0" marL="0">
                         <a:buNone/>
                       </a:pPr>
                       <a:r>

</xml_diff>

<commit_message>
Matrix 23486: title suffix, Pendiente instead of CA comment, separate numbered A and B tables
Co-Authored-By: Claude Opus 5.5 <noreply@anthropic.com>
Claude-Session: https://claude.ai/code/session_01F1WXR13Nv8neEtLhaK3ELa
</commit_message>
<xml_diff>
--- a/supervision-gobierno-corporativo/Matriz_Requerimientos_DS-SABAO-BCS-BC-23486.pptx
+++ b/supervision-gobierno-corporativo/Matriz_Requerimientos_DS-SABAO-BCS-BC-23486.pptx
@@ -503,7 +503,7 @@
           <a:p>
             <a:r>
               <a:rPr lang="en-US" dirty="0"/>
-              <a:t>Texto tal como aparece en la Matriz de requerimientos DS-SABAO-BCS-BC-23486 (versión corta). Secciones A y B.</a:t>
+              <a:t>Matriz de requerimientos DS-SABAO-BCS-BC-23486 (versión corta). Secciones A y B. 'Comentario CA: 14/10/2026 Compromiso' se muestra como 'Pendiente'.</a:t>
             </a:r>
             <a:endParaRPr lang="en-US" dirty="0"/>
           </a:p>
@@ -1102,15 +1102,51 @@
                 <a:ea typeface="Cambria" pitchFamily="34" charset="-122"/>
                 <a:cs typeface="Cambria" pitchFamily="34" charset="-120"/>
               </a:rPr>
-              <a:t>Matriz de requerimientos DS-SABAO-BCS-BC-23486</a:t>
+              <a:t>Matriz de requerimientos DS-SABAO-BCS-BC-23486 · Gestión de Riesgo Específico</a:t>
             </a:r>
             <a:endParaRPr lang="en-US" sz="2000" dirty="0"/>
           </a:p>
         </p:txBody>
       </p:sp>
+      <p:sp>
+        <p:nvSpPr>
+          <p:cNvPr id="3" name="Sección A"/>
+          <p:cNvSpPr txBox="1"/>
+          <p:nvPr/>
+        </p:nvSpPr>
+        <p:spPr>
+          <a:xfrm>
+            <a:off x="411480" y="694944"/>
+            <a:ext cx="11368735" cy="237744"/>
+          </a:xfrm>
+          <a:prstGeom prst="rect">
+            <a:avLst/>
+          </a:prstGeom>
+          <a:noFill/>
+          <a:ln/>
+        </p:spPr>
+        <p:txBody>
+          <a:bodyPr wrap="square" lIns="0" tIns="0" rIns="0" bIns="0" rtlCol="0" anchor="ctr"/>
+          <a:lstStyle/>
+          <a:p>
+            <a:pPr indent="0" marL="0">
+              <a:buNone/>
+            </a:pPr>
+            <a:r>
+              <a:rPr lang="en-US" sz="1100" b="1" dirty="0">
+                <a:solidFill>
+                  <a:schemeClr val="accent1"/>
+                </a:solidFill>
+              </a:rPr>
+              <a:t>A. Gestión de Riesgo de LDA/FT/FPADM</a:t>
+            </a:r>
+            <a:endParaRPr lang="en-US" sz="1100" dirty="0"/>
+          </a:p>
+        </p:txBody>
+      </p:sp>
       <p:graphicFrame>
         <p:nvGraphicFramePr>
-          <p:cNvPr id="2" name="Tabla matriz"/>
+          <p:cNvPr id="2" name="Tabla sección A"/>
           <p:cNvGraphicFramePr>
             <a:graphicFrameLocks noGrp="1"/>
           </p:cNvGraphicFramePr>
@@ -1123,7 +1159,7 @@
           </p:nvPr>
         </p:nvGraphicFramePr>
         <p:xfrm>
-          <a:off x="411480" y="731520"/>
+          <a:off x="411480" y="969264"/>
           <a:ext cx="11368735" cy="914400"/>
         </p:xfrm>
         <a:graphic>
@@ -1131,9 +1167,9 @@
             <a:tbl>
               <a:tblPr/>
               <a:tblGrid>
-                <a:gridCol w="3657600"/>
-                <a:gridCol w="5971032"/>
-                <a:gridCol w="1737360"/>
+                <a:gridCol w="3977640"/>
+                <a:gridCol w="5788152"/>
+                <a:gridCol w="1600200"/>
               </a:tblGrid>
               <a:tr h="0">
                 <a:tc>
@@ -1162,7 +1198,7 @@
                       </a:endParaRPr>
                     </a:p>
                   </a:txBody>
-                  <a:tcPr marL="54864" marR="54864" marT="18288" marB="18288" anchor="ctr">
+                  <a:tcPr marL="54864" marR="54864" marT="13716" marB="13716" anchor="ctr">
                     <a:lnL w="0" cap="flat" cmpd="sng" algn="ctr">
                       <a:noFill/>
                     </a:lnL>
@@ -1212,7 +1248,7 @@
                       </a:endParaRPr>
                     </a:p>
                   </a:txBody>
-                  <a:tcPr marL="54864" marR="54864" marT="18288" marB="18288" anchor="ctr">
+                  <a:tcPr marL="54864" marR="54864" marT="13716" marB="13716" anchor="ctr">
                     <a:lnL w="0" cap="flat" cmpd="sng" algn="ctr">
                       <a:noFill/>
                     </a:lnL>
@@ -1253,7 +1289,7 @@
                           <a:ea typeface="Calibri" pitchFamily="34" charset="-122"/>
                           <a:cs typeface="Calibri" pitchFamily="34" charset="-120"/>
                         </a:rPr>
-                        <a:t>Funcionario</a:t>
+                        <a:t>Funcionario Responsable</a:t>
                       </a:r>
                       <a:endParaRPr lang="en-US" sz="900" dirty="0">
                         <a:latin typeface="Calibri" charset="0"/>
@@ -1261,29 +1297,8 @@
                         <a:cs typeface="Calibri" charset="0"/>
                       </a:endParaRPr>
                     </a:p>
-                    <a:p>
-                      <a:pPr algn="just" indent="0" marL="0">
-                        <a:buNone/>
-                      </a:pPr>
-                      <a:r>
-                        <a:rPr lang="en-US" sz="900" b="1" dirty="0">
-                          <a:solidFill>
-                            <a:schemeClr val="bg1"/>
-                          </a:solidFill>
-                          <a:latin typeface="Calibri" pitchFamily="34" charset="0"/>
-                          <a:ea typeface="Calibri" pitchFamily="34" charset="-122"/>
-                          <a:cs typeface="Calibri" pitchFamily="34" charset="-120"/>
-                        </a:rPr>
-                        <a:t>Responsable</a:t>
-                      </a:r>
-                      <a:endParaRPr lang="en-US" sz="900" dirty="0">
-                        <a:latin typeface="Calibri" charset="0"/>
-                        <a:ea typeface="Calibri" charset="0"/>
-                        <a:cs typeface="Calibri" charset="0"/>
-                      </a:endParaRPr>
-                    </a:p>
-                  </a:txBody>
-                  <a:tcPr marL="54864" marR="54864" marT="18288" marB="18288" anchor="ctr">
+                  </a:txBody>
+                  <a:tcPr marL="54864" marR="54864" marT="13716" marB="13716" anchor="ctr">
                     <a:lnL w="0" cap="flat" cmpd="sng" algn="ctr">
                       <a:noFill/>
                     </a:lnL>
@@ -1309,91 +1324,33 @@
                 </a:tc>
               </a:tr>
               <a:tr h="0">
-                <a:tc gridSpan="3">
-                  <a:txBody>
-                    <a:bodyPr/>
-                    <a:lstStyle/>
-                    <a:p>
-                      <a:pPr algn="just" indent="0" marL="0">
-                        <a:buNone/>
-                      </a:pPr>
-                      <a:r>
-                        <a:rPr lang="en-US" sz="780" b="1" dirty="0">
-                          <a:solidFill>
-                            <a:schemeClr val="accent1"/>
-                          </a:solidFill>
-                          <a:latin typeface="Calibri" pitchFamily="34" charset="0"/>
-                          <a:ea typeface="Calibri" pitchFamily="34" charset="-122"/>
-                          <a:cs typeface="Calibri" pitchFamily="34" charset="-120"/>
-                        </a:rPr>
-                        <a:t>A. Gestión de Riesgo de LDA/FT/FPADM</a:t>
-                      </a:r>
-                      <a:endParaRPr lang="en-US" sz="780" dirty="0">
-                        <a:latin typeface="Calibri" charset="0"/>
-                        <a:ea typeface="Calibri" charset="0"/>
-                        <a:cs typeface="Calibri" charset="0"/>
-                      </a:endParaRPr>
-                    </a:p>
-                  </a:txBody>
-                  <a:tcPr marL="54864" marR="54864" marT="18288" marB="18288" anchor="ctr">
-                    <a:lnL w="0" cap="flat" cmpd="sng" algn="ctr">
-                      <a:noFill/>
-                    </a:lnL>
-                    <a:lnR w="0" cap="flat" cmpd="sng" algn="ctr">
-                      <a:noFill/>
-                    </a:lnR>
-                    <a:lnT w="0" cap="flat" cmpd="sng" algn="ctr">
-                      <a:noFill/>
-                    </a:lnT>
-                    <a:lnB w="9525" cap="flat" cmpd="sng" algn="ctr">
-                      <a:solidFill>
-                        <a:srgbClr val="D9E0EA"/>
-                      </a:solidFill>
-                      <a:prstDash val="solid"/>
-                      <a:round/>
-                      <a:headEnd type="none" w="med" len="med"/>
-                      <a:tailEnd type="none" w="med" len="med"/>
-                    </a:lnB>
-                    <a:solidFill>
-                      <a:schemeClr val="bg2"/>
-                    </a:solidFill>
-                  </a:tcPr>
-                </a:tc>
-                <a:tc hMerge="1">
-                  <a:tcPr/>
-                </a:tc>
-                <a:tc hMerge="1">
-                  <a:tcPr/>
-                </a:tc>
-              </a:tr>
-              <a:tr h="0">
-                <a:tc>
-                  <a:txBody>
-                    <a:bodyPr/>
-                    <a:lstStyle/>
-                    <a:p>
-                      <a:pPr algn="just" indent="0" marL="0">
-                        <a:buNone/>
-                      </a:pPr>
-                      <a:r>
-                        <a:rPr lang="en-US" sz="780" b="1" dirty="0">
-                          <a:solidFill>
-                            <a:schemeClr val="tx1"/>
-                          </a:solidFill>
-                          <a:latin typeface="Calibri" pitchFamily="34" charset="0"/>
-                          <a:ea typeface="Calibri" pitchFamily="34" charset="-122"/>
-                          <a:cs typeface="Calibri" pitchFamily="34" charset="-120"/>
-                        </a:rPr>
-                        <a:t>Deficiencias en la conformación y actualización de expedientes de clientes.</a:t>
-                      </a:r>
-                      <a:endParaRPr lang="en-US" sz="780" dirty="0">
-                        <a:latin typeface="Calibri" charset="0"/>
-                        <a:ea typeface="Calibri" charset="0"/>
-                        <a:cs typeface="Calibri" charset="0"/>
-                      </a:endParaRPr>
-                    </a:p>
-                  </a:txBody>
-                  <a:tcPr marL="54864" marR="54864" marT="18288" marB="18288" anchor="ctr">
+                <a:tc>
+                  <a:txBody>
+                    <a:bodyPr/>
+                    <a:lstStyle/>
+                    <a:p>
+                      <a:pPr algn="just" indent="0" marL="0">
+                        <a:buNone/>
+                      </a:pPr>
+                      <a:r>
+                        <a:rPr lang="en-US" sz="760" b="1" dirty="0">
+                          <a:solidFill>
+                            <a:schemeClr val="tx1"/>
+                          </a:solidFill>
+                          <a:latin typeface="Calibri" pitchFamily="34" charset="0"/>
+                          <a:ea typeface="Calibri" pitchFamily="34" charset="-122"/>
+                          <a:cs typeface="Calibri" pitchFamily="34" charset="-120"/>
+                        </a:rPr>
+                        <a:t>A.1  Deficiencias en la conformación y actualización de expedientes de clientes.</a:t>
+                      </a:r>
+                      <a:endParaRPr lang="en-US" sz="760" dirty="0">
+                        <a:latin typeface="Calibri" charset="0"/>
+                        <a:ea typeface="Calibri" charset="0"/>
+                        <a:cs typeface="Calibri" charset="0"/>
+                      </a:endParaRPr>
+                    </a:p>
+                  </a:txBody>
+                  <a:tcPr marL="54864" marR="54864" marT="13716" marB="13716" anchor="ctr">
                     <a:lnL w="0" cap="flat" cmpd="sng" algn="ctr">
                       <a:noFill/>
                     </a:lnL>
@@ -1426,24 +1383,24 @@
                         <a:buNone/>
                       </a:pPr>
                       <a:r>
-                        <a:rPr lang="en-US" sz="780" dirty="0">
-                          <a:solidFill>
-                            <a:schemeClr val="tx1"/>
-                          </a:solidFill>
-                          <a:latin typeface="Calibri" pitchFamily="34" charset="0"/>
-                          <a:ea typeface="Calibri" pitchFamily="34" charset="-122"/>
-                          <a:cs typeface="Calibri" pitchFamily="34" charset="-120"/>
-                        </a:rPr>
-                        <a:t>Comentario CA: 14/10/2026 Compromiso</a:t>
-                      </a:r>
-                      <a:endParaRPr lang="en-US" sz="780" dirty="0">
-                        <a:latin typeface="Calibri" charset="0"/>
-                        <a:ea typeface="Calibri" charset="0"/>
-                        <a:cs typeface="Calibri" charset="0"/>
-                      </a:endParaRPr>
-                    </a:p>
-                  </a:txBody>
-                  <a:tcPr marL="54864" marR="54864" marT="18288" marB="18288" anchor="ctr">
+                        <a:rPr lang="en-US" sz="760" dirty="0">
+                          <a:solidFill>
+                            <a:schemeClr val="tx1"/>
+                          </a:solidFill>
+                          <a:latin typeface="Calibri" pitchFamily="34" charset="0"/>
+                          <a:ea typeface="Calibri" pitchFamily="34" charset="-122"/>
+                          <a:cs typeface="Calibri" pitchFamily="34" charset="-120"/>
+                        </a:rPr>
+                        <a:t>Pendiente</a:t>
+                      </a:r>
+                      <a:endParaRPr lang="en-US" sz="760" dirty="0">
+                        <a:latin typeface="Calibri" charset="0"/>
+                        <a:ea typeface="Calibri" charset="0"/>
+                        <a:cs typeface="Calibri" charset="0"/>
+                      </a:endParaRPr>
+                    </a:p>
+                  </a:txBody>
+                  <a:tcPr marL="54864" marR="54864" marT="13716" marB="13716" anchor="ctr">
                     <a:lnL w="0" cap="flat" cmpd="sng" algn="ctr">
                       <a:noFill/>
                     </a:lnL>
@@ -1473,7 +1430,7 @@
                         <a:buNone/>
                       </a:pPr>
                       <a:r>
-                        <a:rPr lang="en-US" sz="780" b="1" dirty="0">
+                        <a:rPr lang="en-US" sz="760" b="1" dirty="0">
                           <a:solidFill>
                             <a:schemeClr val="accent1"/>
                           </a:solidFill>
@@ -1483,14 +1440,14 @@
                         </a:rPr>
                         <a:t>Gerencia de Cumplimiento</a:t>
                       </a:r>
-                      <a:endParaRPr lang="en-US" sz="780" dirty="0">
-                        <a:latin typeface="Calibri" charset="0"/>
-                        <a:ea typeface="Calibri" charset="0"/>
-                        <a:cs typeface="Calibri" charset="0"/>
-                      </a:endParaRPr>
-                    </a:p>
-                  </a:txBody>
-                  <a:tcPr marL="54864" marR="54864" marT="18288" marB="18288" anchor="ctr">
+                      <a:endParaRPr lang="en-US" sz="760" dirty="0">
+                        <a:latin typeface="Calibri" charset="0"/>
+                        <a:ea typeface="Calibri" charset="0"/>
+                        <a:cs typeface="Calibri" charset="0"/>
+                      </a:endParaRPr>
+                    </a:p>
+                  </a:txBody>
+                  <a:tcPr marL="54864" marR="54864" marT="13716" marB="13716" anchor="ctr">
                     <a:lnL w="0" cap="flat" cmpd="sng" algn="ctr">
                       <a:noFill/>
                     </a:lnL>
@@ -1522,24 +1479,24 @@
                         <a:buNone/>
                       </a:pPr>
                       <a:r>
-                        <a:rPr lang="en-US" sz="780" b="1" dirty="0">
-                          <a:solidFill>
-                            <a:schemeClr val="tx1"/>
-                          </a:solidFill>
-                          <a:latin typeface="Calibri" pitchFamily="34" charset="0"/>
-                          <a:ea typeface="Calibri" pitchFamily="34" charset="-122"/>
-                          <a:cs typeface="Calibri" pitchFamily="34" charset="-120"/>
-                        </a:rPr>
-                        <a:t>Deficiencias en la identificación de la actividad económica realizada por clientes.</a:t>
-                      </a:r>
-                      <a:endParaRPr lang="en-US" sz="780" dirty="0">
-                        <a:latin typeface="Calibri" charset="0"/>
-                        <a:ea typeface="Calibri" charset="0"/>
-                        <a:cs typeface="Calibri" charset="0"/>
-                      </a:endParaRPr>
-                    </a:p>
-                  </a:txBody>
-                  <a:tcPr marL="54864" marR="54864" marT="18288" marB="18288" anchor="ctr">
+                        <a:rPr lang="en-US" sz="760" b="1" dirty="0">
+                          <a:solidFill>
+                            <a:schemeClr val="tx1"/>
+                          </a:solidFill>
+                          <a:latin typeface="Calibri" pitchFamily="34" charset="0"/>
+                          <a:ea typeface="Calibri" pitchFamily="34" charset="-122"/>
+                          <a:cs typeface="Calibri" pitchFamily="34" charset="-120"/>
+                        </a:rPr>
+                        <a:t>A.2  Deficiencias en la identificación de la actividad económica realizada por clientes.</a:t>
+                      </a:r>
+                      <a:endParaRPr lang="en-US" sz="760" dirty="0">
+                        <a:latin typeface="Calibri" charset="0"/>
+                        <a:ea typeface="Calibri" charset="0"/>
+                        <a:cs typeface="Calibri" charset="0"/>
+                      </a:endParaRPr>
+                    </a:p>
+                  </a:txBody>
+                  <a:tcPr marL="54864" marR="54864" marT="13716" marB="13716" anchor="ctr">
                     <a:lnL w="0" cap="flat" cmpd="sng" algn="ctr">
                       <a:noFill/>
                     </a:lnL>
@@ -1572,24 +1529,24 @@
                         <a:buNone/>
                       </a:pPr>
                       <a:r>
-                        <a:rPr lang="en-US" sz="780" dirty="0">
-                          <a:solidFill>
-                            <a:schemeClr val="tx1"/>
-                          </a:solidFill>
-                          <a:latin typeface="Calibri" pitchFamily="34" charset="0"/>
-                          <a:ea typeface="Calibri" pitchFamily="34" charset="-122"/>
-                          <a:cs typeface="Calibri" pitchFamily="34" charset="-120"/>
-                        </a:rPr>
-                        <a:t>Comentario CA: 14/10/2026 Compromiso</a:t>
-                      </a:r>
-                      <a:endParaRPr lang="en-US" sz="780" dirty="0">
-                        <a:latin typeface="Calibri" charset="0"/>
-                        <a:ea typeface="Calibri" charset="0"/>
-                        <a:cs typeface="Calibri" charset="0"/>
-                      </a:endParaRPr>
-                    </a:p>
-                  </a:txBody>
-                  <a:tcPr marL="54864" marR="54864" marT="18288" marB="18288" anchor="ctr">
+                        <a:rPr lang="en-US" sz="760" dirty="0">
+                          <a:solidFill>
+                            <a:schemeClr val="tx1"/>
+                          </a:solidFill>
+                          <a:latin typeface="Calibri" pitchFamily="34" charset="0"/>
+                          <a:ea typeface="Calibri" pitchFamily="34" charset="-122"/>
+                          <a:cs typeface="Calibri" pitchFamily="34" charset="-120"/>
+                        </a:rPr>
+                        <a:t>Pendiente</a:t>
+                      </a:r>
+                      <a:endParaRPr lang="en-US" sz="760" dirty="0">
+                        <a:latin typeface="Calibri" charset="0"/>
+                        <a:ea typeface="Calibri" charset="0"/>
+                        <a:cs typeface="Calibri" charset="0"/>
+                      </a:endParaRPr>
+                    </a:p>
+                  </a:txBody>
+                  <a:tcPr marL="54864" marR="54864" marT="13716" marB="13716" anchor="ctr">
                     <a:lnL w="0" cap="flat" cmpd="sng" algn="ctr">
                       <a:noFill/>
                     </a:lnL>
@@ -1619,7 +1576,7 @@
                         <a:buNone/>
                       </a:pPr>
                       <a:r>
-                        <a:rPr lang="en-US" sz="780" b="1" dirty="0">
+                        <a:rPr lang="en-US" sz="760" b="1" dirty="0">
                           <a:solidFill>
                             <a:schemeClr val="accent1"/>
                           </a:solidFill>
@@ -1629,121 +1586,282 @@
                         </a:rPr>
                         <a:t>Gerencia de Cumplimiento</a:t>
                       </a:r>
-                      <a:endParaRPr lang="en-US" sz="780" dirty="0">
-                        <a:latin typeface="Calibri" charset="0"/>
-                        <a:ea typeface="Calibri" charset="0"/>
-                        <a:cs typeface="Calibri" charset="0"/>
-                      </a:endParaRPr>
-                    </a:p>
-                  </a:txBody>
-                  <a:tcPr marL="54864" marR="54864" marT="18288" marB="18288" anchor="ctr">
-                    <a:lnL w="0" cap="flat" cmpd="sng" algn="ctr">
-                      <a:noFill/>
-                    </a:lnL>
-                    <a:lnR w="0" cap="flat" cmpd="sng" algn="ctr">
-                      <a:noFill/>
-                    </a:lnR>
-                    <a:lnT w="0" cap="flat" cmpd="sng" algn="ctr">
-                      <a:noFill/>
-                    </a:lnT>
-                    <a:lnB w="9525" cap="flat" cmpd="sng" algn="ctr">
-                      <a:solidFill>
-                        <a:srgbClr val="D9E0EA"/>
-                      </a:solidFill>
-                      <a:prstDash val="solid"/>
-                      <a:round/>
-                      <a:headEnd type="none" w="med" len="med"/>
-                      <a:tailEnd type="none" w="med" len="med"/>
-                    </a:lnB>
+                      <a:endParaRPr lang="en-US" sz="760" dirty="0">
+                        <a:latin typeface="Calibri" charset="0"/>
+                        <a:ea typeface="Calibri" charset="0"/>
+                        <a:cs typeface="Calibri" charset="0"/>
+                      </a:endParaRPr>
+                    </a:p>
+                  </a:txBody>
+                  <a:tcPr marL="54864" marR="54864" marT="13716" marB="13716" anchor="ctr">
+                    <a:lnL w="0" cap="flat" cmpd="sng" algn="ctr">
+                      <a:noFill/>
+                    </a:lnL>
+                    <a:lnR w="0" cap="flat" cmpd="sng" algn="ctr">
+                      <a:noFill/>
+                    </a:lnR>
+                    <a:lnT w="0" cap="flat" cmpd="sng" algn="ctr">
+                      <a:noFill/>
+                    </a:lnT>
+                    <a:lnB w="9525" cap="flat" cmpd="sng" algn="ctr">
+                      <a:solidFill>
+                        <a:srgbClr val="D9E0EA"/>
+                      </a:solidFill>
+                      <a:prstDash val="solid"/>
+                      <a:round/>
+                      <a:headEnd type="none" w="med" len="med"/>
+                      <a:tailEnd type="none" w="med" len="med"/>
+                    </a:lnB>
+                  </a:tcPr>
+                </a:tc>
+              </a:tr>
+            </a:tbl>
+          </a:graphicData>
+        </a:graphic>
+      </p:graphicFrame>
+      <p:sp>
+        <p:nvSpPr>
+          <p:cNvPr id="5" name="Sección B"/>
+          <p:cNvSpPr txBox="1"/>
+          <p:nvPr/>
+        </p:nvSpPr>
+        <p:spPr>
+          <a:xfrm>
+            <a:off x="411480" y="1627632"/>
+            <a:ext cx="11368735" cy="237744"/>
+          </a:xfrm>
+          <a:prstGeom prst="rect">
+            <a:avLst/>
+          </a:prstGeom>
+          <a:noFill/>
+          <a:ln/>
+        </p:spPr>
+        <p:txBody>
+          <a:bodyPr wrap="square" lIns="0" tIns="0" rIns="0" bIns="0" rtlCol="0" anchor="ctr"/>
+          <a:lstStyle/>
+          <a:p>
+            <a:pPr indent="0" marL="0">
+              <a:buNone/>
+            </a:pPr>
+            <a:r>
+              <a:rPr lang="en-US" sz="1100" b="1" dirty="0">
+                <a:solidFill>
+                  <a:schemeClr val="accent1"/>
+                </a:solidFill>
+              </a:rPr>
+              <a:t>B. Proceso de implementación de la Herramienta de Monitoreo</a:t>
+            </a:r>
+            <a:endParaRPr lang="en-US" sz="1100" dirty="0"/>
+          </a:p>
+        </p:txBody>
+      </p:sp>
+      <p:graphicFrame>
+        <p:nvGraphicFramePr>
+          <p:cNvPr id="3" name="Tabla sección B"/>
+          <p:cNvGraphicFramePr>
+            <a:graphicFrameLocks noGrp="1"/>
+          </p:cNvGraphicFramePr>
+          <p:nvPr>
+            <p:extLst>
+              <p:ext uri="{D42A27DB-BD31-4B8C-83A1-F6EECF244321}">
+                <p14:modId xmlns:p14="http://schemas.microsoft.com/office/powerpoint/2010/main" val="1579011935"/>
+              </p:ext>
+            </p:extLst>
+          </p:nvPr>
+        </p:nvGraphicFramePr>
+        <p:xfrm>
+          <a:off x="411480" y="1901952"/>
+          <a:ext cx="11368735" cy="914400"/>
+        </p:xfrm>
+        <a:graphic>
+          <a:graphicData uri="http://schemas.openxmlformats.org/drawingml/2006/table">
+            <a:tbl>
+              <a:tblPr/>
+              <a:tblGrid>
+                <a:gridCol w="3977640"/>
+                <a:gridCol w="5788152"/>
+                <a:gridCol w="1600200"/>
+              </a:tblGrid>
+              <a:tr h="0">
+                <a:tc>
+                  <a:txBody>
+                    <a:bodyPr/>
+                    <a:lstStyle/>
+                    <a:p>
+                      <a:pPr algn="just" indent="0" marL="0">
+                        <a:buNone/>
+                      </a:pPr>
+                      <a:r>
+                        <a:rPr lang="en-US" sz="900" b="1" dirty="0">
+                          <a:solidFill>
+                            <a:schemeClr val="bg1"/>
+                          </a:solidFill>
+                          <a:latin typeface="Calibri" pitchFamily="34" charset="0"/>
+                          <a:ea typeface="Calibri" pitchFamily="34" charset="-122"/>
+                          <a:cs typeface="Calibri" pitchFamily="34" charset="-120"/>
+                        </a:rPr>
+                        <a:t>Observación</a:t>
+                      </a:r>
+                      <a:endParaRPr lang="en-US" sz="900" dirty="0">
+                        <a:latin typeface="Calibri" charset="0"/>
+                        <a:ea typeface="Calibri" charset="0"/>
+                        <a:cs typeface="Calibri" charset="0"/>
+                      </a:endParaRPr>
+                    </a:p>
+                  </a:txBody>
+                  <a:tcPr marL="54864" marR="54864" marT="13716" marB="13716" anchor="ctr">
+                    <a:lnL w="0" cap="flat" cmpd="sng" algn="ctr">
+                      <a:noFill/>
+                    </a:lnL>
+                    <a:lnR w="0" cap="flat" cmpd="sng" algn="ctr">
+                      <a:noFill/>
+                    </a:lnR>
+                    <a:lnT w="0" cap="flat" cmpd="sng" algn="ctr">
+                      <a:noFill/>
+                    </a:lnT>
+                    <a:lnB w="9525" cap="flat" cmpd="sng" algn="ctr">
+                      <a:solidFill>
+                        <a:srgbClr val="D9E0EA"/>
+                      </a:solidFill>
+                      <a:prstDash val="solid"/>
+                      <a:round/>
+                      <a:headEnd type="none" w="med" len="med"/>
+                      <a:tailEnd type="none" w="med" len="med"/>
+                    </a:lnB>
+                    <a:solidFill>
+                      <a:schemeClr val="accent1"/>
+                    </a:solidFill>
+                  </a:tcPr>
+                </a:tc>
+                <a:tc>
+                  <a:txBody>
+                    <a:bodyPr/>
+                    <a:lstStyle/>
+                    <a:p>
+                      <a:pPr algn="just" indent="0" marL="0">
+                        <a:buNone/>
+                      </a:pPr>
+                      <a:r>
+                        <a:rPr lang="en-US" sz="900" b="1" dirty="0">
+                          <a:solidFill>
+                            <a:schemeClr val="bg1"/>
+                          </a:solidFill>
+                          <a:latin typeface="Calibri" pitchFamily="34" charset="0"/>
+                          <a:ea typeface="Calibri" pitchFamily="34" charset="-122"/>
+                          <a:cs typeface="Calibri" pitchFamily="34" charset="-120"/>
+                        </a:rPr>
+                        <a:t>Comentarios</a:t>
+                      </a:r>
+                      <a:endParaRPr lang="en-US" sz="900" dirty="0">
+                        <a:latin typeface="Calibri" charset="0"/>
+                        <a:ea typeface="Calibri" charset="0"/>
+                        <a:cs typeface="Calibri" charset="0"/>
+                      </a:endParaRPr>
+                    </a:p>
+                  </a:txBody>
+                  <a:tcPr marL="54864" marR="54864" marT="13716" marB="13716" anchor="ctr">
+                    <a:lnL w="0" cap="flat" cmpd="sng" algn="ctr">
+                      <a:noFill/>
+                    </a:lnL>
+                    <a:lnR w="0" cap="flat" cmpd="sng" algn="ctr">
+                      <a:noFill/>
+                    </a:lnR>
+                    <a:lnT w="0" cap="flat" cmpd="sng" algn="ctr">
+                      <a:noFill/>
+                    </a:lnT>
+                    <a:lnB w="9525" cap="flat" cmpd="sng" algn="ctr">
+                      <a:solidFill>
+                        <a:srgbClr val="D9E0EA"/>
+                      </a:solidFill>
+                      <a:prstDash val="solid"/>
+                      <a:round/>
+                      <a:headEnd type="none" w="med" len="med"/>
+                      <a:tailEnd type="none" w="med" len="med"/>
+                    </a:lnB>
+                    <a:solidFill>
+                      <a:schemeClr val="accent1"/>
+                    </a:solidFill>
+                  </a:tcPr>
+                </a:tc>
+                <a:tc>
+                  <a:txBody>
+                    <a:bodyPr/>
+                    <a:lstStyle/>
+                    <a:p>
+                      <a:pPr algn="just" indent="0" marL="0">
+                        <a:buNone/>
+                      </a:pPr>
+                      <a:r>
+                        <a:rPr lang="en-US" sz="900" b="1" dirty="0">
+                          <a:solidFill>
+                            <a:schemeClr val="bg1"/>
+                          </a:solidFill>
+                          <a:latin typeface="Calibri" pitchFamily="34" charset="0"/>
+                          <a:ea typeface="Calibri" pitchFamily="34" charset="-122"/>
+                          <a:cs typeface="Calibri" pitchFamily="34" charset="-120"/>
+                        </a:rPr>
+                        <a:t>Funcionario Responsable</a:t>
+                      </a:r>
+                      <a:endParaRPr lang="en-US" sz="900" dirty="0">
+                        <a:latin typeface="Calibri" charset="0"/>
+                        <a:ea typeface="Calibri" charset="0"/>
+                        <a:cs typeface="Calibri" charset="0"/>
+                      </a:endParaRPr>
+                    </a:p>
+                  </a:txBody>
+                  <a:tcPr marL="54864" marR="54864" marT="13716" marB="13716" anchor="ctr">
+                    <a:lnL w="0" cap="flat" cmpd="sng" algn="ctr">
+                      <a:noFill/>
+                    </a:lnL>
+                    <a:lnR w="0" cap="flat" cmpd="sng" algn="ctr">
+                      <a:noFill/>
+                    </a:lnR>
+                    <a:lnT w="0" cap="flat" cmpd="sng" algn="ctr">
+                      <a:noFill/>
+                    </a:lnT>
+                    <a:lnB w="9525" cap="flat" cmpd="sng" algn="ctr">
+                      <a:solidFill>
+                        <a:srgbClr val="D9E0EA"/>
+                      </a:solidFill>
+                      <a:prstDash val="solid"/>
+                      <a:round/>
+                      <a:headEnd type="none" w="med" len="med"/>
+                      <a:tailEnd type="none" w="med" len="med"/>
+                    </a:lnB>
+                    <a:solidFill>
+                      <a:schemeClr val="accent1"/>
+                    </a:solidFill>
                   </a:tcPr>
                 </a:tc>
               </a:tr>
               <a:tr h="0">
-                <a:tc gridSpan="3">
-                  <a:txBody>
-                    <a:bodyPr/>
-                    <a:lstStyle/>
-                    <a:p>
-                      <a:pPr algn="just" indent="0" marL="0">
-                        <a:buNone/>
-                      </a:pPr>
-                      <a:r>
-                        <a:rPr lang="en-US" sz="780" b="1" dirty="0">
-                          <a:solidFill>
-                            <a:schemeClr val="accent1"/>
-                          </a:solidFill>
-                          <a:latin typeface="Calibri" pitchFamily="34" charset="0"/>
-                          <a:ea typeface="Calibri" pitchFamily="34" charset="-122"/>
-                          <a:cs typeface="Calibri" pitchFamily="34" charset="-120"/>
-                        </a:rPr>
-                        <a:t>B. Proceso de implementación de la Herramienta de Monitoreo</a:t>
-                      </a:r>
-                      <a:endParaRPr lang="en-US" sz="780" dirty="0">
-                        <a:latin typeface="Calibri" charset="0"/>
-                        <a:ea typeface="Calibri" charset="0"/>
-                        <a:cs typeface="Calibri" charset="0"/>
-                      </a:endParaRPr>
-                    </a:p>
-                  </a:txBody>
-                  <a:tcPr marL="54864" marR="54864" marT="18288" marB="18288" anchor="ctr">
-                    <a:lnL w="0" cap="flat" cmpd="sng" algn="ctr">
-                      <a:noFill/>
-                    </a:lnL>
-                    <a:lnR w="0" cap="flat" cmpd="sng" algn="ctr">
-                      <a:noFill/>
-                    </a:lnR>
-                    <a:lnT w="0" cap="flat" cmpd="sng" algn="ctr">
-                      <a:noFill/>
-                    </a:lnT>
-                    <a:lnB w="9525" cap="flat" cmpd="sng" algn="ctr">
-                      <a:solidFill>
-                        <a:srgbClr val="D9E0EA"/>
-                      </a:solidFill>
-                      <a:prstDash val="solid"/>
-                      <a:round/>
-                      <a:headEnd type="none" w="med" len="med"/>
-                      <a:tailEnd type="none" w="med" len="med"/>
-                    </a:lnB>
-                    <a:solidFill>
-                      <a:schemeClr val="bg2"/>
-                    </a:solidFill>
-                  </a:tcPr>
-                </a:tc>
-                <a:tc hMerge="1">
-                  <a:tcPr/>
-                </a:tc>
-                <a:tc hMerge="1">
-                  <a:tcPr/>
-                </a:tc>
-              </a:tr>
-              <a:tr h="0">
-                <a:tc>
-                  <a:txBody>
-                    <a:bodyPr/>
-                    <a:lstStyle/>
-                    <a:p>
-                      <a:pPr algn="just" indent="0" marL="0">
-                        <a:buNone/>
-                      </a:pPr>
-                      <a:r>
-                        <a:rPr lang="en-US" sz="780" b="1" dirty="0">
-                          <a:solidFill>
-                            <a:schemeClr val="tx1"/>
-                          </a:solidFill>
-                          <a:latin typeface="Calibri" pitchFamily="34" charset="0"/>
-                          <a:ea typeface="Calibri" pitchFamily="34" charset="-122"/>
-                          <a:cs typeface="Calibri" pitchFamily="34" charset="-120"/>
-                        </a:rPr>
-                        <a:t>Falta de actualización de Metodología y matriz de riesgo LA/FT/FPADM de la Entidad</a:t>
-                      </a:r>
-                      <a:endParaRPr lang="en-US" sz="780" dirty="0">
-                        <a:latin typeface="Calibri" charset="0"/>
-                        <a:ea typeface="Calibri" charset="0"/>
-                        <a:cs typeface="Calibri" charset="0"/>
-                      </a:endParaRPr>
-                    </a:p>
-                  </a:txBody>
-                  <a:tcPr marL="54864" marR="54864" marT="18288" marB="18288" anchor="ctr">
+                <a:tc>
+                  <a:txBody>
+                    <a:bodyPr/>
+                    <a:lstStyle/>
+                    <a:p>
+                      <a:pPr algn="just" indent="0" marL="0">
+                        <a:buNone/>
+                      </a:pPr>
+                      <a:r>
+                        <a:rPr lang="en-US" sz="760" b="1" dirty="0">
+                          <a:solidFill>
+                            <a:schemeClr val="tx1"/>
+                          </a:solidFill>
+                          <a:latin typeface="Calibri" pitchFamily="34" charset="0"/>
+                          <a:ea typeface="Calibri" pitchFamily="34" charset="-122"/>
+                          <a:cs typeface="Calibri" pitchFamily="34" charset="-120"/>
+                        </a:rPr>
+                        <a:t>B.1  Falta de actualización de Metodología y matriz de riesgo LA/FT/FPADM de la Entidad</a:t>
+                      </a:r>
+                      <a:endParaRPr lang="en-US" sz="760" dirty="0">
+                        <a:latin typeface="Calibri" charset="0"/>
+                        <a:ea typeface="Calibri" charset="0"/>
+                        <a:cs typeface="Calibri" charset="0"/>
+                      </a:endParaRPr>
+                    </a:p>
+                  </a:txBody>
+                  <a:tcPr marL="54864" marR="54864" marT="13716" marB="13716" anchor="ctr">
                     <a:lnL w="0" cap="flat" cmpd="sng" algn="ctr">
                       <a:noFill/>
                     </a:lnL>
@@ -1776,24 +1894,24 @@
                         <a:buNone/>
                       </a:pPr>
                       <a:r>
-                        <a:rPr lang="en-US" sz="780" dirty="0">
-                          <a:solidFill>
-                            <a:schemeClr val="tx1"/>
-                          </a:solidFill>
-                          <a:latin typeface="Calibri" pitchFamily="34" charset="0"/>
-                          <a:ea typeface="Calibri" pitchFamily="34" charset="-122"/>
-                          <a:cs typeface="Calibri" pitchFamily="34" charset="-120"/>
-                        </a:rPr>
-                        <a:t>Comentario CA: 14/10/2026 Compromiso</a:t>
-                      </a:r>
-                      <a:endParaRPr lang="en-US" sz="780" dirty="0">
-                        <a:latin typeface="Calibri" charset="0"/>
-                        <a:ea typeface="Calibri" charset="0"/>
-                        <a:cs typeface="Calibri" charset="0"/>
-                      </a:endParaRPr>
-                    </a:p>
-                  </a:txBody>
-                  <a:tcPr marL="54864" marR="54864" marT="18288" marB="18288" anchor="ctr">
+                        <a:rPr lang="en-US" sz="760" dirty="0">
+                          <a:solidFill>
+                            <a:schemeClr val="tx1"/>
+                          </a:solidFill>
+                          <a:latin typeface="Calibri" pitchFamily="34" charset="0"/>
+                          <a:ea typeface="Calibri" pitchFamily="34" charset="-122"/>
+                          <a:cs typeface="Calibri" pitchFamily="34" charset="-120"/>
+                        </a:rPr>
+                        <a:t>Pendiente</a:t>
+                      </a:r>
+                      <a:endParaRPr lang="en-US" sz="760" dirty="0">
+                        <a:latin typeface="Calibri" charset="0"/>
+                        <a:ea typeface="Calibri" charset="0"/>
+                        <a:cs typeface="Calibri" charset="0"/>
+                      </a:endParaRPr>
+                    </a:p>
+                  </a:txBody>
+                  <a:tcPr marL="54864" marR="54864" marT="13716" marB="13716" anchor="ctr">
                     <a:lnL w="0" cap="flat" cmpd="sng" algn="ctr">
                       <a:noFill/>
                     </a:lnL>
@@ -1823,7 +1941,7 @@
                         <a:buNone/>
                       </a:pPr>
                       <a:r>
-                        <a:rPr lang="en-US" sz="780" b="1" dirty="0">
+                        <a:rPr lang="en-US" sz="760" b="1" dirty="0">
                           <a:solidFill>
                             <a:schemeClr val="accent1"/>
                           </a:solidFill>
@@ -1833,14 +1951,14 @@
                         </a:rPr>
                         <a:t>Gerencia de Cumplimiento</a:t>
                       </a:r>
-                      <a:endParaRPr lang="en-US" sz="780" dirty="0">
-                        <a:latin typeface="Calibri" charset="0"/>
-                        <a:ea typeface="Calibri" charset="0"/>
-                        <a:cs typeface="Calibri" charset="0"/>
-                      </a:endParaRPr>
-                    </a:p>
-                  </a:txBody>
-                  <a:tcPr marL="54864" marR="54864" marT="18288" marB="18288" anchor="ctr">
+                      <a:endParaRPr lang="en-US" sz="760" dirty="0">
+                        <a:latin typeface="Calibri" charset="0"/>
+                        <a:ea typeface="Calibri" charset="0"/>
+                        <a:cs typeface="Calibri" charset="0"/>
+                      </a:endParaRPr>
+                    </a:p>
+                  </a:txBody>
+                  <a:tcPr marL="54864" marR="54864" marT="13716" marB="13716" anchor="ctr">
                     <a:lnL w="0" cap="flat" cmpd="sng" algn="ctr">
                       <a:noFill/>
                     </a:lnL>
@@ -1872,24 +1990,24 @@
                         <a:buNone/>
                       </a:pPr>
                       <a:r>
-                        <a:rPr lang="en-US" sz="780" b="1" dirty="0">
-                          <a:solidFill>
-                            <a:schemeClr val="tx1"/>
-                          </a:solidFill>
-                          <a:latin typeface="Calibri" pitchFamily="34" charset="0"/>
-                          <a:ea typeface="Calibri" pitchFamily="34" charset="-122"/>
-                          <a:cs typeface="Calibri" pitchFamily="34" charset="-120"/>
-                        </a:rPr>
-                        <a:t>Falta de actualización de Metodología y matriz de riesgo LA/FT/FPADM Clientes o asociados</a:t>
-                      </a:r>
-                      <a:endParaRPr lang="en-US" sz="780" dirty="0">
-                        <a:latin typeface="Calibri" charset="0"/>
-                        <a:ea typeface="Calibri" charset="0"/>
-                        <a:cs typeface="Calibri" charset="0"/>
-                      </a:endParaRPr>
-                    </a:p>
-                  </a:txBody>
-                  <a:tcPr marL="54864" marR="54864" marT="18288" marB="18288" anchor="ctr">
+                        <a:rPr lang="en-US" sz="760" b="1" dirty="0">
+                          <a:solidFill>
+                            <a:schemeClr val="tx1"/>
+                          </a:solidFill>
+                          <a:latin typeface="Calibri" pitchFamily="34" charset="0"/>
+                          <a:ea typeface="Calibri" pitchFamily="34" charset="-122"/>
+                          <a:cs typeface="Calibri" pitchFamily="34" charset="-120"/>
+                        </a:rPr>
+                        <a:t>B.2  Falta de actualización de Metodología y matriz de riesgo LA/FT/FPADM Clientes o asociados</a:t>
+                      </a:r>
+                      <a:endParaRPr lang="en-US" sz="760" dirty="0">
+                        <a:latin typeface="Calibri" charset="0"/>
+                        <a:ea typeface="Calibri" charset="0"/>
+                        <a:cs typeface="Calibri" charset="0"/>
+                      </a:endParaRPr>
+                    </a:p>
+                  </a:txBody>
+                  <a:tcPr marL="54864" marR="54864" marT="13716" marB="13716" anchor="ctr">
                     <a:lnL w="0" cap="flat" cmpd="sng" algn="ctr">
                       <a:noFill/>
                     </a:lnL>
@@ -1922,24 +2040,24 @@
                         <a:buNone/>
                       </a:pPr>
                       <a:r>
-                        <a:rPr lang="en-US" sz="780" dirty="0">
-                          <a:solidFill>
-                            <a:schemeClr val="tx1"/>
-                          </a:solidFill>
-                          <a:latin typeface="Calibri" pitchFamily="34" charset="0"/>
-                          <a:ea typeface="Calibri" pitchFamily="34" charset="-122"/>
-                          <a:cs typeface="Calibri" pitchFamily="34" charset="-120"/>
-                        </a:rPr>
-                        <a:t>Comentario CA: 14/10/2026 Compromiso</a:t>
-                      </a:r>
-                      <a:endParaRPr lang="en-US" sz="780" dirty="0">
-                        <a:latin typeface="Calibri" charset="0"/>
-                        <a:ea typeface="Calibri" charset="0"/>
-                        <a:cs typeface="Calibri" charset="0"/>
-                      </a:endParaRPr>
-                    </a:p>
-                  </a:txBody>
-                  <a:tcPr marL="54864" marR="54864" marT="18288" marB="18288" anchor="ctr">
+                        <a:rPr lang="en-US" sz="760" dirty="0">
+                          <a:solidFill>
+                            <a:schemeClr val="tx1"/>
+                          </a:solidFill>
+                          <a:latin typeface="Calibri" pitchFamily="34" charset="0"/>
+                          <a:ea typeface="Calibri" pitchFamily="34" charset="-122"/>
+                          <a:cs typeface="Calibri" pitchFamily="34" charset="-120"/>
+                        </a:rPr>
+                        <a:t>Pendiente</a:t>
+                      </a:r>
+                      <a:endParaRPr lang="en-US" sz="760" dirty="0">
+                        <a:latin typeface="Calibri" charset="0"/>
+                        <a:ea typeface="Calibri" charset="0"/>
+                        <a:cs typeface="Calibri" charset="0"/>
+                      </a:endParaRPr>
+                    </a:p>
+                  </a:txBody>
+                  <a:tcPr marL="54864" marR="54864" marT="13716" marB="13716" anchor="ctr">
                     <a:lnL w="0" cap="flat" cmpd="sng" algn="ctr">
                       <a:noFill/>
                     </a:lnL>
@@ -1969,7 +2087,7 @@
                         <a:buNone/>
                       </a:pPr>
                       <a:r>
-                        <a:rPr lang="en-US" sz="780" b="1" dirty="0">
+                        <a:rPr lang="en-US" sz="760" b="1" dirty="0">
                           <a:solidFill>
                             <a:schemeClr val="accent1"/>
                           </a:solidFill>
@@ -1979,14 +2097,14 @@
                         </a:rPr>
                         <a:t>Gerencia de Cumplimiento</a:t>
                       </a:r>
-                      <a:endParaRPr lang="en-US" sz="780" dirty="0">
-                        <a:latin typeface="Calibri" charset="0"/>
-                        <a:ea typeface="Calibri" charset="0"/>
-                        <a:cs typeface="Calibri" charset="0"/>
-                      </a:endParaRPr>
-                    </a:p>
-                  </a:txBody>
-                  <a:tcPr marL="54864" marR="54864" marT="18288" marB="18288" anchor="ctr">
+                      <a:endParaRPr lang="en-US" sz="760" dirty="0">
+                        <a:latin typeface="Calibri" charset="0"/>
+                        <a:ea typeface="Calibri" charset="0"/>
+                        <a:cs typeface="Calibri" charset="0"/>
+                      </a:endParaRPr>
+                    </a:p>
+                  </a:txBody>
+                  <a:tcPr marL="54864" marR="54864" marT="13716" marB="13716" anchor="ctr">
                     <a:lnL w="0" cap="flat" cmpd="sng" algn="ctr">
                       <a:noFill/>
                     </a:lnL>
@@ -2018,24 +2136,24 @@
                         <a:buNone/>
                       </a:pPr>
                       <a:r>
-                        <a:rPr lang="en-US" sz="780" b="1" dirty="0">
-                          <a:solidFill>
-                            <a:schemeClr val="tx1"/>
-                          </a:solidFill>
-                          <a:latin typeface="Calibri" pitchFamily="34" charset="0"/>
-                          <a:ea typeface="Calibri" pitchFamily="34" charset="-122"/>
-                          <a:cs typeface="Calibri" pitchFamily="34" charset="-120"/>
-                        </a:rPr>
-                        <a:t>Falta de automatización en el proceso de remisión de reportería regulada a la Web Service de UIF.</a:t>
-                      </a:r>
-                      <a:endParaRPr lang="en-US" sz="780" dirty="0">
-                        <a:latin typeface="Calibri" charset="0"/>
-                        <a:ea typeface="Calibri" charset="0"/>
-                        <a:cs typeface="Calibri" charset="0"/>
-                      </a:endParaRPr>
-                    </a:p>
-                  </a:txBody>
-                  <a:tcPr marL="54864" marR="54864" marT="18288" marB="18288" anchor="ctr">
+                        <a:rPr lang="en-US" sz="760" b="1" dirty="0">
+                          <a:solidFill>
+                            <a:schemeClr val="tx1"/>
+                          </a:solidFill>
+                          <a:latin typeface="Calibri" pitchFamily="34" charset="0"/>
+                          <a:ea typeface="Calibri" pitchFamily="34" charset="-122"/>
+                          <a:cs typeface="Calibri" pitchFamily="34" charset="-120"/>
+                        </a:rPr>
+                        <a:t>B.3  Falta de automatización en el proceso de remisión de reportería regulada a la Web Service de UIF.</a:t>
+                      </a:r>
+                      <a:endParaRPr lang="en-US" sz="760" dirty="0">
+                        <a:latin typeface="Calibri" charset="0"/>
+                        <a:ea typeface="Calibri" charset="0"/>
+                        <a:cs typeface="Calibri" charset="0"/>
+                      </a:endParaRPr>
+                    </a:p>
+                  </a:txBody>
+                  <a:tcPr marL="54864" marR="54864" marT="13716" marB="13716" anchor="ctr">
                     <a:lnL w="0" cap="flat" cmpd="sng" algn="ctr">
                       <a:noFill/>
                     </a:lnL>
@@ -2068,24 +2186,24 @@
                         <a:buNone/>
                       </a:pPr>
                       <a:r>
-                        <a:rPr lang="en-US" sz="780" dirty="0">
-                          <a:solidFill>
-                            <a:schemeClr val="tx1"/>
-                          </a:solidFill>
-                          <a:latin typeface="Calibri" pitchFamily="34" charset="0"/>
-                          <a:ea typeface="Calibri" pitchFamily="34" charset="-122"/>
-                          <a:cs typeface="Calibri" pitchFamily="34" charset="-120"/>
-                        </a:rPr>
-                        <a:t>Comentario CA: 14/10/2026 Compromiso</a:t>
-                      </a:r>
-                      <a:endParaRPr lang="en-US" sz="780" dirty="0">
-                        <a:latin typeface="Calibri" charset="0"/>
-                        <a:ea typeface="Calibri" charset="0"/>
-                        <a:cs typeface="Calibri" charset="0"/>
-                      </a:endParaRPr>
-                    </a:p>
-                  </a:txBody>
-                  <a:tcPr marL="54864" marR="54864" marT="18288" marB="18288" anchor="ctr">
+                        <a:rPr lang="en-US" sz="760" dirty="0">
+                          <a:solidFill>
+                            <a:schemeClr val="tx1"/>
+                          </a:solidFill>
+                          <a:latin typeface="Calibri" pitchFamily="34" charset="0"/>
+                          <a:ea typeface="Calibri" pitchFamily="34" charset="-122"/>
+                          <a:cs typeface="Calibri" pitchFamily="34" charset="-120"/>
+                        </a:rPr>
+                        <a:t>Pendiente</a:t>
+                      </a:r>
+                      <a:endParaRPr lang="en-US" sz="760" dirty="0">
+                        <a:latin typeface="Calibri" charset="0"/>
+                        <a:ea typeface="Calibri" charset="0"/>
+                        <a:cs typeface="Calibri" charset="0"/>
+                      </a:endParaRPr>
+                    </a:p>
+                  </a:txBody>
+                  <a:tcPr marL="54864" marR="54864" marT="13716" marB="13716" anchor="ctr">
                     <a:lnL w="0" cap="flat" cmpd="sng" algn="ctr">
                       <a:noFill/>
                     </a:lnL>
@@ -2115,7 +2233,7 @@
                         <a:buNone/>
                       </a:pPr>
                       <a:r>
-                        <a:rPr lang="en-US" sz="780" b="1" dirty="0">
+                        <a:rPr lang="en-US" sz="760" b="1" dirty="0">
                           <a:solidFill>
                             <a:schemeClr val="accent1"/>
                           </a:solidFill>
@@ -2125,14 +2243,14 @@
                         </a:rPr>
                         <a:t>Gerencia de Cumplimiento</a:t>
                       </a:r>
-                      <a:endParaRPr lang="en-US" sz="780" dirty="0">
-                        <a:latin typeface="Calibri" charset="0"/>
-                        <a:ea typeface="Calibri" charset="0"/>
-                        <a:cs typeface="Calibri" charset="0"/>
-                      </a:endParaRPr>
-                    </a:p>
-                  </a:txBody>
-                  <a:tcPr marL="54864" marR="54864" marT="18288" marB="18288" anchor="ctr">
+                      <a:endParaRPr lang="en-US" sz="760" dirty="0">
+                        <a:latin typeface="Calibri" charset="0"/>
+                        <a:ea typeface="Calibri" charset="0"/>
+                        <a:cs typeface="Calibri" charset="0"/>
+                      </a:endParaRPr>
+                    </a:p>
+                  </a:txBody>
+                  <a:tcPr marL="54864" marR="54864" marT="13716" marB="13716" anchor="ctr">
                     <a:lnL w="0" cap="flat" cmpd="sng" algn="ctr">
                       <a:noFill/>
                     </a:lnL>
@@ -2164,24 +2282,24 @@
                         <a:buNone/>
                       </a:pPr>
                       <a:r>
-                        <a:rPr lang="en-US" sz="780" b="1" dirty="0">
-                          <a:solidFill>
-                            <a:schemeClr val="tx1"/>
-                          </a:solidFill>
-                          <a:latin typeface="Calibri" pitchFamily="34" charset="0"/>
-                          <a:ea typeface="Calibri" pitchFamily="34" charset="-122"/>
-                          <a:cs typeface="Calibri" pitchFamily="34" charset="-120"/>
-                        </a:rPr>
-                        <a:t>Falta de Automatización de la herramienta de validación de Listas de Cautela</a:t>
-                      </a:r>
-                      <a:endParaRPr lang="en-US" sz="780" dirty="0">
-                        <a:latin typeface="Calibri" charset="0"/>
-                        <a:ea typeface="Calibri" charset="0"/>
-                        <a:cs typeface="Calibri" charset="0"/>
-                      </a:endParaRPr>
-                    </a:p>
-                  </a:txBody>
-                  <a:tcPr marL="54864" marR="54864" marT="18288" marB="18288" anchor="ctr">
+                        <a:rPr lang="en-US" sz="760" b="1" dirty="0">
+                          <a:solidFill>
+                            <a:schemeClr val="tx1"/>
+                          </a:solidFill>
+                          <a:latin typeface="Calibri" pitchFamily="34" charset="0"/>
+                          <a:ea typeface="Calibri" pitchFamily="34" charset="-122"/>
+                          <a:cs typeface="Calibri" pitchFamily="34" charset="-120"/>
+                        </a:rPr>
+                        <a:t>B.4  Falta de Automatización de la herramienta de validación de Listas de Cautela</a:t>
+                      </a:r>
+                      <a:endParaRPr lang="en-US" sz="760" dirty="0">
+                        <a:latin typeface="Calibri" charset="0"/>
+                        <a:ea typeface="Calibri" charset="0"/>
+                        <a:cs typeface="Calibri" charset="0"/>
+                      </a:endParaRPr>
+                    </a:p>
+                  </a:txBody>
+                  <a:tcPr marL="54864" marR="54864" marT="13716" marB="13716" anchor="ctr">
                     <a:lnL w="0" cap="flat" cmpd="sng" algn="ctr">
                       <a:noFill/>
                     </a:lnL>
@@ -2214,24 +2332,24 @@
                         <a:buNone/>
                       </a:pPr>
                       <a:r>
-                        <a:rPr lang="en-US" sz="780" dirty="0">
-                          <a:solidFill>
-                            <a:schemeClr val="tx1"/>
-                          </a:solidFill>
-                          <a:latin typeface="Calibri" pitchFamily="34" charset="0"/>
-                          <a:ea typeface="Calibri" pitchFamily="34" charset="-122"/>
-                          <a:cs typeface="Calibri" pitchFamily="34" charset="-120"/>
-                        </a:rPr>
-                        <a:t>Comentario CA: 14/10/2026 Compromiso</a:t>
-                      </a:r>
-                      <a:endParaRPr lang="en-US" sz="780" dirty="0">
-                        <a:latin typeface="Calibri" charset="0"/>
-                        <a:ea typeface="Calibri" charset="0"/>
-                        <a:cs typeface="Calibri" charset="0"/>
-                      </a:endParaRPr>
-                    </a:p>
-                  </a:txBody>
-                  <a:tcPr marL="54864" marR="54864" marT="18288" marB="18288" anchor="ctr">
+                        <a:rPr lang="en-US" sz="760" dirty="0">
+                          <a:solidFill>
+                            <a:schemeClr val="tx1"/>
+                          </a:solidFill>
+                          <a:latin typeface="Calibri" pitchFamily="34" charset="0"/>
+                          <a:ea typeface="Calibri" pitchFamily="34" charset="-122"/>
+                          <a:cs typeface="Calibri" pitchFamily="34" charset="-120"/>
+                        </a:rPr>
+                        <a:t>Pendiente</a:t>
+                      </a:r>
+                      <a:endParaRPr lang="en-US" sz="760" dirty="0">
+                        <a:latin typeface="Calibri" charset="0"/>
+                        <a:ea typeface="Calibri" charset="0"/>
+                        <a:cs typeface="Calibri" charset="0"/>
+                      </a:endParaRPr>
+                    </a:p>
+                  </a:txBody>
+                  <a:tcPr marL="54864" marR="54864" marT="13716" marB="13716" anchor="ctr">
                     <a:lnL w="0" cap="flat" cmpd="sng" algn="ctr">
                       <a:noFill/>
                     </a:lnL>
@@ -2261,7 +2379,7 @@
                         <a:buNone/>
                       </a:pPr>
                       <a:r>
-                        <a:rPr lang="en-US" sz="780" b="1" dirty="0">
+                        <a:rPr lang="en-US" sz="760" b="1" dirty="0">
                           <a:solidFill>
                             <a:schemeClr val="accent1"/>
                           </a:solidFill>
@@ -2271,14 +2389,14 @@
                         </a:rPr>
                         <a:t>Gerencia de Cumplimiento</a:t>
                       </a:r>
-                      <a:endParaRPr lang="en-US" sz="780" dirty="0">
-                        <a:latin typeface="Calibri" charset="0"/>
-                        <a:ea typeface="Calibri" charset="0"/>
-                        <a:cs typeface="Calibri" charset="0"/>
-                      </a:endParaRPr>
-                    </a:p>
-                  </a:txBody>
-                  <a:tcPr marL="54864" marR="54864" marT="18288" marB="18288" anchor="ctr">
+                      <a:endParaRPr lang="en-US" sz="760" dirty="0">
+                        <a:latin typeface="Calibri" charset="0"/>
+                        <a:ea typeface="Calibri" charset="0"/>
+                        <a:cs typeface="Calibri" charset="0"/>
+                      </a:endParaRPr>
+                    </a:p>
+                  </a:txBody>
+                  <a:tcPr marL="54864" marR="54864" marT="13716" marB="13716" anchor="ctr">
                     <a:lnL w="0" cap="flat" cmpd="sng" algn="ctr">
                       <a:noFill/>
                     </a:lnL>
@@ -2310,24 +2428,24 @@
                         <a:buNone/>
                       </a:pPr>
                       <a:r>
-                        <a:rPr lang="en-US" sz="780" b="1" dirty="0">
-                          <a:solidFill>
-                            <a:schemeClr val="tx1"/>
-                          </a:solidFill>
-                          <a:latin typeface="Calibri" pitchFamily="34" charset="0"/>
-                          <a:ea typeface="Calibri" pitchFamily="34" charset="-122"/>
-                          <a:cs typeface="Calibri" pitchFamily="34" charset="-120"/>
-                        </a:rPr>
-                        <a:t>Falta de evidencia en los porcentajes de avance comunicados en el cronograma</a:t>
-                      </a:r>
-                      <a:endParaRPr lang="en-US" sz="780" dirty="0">
-                        <a:latin typeface="Calibri" charset="0"/>
-                        <a:ea typeface="Calibri" charset="0"/>
-                        <a:cs typeface="Calibri" charset="0"/>
-                      </a:endParaRPr>
-                    </a:p>
-                  </a:txBody>
-                  <a:tcPr marL="54864" marR="54864" marT="18288" marB="18288" anchor="ctr">
+                        <a:rPr lang="en-US" sz="760" b="1" dirty="0">
+                          <a:solidFill>
+                            <a:schemeClr val="tx1"/>
+                          </a:solidFill>
+                          <a:latin typeface="Calibri" pitchFamily="34" charset="0"/>
+                          <a:ea typeface="Calibri" pitchFamily="34" charset="-122"/>
+                          <a:cs typeface="Calibri" pitchFamily="34" charset="-120"/>
+                        </a:rPr>
+                        <a:t>B.5  Falta de evidencia en los porcentajes de avance comunicados en el cronograma</a:t>
+                      </a:r>
+                      <a:endParaRPr lang="en-US" sz="760" dirty="0">
+                        <a:latin typeface="Calibri" charset="0"/>
+                        <a:ea typeface="Calibri" charset="0"/>
+                        <a:cs typeface="Calibri" charset="0"/>
+                      </a:endParaRPr>
+                    </a:p>
+                  </a:txBody>
+                  <a:tcPr marL="54864" marR="54864" marT="13716" marB="13716" anchor="ctr">
                     <a:lnL w="0" cap="flat" cmpd="sng" algn="ctr">
                       <a:noFill/>
                     </a:lnL>
@@ -2360,24 +2478,24 @@
                         <a:buNone/>
                       </a:pPr>
                       <a:r>
-                        <a:rPr lang="en-US" sz="780" dirty="0">
-                          <a:solidFill>
-                            <a:schemeClr val="tx1"/>
-                          </a:solidFill>
-                          <a:latin typeface="Calibri" pitchFamily="34" charset="0"/>
-                          <a:ea typeface="Calibri" pitchFamily="34" charset="-122"/>
-                          <a:cs typeface="Calibri" pitchFamily="34" charset="-120"/>
-                        </a:rPr>
-                        <a:t>Comentario CA: 14/10/2026 Compromiso</a:t>
-                      </a:r>
-                      <a:endParaRPr lang="en-US" sz="780" dirty="0">
-                        <a:latin typeface="Calibri" charset="0"/>
-                        <a:ea typeface="Calibri" charset="0"/>
-                        <a:cs typeface="Calibri" charset="0"/>
-                      </a:endParaRPr>
-                    </a:p>
-                  </a:txBody>
-                  <a:tcPr marL="54864" marR="54864" marT="18288" marB="18288" anchor="ctr">
+                        <a:rPr lang="en-US" sz="760" dirty="0">
+                          <a:solidFill>
+                            <a:schemeClr val="tx1"/>
+                          </a:solidFill>
+                          <a:latin typeface="Calibri" pitchFamily="34" charset="0"/>
+                          <a:ea typeface="Calibri" pitchFamily="34" charset="-122"/>
+                          <a:cs typeface="Calibri" pitchFamily="34" charset="-120"/>
+                        </a:rPr>
+                        <a:t>Pendiente</a:t>
+                      </a:r>
+                      <a:endParaRPr lang="en-US" sz="760" dirty="0">
+                        <a:latin typeface="Calibri" charset="0"/>
+                        <a:ea typeface="Calibri" charset="0"/>
+                        <a:cs typeface="Calibri" charset="0"/>
+                      </a:endParaRPr>
+                    </a:p>
+                  </a:txBody>
+                  <a:tcPr marL="54864" marR="54864" marT="13716" marB="13716" anchor="ctr">
                     <a:lnL w="0" cap="flat" cmpd="sng" algn="ctr">
                       <a:noFill/>
                     </a:lnL>
@@ -2407,7 +2525,7 @@
                         <a:buNone/>
                       </a:pPr>
                       <a:r>
-                        <a:rPr lang="en-US" sz="780" b="1" dirty="0">
+                        <a:rPr lang="en-US" sz="760" b="1" dirty="0">
                           <a:solidFill>
                             <a:schemeClr val="accent1"/>
                           </a:solidFill>
@@ -2417,14 +2535,14 @@
                         </a:rPr>
                         <a:t>Gerencia de Cumplimiento</a:t>
                       </a:r>
-                      <a:endParaRPr lang="en-US" sz="780" dirty="0">
-                        <a:latin typeface="Calibri" charset="0"/>
-                        <a:ea typeface="Calibri" charset="0"/>
-                        <a:cs typeface="Calibri" charset="0"/>
-                      </a:endParaRPr>
-                    </a:p>
-                  </a:txBody>
-                  <a:tcPr marL="54864" marR="54864" marT="18288" marB="18288" anchor="ctr">
+                      <a:endParaRPr lang="en-US" sz="760" dirty="0">
+                        <a:latin typeface="Calibri" charset="0"/>
+                        <a:ea typeface="Calibri" charset="0"/>
+                        <a:cs typeface="Calibri" charset="0"/>
+                      </a:endParaRPr>
+                    </a:p>
+                  </a:txBody>
+                  <a:tcPr marL="54864" marR="54864" marT="13716" marB="13716" anchor="ctr">
                     <a:lnL w="0" cap="flat" cmpd="sng" algn="ctr">
                       <a:noFill/>
                     </a:lnL>
@@ -2456,24 +2574,24 @@
                         <a:buNone/>
                       </a:pPr>
                       <a:r>
-                        <a:rPr lang="en-US" sz="780" b="1" dirty="0">
-                          <a:solidFill>
-                            <a:schemeClr val="tx1"/>
-                          </a:solidFill>
-                          <a:latin typeface="Calibri" pitchFamily="34" charset="0"/>
-                          <a:ea typeface="Calibri" pitchFamily="34" charset="-122"/>
-                          <a:cs typeface="Calibri" pitchFamily="34" charset="-120"/>
-                        </a:rPr>
-                        <a:t>Revisión documentación conforme artículo22 de la NRP-23</a:t>
-                      </a:r>
-                      <a:endParaRPr lang="en-US" sz="780" dirty="0">
-                        <a:latin typeface="Calibri" charset="0"/>
-                        <a:ea typeface="Calibri" charset="0"/>
-                        <a:cs typeface="Calibri" charset="0"/>
-                      </a:endParaRPr>
-                    </a:p>
-                  </a:txBody>
-                  <a:tcPr marL="54864" marR="54864" marT="18288" marB="18288" anchor="ctr">
+                        <a:rPr lang="en-US" sz="760" b="1" dirty="0">
+                          <a:solidFill>
+                            <a:schemeClr val="tx1"/>
+                          </a:solidFill>
+                          <a:latin typeface="Calibri" pitchFamily="34" charset="0"/>
+                          <a:ea typeface="Calibri" pitchFamily="34" charset="-122"/>
+                          <a:cs typeface="Calibri" pitchFamily="34" charset="-120"/>
+                        </a:rPr>
+                        <a:t>B.6  Revisión documentación conforme artículo22 de la NRP-23</a:t>
+                      </a:r>
+                      <a:endParaRPr lang="en-US" sz="760" dirty="0">
+                        <a:latin typeface="Calibri" charset="0"/>
+                        <a:ea typeface="Calibri" charset="0"/>
+                        <a:cs typeface="Calibri" charset="0"/>
+                      </a:endParaRPr>
+                    </a:p>
+                  </a:txBody>
+                  <a:tcPr marL="54864" marR="54864" marT="13716" marB="13716" anchor="ctr">
                     <a:lnL w="0" cap="flat" cmpd="sng" algn="ctr">
                       <a:noFill/>
                     </a:lnL>
@@ -2506,7 +2624,7 @@
                         <a:buNone/>
                       </a:pPr>
                       <a:r>
-                        <a:rPr lang="en-US" sz="780" dirty="0">
+                        <a:rPr lang="en-US" sz="760" dirty="0">
                           <a:solidFill>
                             <a:schemeClr val="tx1"/>
                           </a:solidFill>
@@ -2516,14 +2634,14 @@
                         </a:rPr>
                         <a:t>Se anexa informe elaborado en fecha 13 de diciembre de 2024, sobre proyecto de implementación de un nuevo sistema de monitoreo de LDA/FT/FPADM y del sistema de fraude de canales digitales.</a:t>
                       </a:r>
-                      <a:endParaRPr lang="en-US" sz="780" dirty="0">
-                        <a:latin typeface="Calibri" charset="0"/>
-                        <a:ea typeface="Calibri" charset="0"/>
-                        <a:cs typeface="Calibri" charset="0"/>
-                      </a:endParaRPr>
-                    </a:p>
-                  </a:txBody>
-                  <a:tcPr marL="54864" marR="54864" marT="18288" marB="18288" anchor="ctr">
+                      <a:endParaRPr lang="en-US" sz="760" dirty="0">
+                        <a:latin typeface="Calibri" charset="0"/>
+                        <a:ea typeface="Calibri" charset="0"/>
+                        <a:cs typeface="Calibri" charset="0"/>
+                      </a:endParaRPr>
+                    </a:p>
+                  </a:txBody>
+                  <a:tcPr marL="54864" marR="54864" marT="13716" marB="13716" anchor="ctr">
                     <a:lnL w="0" cap="flat" cmpd="sng" algn="ctr">
                       <a:noFill/>
                     </a:lnL>
@@ -2553,7 +2671,7 @@
                         <a:buNone/>
                       </a:pPr>
                       <a:r>
-                        <a:rPr lang="en-US" sz="780" b="1" dirty="0">
+                        <a:rPr lang="en-US" sz="760" b="1" dirty="0">
                           <a:solidFill>
                             <a:schemeClr val="accent1"/>
                           </a:solidFill>
@@ -2563,14 +2681,14 @@
                         </a:rPr>
                         <a:t>Jefe de Riesgos</a:t>
                       </a:r>
-                      <a:endParaRPr lang="en-US" sz="780" dirty="0">
-                        <a:latin typeface="Calibri" charset="0"/>
-                        <a:ea typeface="Calibri" charset="0"/>
-                        <a:cs typeface="Calibri" charset="0"/>
-                      </a:endParaRPr>
-                    </a:p>
-                  </a:txBody>
-                  <a:tcPr marL="54864" marR="54864" marT="18288" marB="18288" anchor="ctr">
+                      <a:endParaRPr lang="en-US" sz="760" dirty="0">
+                        <a:latin typeface="Calibri" charset="0"/>
+                        <a:ea typeface="Calibri" charset="0"/>
+                        <a:cs typeface="Calibri" charset="0"/>
+                      </a:endParaRPr>
+                    </a:p>
+                  </a:txBody>
+                  <a:tcPr marL="54864" marR="54864" marT="13716" marB="13716" anchor="ctr">
                     <a:lnL w="0" cap="flat" cmpd="sng" algn="ctr">
                       <a:noFill/>
                     </a:lnL>
@@ -2602,24 +2720,24 @@
                         <a:buNone/>
                       </a:pPr>
                       <a:r>
-                        <a:rPr lang="en-US" sz="780" b="1" dirty="0">
-                          <a:solidFill>
-                            <a:schemeClr val="tx1"/>
-                          </a:solidFill>
-                          <a:latin typeface="Calibri" pitchFamily="34" charset="0"/>
-                          <a:ea typeface="Calibri" pitchFamily="34" charset="-122"/>
-                          <a:cs typeface="Calibri" pitchFamily="34" charset="-120"/>
-                        </a:rPr>
-                        <a:t>Debilidades en el contrato del servicio de software</a:t>
-                      </a:r>
-                      <a:endParaRPr lang="en-US" sz="780" dirty="0">
-                        <a:latin typeface="Calibri" charset="0"/>
-                        <a:ea typeface="Calibri" charset="0"/>
-                        <a:cs typeface="Calibri" charset="0"/>
-                      </a:endParaRPr>
-                    </a:p>
-                  </a:txBody>
-                  <a:tcPr marL="54864" marR="54864" marT="18288" marB="18288" anchor="ctr">
+                        <a:rPr lang="en-US" sz="760" b="1" dirty="0">
+                          <a:solidFill>
+                            <a:schemeClr val="tx1"/>
+                          </a:solidFill>
+                          <a:latin typeface="Calibri" pitchFamily="34" charset="0"/>
+                          <a:ea typeface="Calibri" pitchFamily="34" charset="-122"/>
+                          <a:cs typeface="Calibri" pitchFamily="34" charset="-120"/>
+                        </a:rPr>
+                        <a:t>B.7  Debilidades en el contrato del servicio de software</a:t>
+                      </a:r>
+                      <a:endParaRPr lang="en-US" sz="760" dirty="0">
+                        <a:latin typeface="Calibri" charset="0"/>
+                        <a:ea typeface="Calibri" charset="0"/>
+                        <a:cs typeface="Calibri" charset="0"/>
+                      </a:endParaRPr>
+                    </a:p>
+                  </a:txBody>
+                  <a:tcPr marL="54864" marR="54864" marT="13716" marB="13716" anchor="ctr">
                     <a:lnL w="0" cap="flat" cmpd="sng" algn="ctr">
                       <a:noFill/>
                     </a:lnL>
@@ -2652,7 +2770,7 @@
                         <a:buNone/>
                       </a:pPr>
                       <a:r>
-                        <a:rPr lang="en-US" sz="780" dirty="0">
+                        <a:rPr lang="en-US" sz="760" dirty="0">
                           <a:solidFill>
                             <a:schemeClr val="tx1"/>
                           </a:solidFill>
@@ -2662,35 +2780,35 @@
                         </a:rPr>
                         <a:t>Se adjuntará la propuesta de la Gerencia Legal por medio de correo de fecha 09 de octubre 2026, envió propuesta a la Gerencia de Cumplimiento y Seguridad de la Información para la modificación del contrato.</a:t>
                       </a:r>
-                      <a:endParaRPr lang="en-US" sz="780" dirty="0">
-                        <a:latin typeface="Calibri" charset="0"/>
-                        <a:ea typeface="Calibri" charset="0"/>
-                        <a:cs typeface="Calibri" charset="0"/>
-                      </a:endParaRPr>
-                    </a:p>
-                    <a:p>
-                      <a:pPr algn="just" indent="0" marL="0">
-                        <a:buNone/>
-                      </a:pPr>
-                      <a:r>
-                        <a:rPr lang="en-US" sz="780" dirty="0">
-                          <a:solidFill>
-                            <a:schemeClr val="tx1"/>
-                          </a:solidFill>
-                          <a:latin typeface="Calibri" pitchFamily="34" charset="0"/>
-                          <a:ea typeface="Calibri" pitchFamily="34" charset="-122"/>
-                          <a:cs typeface="Calibri" pitchFamily="34" charset="-120"/>
-                        </a:rPr>
-                        <a:t>Comentario CA: 14/10/2026 Compromiso</a:t>
-                      </a:r>
-                      <a:endParaRPr lang="en-US" sz="780" dirty="0">
-                        <a:latin typeface="Calibri" charset="0"/>
-                        <a:ea typeface="Calibri" charset="0"/>
-                        <a:cs typeface="Calibri" charset="0"/>
-                      </a:endParaRPr>
-                    </a:p>
-                  </a:txBody>
-                  <a:tcPr marL="54864" marR="54864" marT="18288" marB="18288" anchor="ctr">
+                      <a:endParaRPr lang="en-US" sz="760" dirty="0">
+                        <a:latin typeface="Calibri" charset="0"/>
+                        <a:ea typeface="Calibri" charset="0"/>
+                        <a:cs typeface="Calibri" charset="0"/>
+                      </a:endParaRPr>
+                    </a:p>
+                    <a:p>
+                      <a:pPr algn="just" indent="0" marL="0">
+                        <a:buNone/>
+                      </a:pPr>
+                      <a:r>
+                        <a:rPr lang="en-US" sz="760" dirty="0">
+                          <a:solidFill>
+                            <a:schemeClr val="tx1"/>
+                          </a:solidFill>
+                          <a:latin typeface="Calibri" pitchFamily="34" charset="0"/>
+                          <a:ea typeface="Calibri" pitchFamily="34" charset="-122"/>
+                          <a:cs typeface="Calibri" pitchFamily="34" charset="-120"/>
+                        </a:rPr>
+                        <a:t>Pendiente</a:t>
+                      </a:r>
+                      <a:endParaRPr lang="en-US" sz="760" dirty="0">
+                        <a:latin typeface="Calibri" charset="0"/>
+                        <a:ea typeface="Calibri" charset="0"/>
+                        <a:cs typeface="Calibri" charset="0"/>
+                      </a:endParaRPr>
+                    </a:p>
+                  </a:txBody>
+                  <a:tcPr marL="54864" marR="54864" marT="13716" marB="13716" anchor="ctr">
                     <a:lnL w="0" cap="flat" cmpd="sng" algn="ctr">
                       <a:noFill/>
                     </a:lnL>
@@ -2720,7 +2838,7 @@
                         <a:buNone/>
                       </a:pPr>
                       <a:r>
-                        <a:rPr lang="en-US" sz="780" b="1" dirty="0">
+                        <a:rPr lang="en-US" sz="760" b="1" dirty="0">
                           <a:solidFill>
                             <a:schemeClr val="accent1"/>
                           </a:solidFill>
@@ -2730,7 +2848,7 @@
                         </a:rPr>
                         <a:t>Gerencia de Cumplimiento</a:t>
                       </a:r>
-                      <a:endParaRPr lang="en-US" sz="780" dirty="0">
+                      <a:endParaRPr lang="en-US" sz="760" dirty="0">
                         <a:latin typeface="Calibri" charset="0"/>
                         <a:ea typeface="Calibri" charset="0"/>
                         <a:cs typeface="Calibri" charset="0"/>
@@ -2741,7 +2859,7 @@
                         <a:buNone/>
                       </a:pPr>
                       <a:r>
-                        <a:rPr lang="en-US" sz="780" b="1" dirty="0">
+                        <a:rPr lang="en-US" sz="760" b="1" dirty="0">
                           <a:solidFill>
                             <a:schemeClr val="accent1"/>
                           </a:solidFill>
@@ -2751,14 +2869,14 @@
                         </a:rPr>
                         <a:t>/ Gerencia Legal</a:t>
                       </a:r>
-                      <a:endParaRPr lang="en-US" sz="780" dirty="0">
-                        <a:latin typeface="Calibri" charset="0"/>
-                        <a:ea typeface="Calibri" charset="0"/>
-                        <a:cs typeface="Calibri" charset="0"/>
-                      </a:endParaRPr>
-                    </a:p>
-                  </a:txBody>
-                  <a:tcPr marL="54864" marR="54864" marT="18288" marB="18288" anchor="ctr">
+                      <a:endParaRPr lang="en-US" sz="760" dirty="0">
+                        <a:latin typeface="Calibri" charset="0"/>
+                        <a:ea typeface="Calibri" charset="0"/>
+                        <a:cs typeface="Calibri" charset="0"/>
+                      </a:endParaRPr>
+                    </a:p>
+                  </a:txBody>
+                  <a:tcPr marL="54864" marR="54864" marT="13716" marB="13716" anchor="ctr">
                     <a:lnL w="0" cap="flat" cmpd="sng" algn="ctr">
                       <a:noFill/>
                     </a:lnL>
@@ -2790,24 +2908,24 @@
                         <a:buNone/>
                       </a:pPr>
                       <a:r>
-                        <a:rPr lang="en-US" sz="780" b="1" dirty="0">
-                          <a:solidFill>
-                            <a:schemeClr val="tx1"/>
-                          </a:solidFill>
-                          <a:latin typeface="Calibri" pitchFamily="34" charset="0"/>
-                          <a:ea typeface="Calibri" pitchFamily="34" charset="-122"/>
-                          <a:cs typeface="Calibri" pitchFamily="34" charset="-120"/>
-                        </a:rPr>
-                        <a:t>Debilidad en el Alcance de las Pruebas Continuidad del Negocio</a:t>
-                      </a:r>
-                      <a:endParaRPr lang="en-US" sz="780" dirty="0">
-                        <a:latin typeface="Calibri" charset="0"/>
-                        <a:ea typeface="Calibri" charset="0"/>
-                        <a:cs typeface="Calibri" charset="0"/>
-                      </a:endParaRPr>
-                    </a:p>
-                  </a:txBody>
-                  <a:tcPr marL="54864" marR="54864" marT="18288" marB="18288" anchor="ctr">
+                        <a:rPr lang="en-US" sz="760" b="1" dirty="0">
+                          <a:solidFill>
+                            <a:schemeClr val="tx1"/>
+                          </a:solidFill>
+                          <a:latin typeface="Calibri" pitchFamily="34" charset="0"/>
+                          <a:ea typeface="Calibri" pitchFamily="34" charset="-122"/>
+                          <a:cs typeface="Calibri" pitchFamily="34" charset="-120"/>
+                        </a:rPr>
+                        <a:t>B.8  Debilidad en el Alcance de las Pruebas Continuidad del Negocio</a:t>
+                      </a:r>
+                      <a:endParaRPr lang="en-US" sz="760" dirty="0">
+                        <a:latin typeface="Calibri" charset="0"/>
+                        <a:ea typeface="Calibri" charset="0"/>
+                        <a:cs typeface="Calibri" charset="0"/>
+                      </a:endParaRPr>
+                    </a:p>
+                  </a:txBody>
+                  <a:tcPr marL="54864" marR="54864" marT="13716" marB="13716" anchor="ctr">
                     <a:lnL w="0" cap="flat" cmpd="sng" algn="ctr">
                       <a:noFill/>
                     </a:lnL>
@@ -2840,7 +2958,7 @@
                         <a:buNone/>
                       </a:pPr>
                       <a:r>
-                        <a:rPr lang="en-US" sz="780" dirty="0">
+                        <a:rPr lang="en-US" sz="760" dirty="0">
                           <a:solidFill>
                             <a:schemeClr val="tx1"/>
                           </a:solidFill>
@@ -2850,39 +2968,39 @@
                         </a:rPr>
                         <a:t>Plan de acción: proveedor critico</a:t>
                       </a:r>
-                      <a:endParaRPr lang="en-US" sz="780" dirty="0">
-                        <a:latin typeface="Calibri" charset="0"/>
-                        <a:ea typeface="Calibri" charset="0"/>
-                        <a:cs typeface="Calibri" charset="0"/>
-                      </a:endParaRPr>
-                    </a:p>
-                    <a:p>
-                      <a:pPr algn="just" indent="0" marL="0">
-                        <a:buNone/>
-                      </a:pPr>
-                      <a:r>
-                        <a:rPr lang="en-US" sz="780" dirty="0">
-                          <a:solidFill>
-                            <a:schemeClr val="tx1"/>
-                          </a:solidFill>
-                          <a:latin typeface="Calibri" pitchFamily="34" charset="0"/>
-                          <a:ea typeface="Calibri" pitchFamily="34" charset="-122"/>
-                          <a:cs typeface="Calibri" pitchFamily="34" charset="-120"/>
-                        </a:rPr>
-                        <a:t>Comentario CA: 14/10/2026 Compromiso</a:t>
-                      </a:r>
-                      <a:endParaRPr lang="en-US" sz="780" dirty="0">
-                        <a:latin typeface="Calibri" charset="0"/>
-                        <a:ea typeface="Calibri" charset="0"/>
-                        <a:cs typeface="Calibri" charset="0"/>
-                      </a:endParaRPr>
-                    </a:p>
-                    <a:p>
-                      <a:pPr algn="just" indent="0" marL="0">
-                        <a:buNone/>
-                      </a:pPr>
-                      <a:r>
-                        <a:rPr lang="en-US" sz="780" dirty="0">
+                      <a:endParaRPr lang="en-US" sz="760" dirty="0">
+                        <a:latin typeface="Calibri" charset="0"/>
+                        <a:ea typeface="Calibri" charset="0"/>
+                        <a:cs typeface="Calibri" charset="0"/>
+                      </a:endParaRPr>
+                    </a:p>
+                    <a:p>
+                      <a:pPr algn="just" indent="0" marL="0">
+                        <a:buNone/>
+                      </a:pPr>
+                      <a:r>
+                        <a:rPr lang="en-US" sz="760" dirty="0">
+                          <a:solidFill>
+                            <a:schemeClr val="tx1"/>
+                          </a:solidFill>
+                          <a:latin typeface="Calibri" pitchFamily="34" charset="0"/>
+                          <a:ea typeface="Calibri" pitchFamily="34" charset="-122"/>
+                          <a:cs typeface="Calibri" pitchFamily="34" charset="-120"/>
+                        </a:rPr>
+                        <a:t>Pendiente</a:t>
+                      </a:r>
+                      <a:endParaRPr lang="en-US" sz="760" dirty="0">
+                        <a:latin typeface="Calibri" charset="0"/>
+                        <a:ea typeface="Calibri" charset="0"/>
+                        <a:cs typeface="Calibri" charset="0"/>
+                      </a:endParaRPr>
+                    </a:p>
+                    <a:p>
+                      <a:pPr algn="just" indent="0" marL="0">
+                        <a:buNone/>
+                      </a:pPr>
+                      <a:r>
+                        <a:rPr lang="en-US" sz="760" dirty="0">
                           <a:solidFill>
                             <a:schemeClr val="tx1"/>
                           </a:solidFill>
@@ -2892,14 +3010,14 @@
                         </a:rPr>
                         <a:t>Se identificarán los servicios tecnológicos tercerizados críticos y se incorporarán en el alcance de las pruebas de continuidad del negocio. Asimismo, se solicitarán a los proveedores los resultados y evidencias de las pruebas realizadas, con el fin de validar la efectividad de los controles implementados.</a:t>
                       </a:r>
-                      <a:endParaRPr lang="en-US" sz="780" dirty="0">
-                        <a:latin typeface="Calibri" charset="0"/>
-                        <a:ea typeface="Calibri" charset="0"/>
-                        <a:cs typeface="Calibri" charset="0"/>
-                      </a:endParaRPr>
-                    </a:p>
-                  </a:txBody>
-                  <a:tcPr marL="54864" marR="54864" marT="18288" marB="18288" anchor="ctr">
+                      <a:endParaRPr lang="en-US" sz="760" dirty="0">
+                        <a:latin typeface="Calibri" charset="0"/>
+                        <a:ea typeface="Calibri" charset="0"/>
+                        <a:cs typeface="Calibri" charset="0"/>
+                      </a:endParaRPr>
+                    </a:p>
+                  </a:txBody>
+                  <a:tcPr marL="54864" marR="54864" marT="13716" marB="13716" anchor="ctr">
                     <a:lnL w="0" cap="flat" cmpd="sng" algn="ctr">
                       <a:noFill/>
                     </a:lnL>
@@ -2929,7 +3047,7 @@
                         <a:buNone/>
                       </a:pPr>
                       <a:r>
-                        <a:rPr lang="en-US" sz="780" b="1" dirty="0">
+                        <a:rPr lang="en-US" sz="760" b="1" dirty="0">
                           <a:solidFill>
                             <a:schemeClr val="accent1"/>
                           </a:solidFill>
@@ -2939,14 +3057,14 @@
                         </a:rPr>
                         <a:t>Administración de Riesgos/Gerencia de sistemas/Seguridad de la información</a:t>
                       </a:r>
-                      <a:endParaRPr lang="en-US" sz="780" dirty="0">
-                        <a:latin typeface="Calibri" charset="0"/>
-                        <a:ea typeface="Calibri" charset="0"/>
-                        <a:cs typeface="Calibri" charset="0"/>
-                      </a:endParaRPr>
-                    </a:p>
-                  </a:txBody>
-                  <a:tcPr marL="54864" marR="54864" marT="18288" marB="18288" anchor="ctr">
+                      <a:endParaRPr lang="en-US" sz="760" dirty="0">
+                        <a:latin typeface="Calibri" charset="0"/>
+                        <a:ea typeface="Calibri" charset="0"/>
+                        <a:cs typeface="Calibri" charset="0"/>
+                      </a:endParaRPr>
+                    </a:p>
+                  </a:txBody>
+                  <a:tcPr marL="54864" marR="54864" marT="13716" marB="13716" anchor="ctr">
                     <a:lnL w="0" cap="flat" cmpd="sng" algn="ctr">
                       <a:noFill/>
                     </a:lnL>
@@ -2978,24 +3096,24 @@
                         <a:buNone/>
                       </a:pPr>
                       <a:r>
-                        <a:rPr lang="en-US" sz="780" b="1" dirty="0">
-                          <a:solidFill>
-                            <a:schemeClr val="tx1"/>
-                          </a:solidFill>
-                          <a:latin typeface="Calibri" pitchFamily="34" charset="0"/>
-                          <a:ea typeface="Calibri" pitchFamily="34" charset="-122"/>
-                          <a:cs typeface="Calibri" pitchFamily="34" charset="-120"/>
-                        </a:rPr>
-                        <a:t>Deficiencia en los procedimientos de Respaldos.</a:t>
-                      </a:r>
-                      <a:endParaRPr lang="en-US" sz="780" dirty="0">
-                        <a:latin typeface="Calibri" charset="0"/>
-                        <a:ea typeface="Calibri" charset="0"/>
-                        <a:cs typeface="Calibri" charset="0"/>
-                      </a:endParaRPr>
-                    </a:p>
-                  </a:txBody>
-                  <a:tcPr marL="54864" marR="54864" marT="18288" marB="18288" anchor="ctr">
+                        <a:rPr lang="en-US" sz="760" b="1" dirty="0">
+                          <a:solidFill>
+                            <a:schemeClr val="tx1"/>
+                          </a:solidFill>
+                          <a:latin typeface="Calibri" pitchFamily="34" charset="0"/>
+                          <a:ea typeface="Calibri" pitchFamily="34" charset="-122"/>
+                          <a:cs typeface="Calibri" pitchFamily="34" charset="-120"/>
+                        </a:rPr>
+                        <a:t>B.9  Deficiencia en los procedimientos de Respaldos.</a:t>
+                      </a:r>
+                      <a:endParaRPr lang="en-US" sz="760" dirty="0">
+                        <a:latin typeface="Calibri" charset="0"/>
+                        <a:ea typeface="Calibri" charset="0"/>
+                        <a:cs typeface="Calibri" charset="0"/>
+                      </a:endParaRPr>
+                    </a:p>
+                  </a:txBody>
+                  <a:tcPr marL="54864" marR="54864" marT="13716" marB="13716" anchor="ctr">
                     <a:lnL w="0" cap="flat" cmpd="sng" algn="ctr">
                       <a:noFill/>
                     </a:lnL>
@@ -3028,7 +3146,7 @@
                         <a:buNone/>
                       </a:pPr>
                       <a:r>
-                        <a:rPr lang="en-US" sz="780" dirty="0">
+                        <a:rPr lang="en-US" sz="760" dirty="0">
                           <a:solidFill>
                             <a:schemeClr val="tx1"/>
                           </a:solidFill>
@@ -3038,35 +3156,35 @@
                         </a:rPr>
                         <a:t>Plan de acción</a:t>
                       </a:r>
-                      <a:endParaRPr lang="en-US" sz="780" dirty="0">
-                        <a:latin typeface="Calibri" charset="0"/>
-                        <a:ea typeface="Calibri" charset="0"/>
-                        <a:cs typeface="Calibri" charset="0"/>
-                      </a:endParaRPr>
-                    </a:p>
-                    <a:p>
-                      <a:pPr algn="just" indent="0" marL="0">
-                        <a:buNone/>
-                      </a:pPr>
-                      <a:r>
-                        <a:rPr lang="en-US" sz="780" dirty="0">
-                          <a:solidFill>
-                            <a:schemeClr val="tx1"/>
-                          </a:solidFill>
-                          <a:latin typeface="Calibri" pitchFamily="34" charset="0"/>
-                          <a:ea typeface="Calibri" pitchFamily="34" charset="-122"/>
-                          <a:cs typeface="Calibri" pitchFamily="34" charset="-120"/>
-                        </a:rPr>
-                        <a:t>Comentario CA: 14/10/2026 Compromiso</a:t>
-                      </a:r>
-                      <a:endParaRPr lang="en-US" sz="780" dirty="0">
-                        <a:latin typeface="Calibri" charset="0"/>
-                        <a:ea typeface="Calibri" charset="0"/>
-                        <a:cs typeface="Calibri" charset="0"/>
-                      </a:endParaRPr>
-                    </a:p>
-                  </a:txBody>
-                  <a:tcPr marL="54864" marR="54864" marT="18288" marB="18288" anchor="ctr">
+                      <a:endParaRPr lang="en-US" sz="760" dirty="0">
+                        <a:latin typeface="Calibri" charset="0"/>
+                        <a:ea typeface="Calibri" charset="0"/>
+                        <a:cs typeface="Calibri" charset="0"/>
+                      </a:endParaRPr>
+                    </a:p>
+                    <a:p>
+                      <a:pPr algn="just" indent="0" marL="0">
+                        <a:buNone/>
+                      </a:pPr>
+                      <a:r>
+                        <a:rPr lang="en-US" sz="760" dirty="0">
+                          <a:solidFill>
+                            <a:schemeClr val="tx1"/>
+                          </a:solidFill>
+                          <a:latin typeface="Calibri" pitchFamily="34" charset="0"/>
+                          <a:ea typeface="Calibri" pitchFamily="34" charset="-122"/>
+                          <a:cs typeface="Calibri" pitchFamily="34" charset="-120"/>
+                        </a:rPr>
+                        <a:t>Pendiente</a:t>
+                      </a:r>
+                      <a:endParaRPr lang="en-US" sz="760" dirty="0">
+                        <a:latin typeface="Calibri" charset="0"/>
+                        <a:ea typeface="Calibri" charset="0"/>
+                        <a:cs typeface="Calibri" charset="0"/>
+                      </a:endParaRPr>
+                    </a:p>
+                  </a:txBody>
+                  <a:tcPr marL="54864" marR="54864" marT="13716" marB="13716" anchor="ctr">
                     <a:lnL w="0" cap="flat" cmpd="sng" algn="ctr">
                       <a:noFill/>
                     </a:lnL>
@@ -3096,7 +3214,7 @@
                         <a:buNone/>
                       </a:pPr>
                       <a:r>
-                        <a:rPr lang="en-US" sz="780" b="1" dirty="0">
+                        <a:rPr lang="en-US" sz="760" b="1" dirty="0">
                           <a:solidFill>
                             <a:schemeClr val="accent1"/>
                           </a:solidFill>
@@ -3106,7 +3224,7 @@
                         </a:rPr>
                         <a:t>Gerencia de Cumplimiento</a:t>
                       </a:r>
-                      <a:endParaRPr lang="en-US" sz="780" dirty="0">
+                      <a:endParaRPr lang="en-US" sz="760" dirty="0">
                         <a:latin typeface="Calibri" charset="0"/>
                         <a:ea typeface="Calibri" charset="0"/>
                         <a:cs typeface="Calibri" charset="0"/>
@@ -3117,7 +3235,7 @@
                         <a:buNone/>
                       </a:pPr>
                       <a:r>
-                        <a:rPr lang="en-US" sz="780" b="1" dirty="0">
+                        <a:rPr lang="en-US" sz="760" b="1" dirty="0">
                           <a:solidFill>
                             <a:schemeClr val="accent1"/>
                           </a:solidFill>
@@ -3127,14 +3245,14 @@
                         </a:rPr>
                         <a:t>/ Gerencia de Sistemas</a:t>
                       </a:r>
-                      <a:endParaRPr lang="en-US" sz="780" dirty="0">
-                        <a:latin typeface="Calibri" charset="0"/>
-                        <a:ea typeface="Calibri" charset="0"/>
-                        <a:cs typeface="Calibri" charset="0"/>
-                      </a:endParaRPr>
-                    </a:p>
-                  </a:txBody>
-                  <a:tcPr marL="54864" marR="54864" marT="18288" marB="18288" anchor="ctr">
+                      <a:endParaRPr lang="en-US" sz="760" dirty="0">
+                        <a:latin typeface="Calibri" charset="0"/>
+                        <a:ea typeface="Calibri" charset="0"/>
+                        <a:cs typeface="Calibri" charset="0"/>
+                      </a:endParaRPr>
+                    </a:p>
+                  </a:txBody>
+                  <a:tcPr marL="54864" marR="54864" marT="13716" marB="13716" anchor="ctr">
                     <a:lnL w="0" cap="flat" cmpd="sng" algn="ctr">
                       <a:noFill/>
                     </a:lnL>
@@ -3166,24 +3284,24 @@
                         <a:buNone/>
                       </a:pPr>
                       <a:r>
-                        <a:rPr lang="en-US" sz="780" b="1" dirty="0">
-                          <a:solidFill>
-                            <a:schemeClr val="tx1"/>
-                          </a:solidFill>
-                          <a:latin typeface="Calibri" pitchFamily="34" charset="0"/>
-                          <a:ea typeface="Calibri" pitchFamily="34" charset="-122"/>
-                          <a:cs typeface="Calibri" pitchFamily="34" charset="-120"/>
-                        </a:rPr>
-                        <a:t>Deficiencia en la hora del sistema y la herramienta de Monitoreo</a:t>
-                      </a:r>
-                      <a:endParaRPr lang="en-US" sz="780" dirty="0">
-                        <a:latin typeface="Calibri" charset="0"/>
-                        <a:ea typeface="Calibri" charset="0"/>
-                        <a:cs typeface="Calibri" charset="0"/>
-                      </a:endParaRPr>
-                    </a:p>
-                  </a:txBody>
-                  <a:tcPr marL="54864" marR="54864" marT="18288" marB="18288" anchor="ctr">
+                        <a:rPr lang="en-US" sz="760" b="1" dirty="0">
+                          <a:solidFill>
+                            <a:schemeClr val="tx1"/>
+                          </a:solidFill>
+                          <a:latin typeface="Calibri" pitchFamily="34" charset="0"/>
+                          <a:ea typeface="Calibri" pitchFamily="34" charset="-122"/>
+                          <a:cs typeface="Calibri" pitchFamily="34" charset="-120"/>
+                        </a:rPr>
+                        <a:t>B.10  Deficiencia en la hora del sistema y la herramienta de Monitoreo</a:t>
+                      </a:r>
+                      <a:endParaRPr lang="en-US" sz="760" dirty="0">
+                        <a:latin typeface="Calibri" charset="0"/>
+                        <a:ea typeface="Calibri" charset="0"/>
+                        <a:cs typeface="Calibri" charset="0"/>
+                      </a:endParaRPr>
+                    </a:p>
+                  </a:txBody>
+                  <a:tcPr marL="54864" marR="54864" marT="13716" marB="13716" anchor="ctr">
                     <a:lnL w="0" cap="flat" cmpd="sng" algn="ctr">
                       <a:noFill/>
                     </a:lnL>
@@ -3216,7 +3334,7 @@
                         <a:buNone/>
                       </a:pPr>
                       <a:r>
-                        <a:rPr lang="en-US" sz="780" dirty="0">
+                        <a:rPr lang="en-US" sz="760" dirty="0">
                           <a:solidFill>
                             <a:schemeClr val="tx1"/>
                           </a:solidFill>
@@ -3226,35 +3344,35 @@
                         </a:rPr>
                         <a:t>Descargo correos de gestion</a:t>
                       </a:r>
-                      <a:endParaRPr lang="en-US" sz="780" dirty="0">
-                        <a:latin typeface="Calibri" charset="0"/>
-                        <a:ea typeface="Calibri" charset="0"/>
-                        <a:cs typeface="Calibri" charset="0"/>
-                      </a:endParaRPr>
-                    </a:p>
-                    <a:p>
-                      <a:pPr algn="just" indent="0" marL="0">
-                        <a:buNone/>
-                      </a:pPr>
-                      <a:r>
-                        <a:rPr lang="en-US" sz="780" dirty="0">
-                          <a:solidFill>
-                            <a:schemeClr val="tx1"/>
-                          </a:solidFill>
-                          <a:latin typeface="Calibri" pitchFamily="34" charset="0"/>
-                          <a:ea typeface="Calibri" pitchFamily="34" charset="-122"/>
-                          <a:cs typeface="Calibri" pitchFamily="34" charset="-120"/>
-                        </a:rPr>
-                        <a:t>Comentario CA: 14/10/2026 Compromiso</a:t>
-                      </a:r>
-                      <a:endParaRPr lang="en-US" sz="780" dirty="0">
-                        <a:latin typeface="Calibri" charset="0"/>
-                        <a:ea typeface="Calibri" charset="0"/>
-                        <a:cs typeface="Calibri" charset="0"/>
-                      </a:endParaRPr>
-                    </a:p>
-                  </a:txBody>
-                  <a:tcPr marL="54864" marR="54864" marT="18288" marB="18288" anchor="ctr">
+                      <a:endParaRPr lang="en-US" sz="760" dirty="0">
+                        <a:latin typeface="Calibri" charset="0"/>
+                        <a:ea typeface="Calibri" charset="0"/>
+                        <a:cs typeface="Calibri" charset="0"/>
+                      </a:endParaRPr>
+                    </a:p>
+                    <a:p>
+                      <a:pPr algn="just" indent="0" marL="0">
+                        <a:buNone/>
+                      </a:pPr>
+                      <a:r>
+                        <a:rPr lang="en-US" sz="760" dirty="0">
+                          <a:solidFill>
+                            <a:schemeClr val="tx1"/>
+                          </a:solidFill>
+                          <a:latin typeface="Calibri" pitchFamily="34" charset="0"/>
+                          <a:ea typeface="Calibri" pitchFamily="34" charset="-122"/>
+                          <a:cs typeface="Calibri" pitchFamily="34" charset="-120"/>
+                        </a:rPr>
+                        <a:t>Pendiente</a:t>
+                      </a:r>
+                      <a:endParaRPr lang="en-US" sz="760" dirty="0">
+                        <a:latin typeface="Calibri" charset="0"/>
+                        <a:ea typeface="Calibri" charset="0"/>
+                        <a:cs typeface="Calibri" charset="0"/>
+                      </a:endParaRPr>
+                    </a:p>
+                  </a:txBody>
+                  <a:tcPr marL="54864" marR="54864" marT="13716" marB="13716" anchor="ctr">
                     <a:lnL w="0" cap="flat" cmpd="sng" algn="ctr">
                       <a:noFill/>
                     </a:lnL>
@@ -3284,7 +3402,7 @@
                         <a:buNone/>
                       </a:pPr>
                       <a:r>
-                        <a:rPr lang="en-US" sz="780" b="1" dirty="0">
+                        <a:rPr lang="en-US" sz="760" b="1" dirty="0">
                           <a:solidFill>
                             <a:schemeClr val="accent1"/>
                           </a:solidFill>
@@ -3294,14 +3412,14 @@
                         </a:rPr>
                         <a:t>Gerencia de Cumplimiento</a:t>
                       </a:r>
-                      <a:endParaRPr lang="en-US" sz="780" dirty="0">
-                        <a:latin typeface="Calibri" charset="0"/>
-                        <a:ea typeface="Calibri" charset="0"/>
-                        <a:cs typeface="Calibri" charset="0"/>
-                      </a:endParaRPr>
-                    </a:p>
-                  </a:txBody>
-                  <a:tcPr marL="54864" marR="54864" marT="18288" marB="18288" anchor="ctr">
+                      <a:endParaRPr lang="en-US" sz="760" dirty="0">
+                        <a:latin typeface="Calibri" charset="0"/>
+                        <a:ea typeface="Calibri" charset="0"/>
+                        <a:cs typeface="Calibri" charset="0"/>
+                      </a:endParaRPr>
+                    </a:p>
+                  </a:txBody>
+                  <a:tcPr marL="54864" marR="54864" marT="13716" marB="13716" anchor="ctr">
                     <a:lnL w="0" cap="flat" cmpd="sng" algn="ctr">
                       <a:noFill/>
                     </a:lnL>
@@ -3333,24 +3451,24 @@
                         <a:buNone/>
                       </a:pPr>
                       <a:r>
-                        <a:rPr lang="en-US" sz="780" b="1" dirty="0">
-                          <a:solidFill>
-                            <a:schemeClr val="tx1"/>
-                          </a:solidFill>
-                          <a:latin typeface="Calibri" pitchFamily="34" charset="0"/>
-                          <a:ea typeface="Calibri" pitchFamily="34" charset="-122"/>
-                          <a:cs typeface="Calibri" pitchFamily="34" charset="-120"/>
-                        </a:rPr>
-                        <a:t>Verificación de las condiciones en ACRM</a:t>
-                      </a:r>
-                      <a:endParaRPr lang="en-US" sz="780" dirty="0">
-                        <a:latin typeface="Calibri" charset="0"/>
-                        <a:ea typeface="Calibri" charset="0"/>
-                        <a:cs typeface="Calibri" charset="0"/>
-                      </a:endParaRPr>
-                    </a:p>
-                  </a:txBody>
-                  <a:tcPr marL="54864" marR="54864" marT="18288" marB="18288" anchor="ctr">
+                        <a:rPr lang="en-US" sz="760" b="1" dirty="0">
+                          <a:solidFill>
+                            <a:schemeClr val="tx1"/>
+                          </a:solidFill>
+                          <a:latin typeface="Calibri" pitchFamily="34" charset="0"/>
+                          <a:ea typeface="Calibri" pitchFamily="34" charset="-122"/>
+                          <a:cs typeface="Calibri" pitchFamily="34" charset="-120"/>
+                        </a:rPr>
+                        <a:t>B.11  Verificación de las condiciones en ACRM</a:t>
+                      </a:r>
+                      <a:endParaRPr lang="en-US" sz="760" dirty="0">
+                        <a:latin typeface="Calibri" charset="0"/>
+                        <a:ea typeface="Calibri" charset="0"/>
+                        <a:cs typeface="Calibri" charset="0"/>
+                      </a:endParaRPr>
+                    </a:p>
+                  </a:txBody>
+                  <a:tcPr marL="54864" marR="54864" marT="13716" marB="13716" anchor="ctr">
                     <a:lnL w="0" cap="flat" cmpd="sng" algn="ctr">
                       <a:noFill/>
                     </a:lnL>
@@ -3383,7 +3501,7 @@
                         <a:buNone/>
                       </a:pPr>
                       <a:r>
-                        <a:rPr lang="en-US" sz="780" dirty="0">
+                        <a:rPr lang="en-US" sz="760" dirty="0">
                           <a:solidFill>
                             <a:schemeClr val="tx1"/>
                           </a:solidFill>
@@ -3393,35 +3511,35 @@
                         </a:rPr>
                         <a:t>Descargo</a:t>
                       </a:r>
-                      <a:endParaRPr lang="en-US" sz="780" dirty="0">
-                        <a:latin typeface="Calibri" charset="0"/>
-                        <a:ea typeface="Calibri" charset="0"/>
-                        <a:cs typeface="Calibri" charset="0"/>
-                      </a:endParaRPr>
-                    </a:p>
-                    <a:p>
-                      <a:pPr algn="just" indent="0" marL="0">
-                        <a:buNone/>
-                      </a:pPr>
-                      <a:r>
-                        <a:rPr lang="en-US" sz="780" dirty="0">
-                          <a:solidFill>
-                            <a:schemeClr val="tx1"/>
-                          </a:solidFill>
-                          <a:latin typeface="Calibri" pitchFamily="34" charset="0"/>
-                          <a:ea typeface="Calibri" pitchFamily="34" charset="-122"/>
-                          <a:cs typeface="Calibri" pitchFamily="34" charset="-120"/>
-                        </a:rPr>
-                        <a:t>Comentario CA: 14/10/2026 Compromiso</a:t>
-                      </a:r>
-                      <a:endParaRPr lang="en-US" sz="780" dirty="0">
-                        <a:latin typeface="Calibri" charset="0"/>
-                        <a:ea typeface="Calibri" charset="0"/>
-                        <a:cs typeface="Calibri" charset="0"/>
-                      </a:endParaRPr>
-                    </a:p>
-                  </a:txBody>
-                  <a:tcPr marL="54864" marR="54864" marT="18288" marB="18288" anchor="ctr">
+                      <a:endParaRPr lang="en-US" sz="760" dirty="0">
+                        <a:latin typeface="Calibri" charset="0"/>
+                        <a:ea typeface="Calibri" charset="0"/>
+                        <a:cs typeface="Calibri" charset="0"/>
+                      </a:endParaRPr>
+                    </a:p>
+                    <a:p>
+                      <a:pPr algn="just" indent="0" marL="0">
+                        <a:buNone/>
+                      </a:pPr>
+                      <a:r>
+                        <a:rPr lang="en-US" sz="760" dirty="0">
+                          <a:solidFill>
+                            <a:schemeClr val="tx1"/>
+                          </a:solidFill>
+                          <a:latin typeface="Calibri" pitchFamily="34" charset="0"/>
+                          <a:ea typeface="Calibri" pitchFamily="34" charset="-122"/>
+                          <a:cs typeface="Calibri" pitchFamily="34" charset="-120"/>
+                        </a:rPr>
+                        <a:t>Pendiente</a:t>
+                      </a:r>
+                      <a:endParaRPr lang="en-US" sz="760" dirty="0">
+                        <a:latin typeface="Calibri" charset="0"/>
+                        <a:ea typeface="Calibri" charset="0"/>
+                        <a:cs typeface="Calibri" charset="0"/>
+                      </a:endParaRPr>
+                    </a:p>
+                  </a:txBody>
+                  <a:tcPr marL="54864" marR="54864" marT="13716" marB="13716" anchor="ctr">
                     <a:lnL w="0" cap="flat" cmpd="sng" algn="ctr">
                       <a:noFill/>
                     </a:lnL>
@@ -3451,7 +3569,7 @@
                         <a:buNone/>
                       </a:pPr>
                       <a:r>
-                        <a:rPr lang="en-US" sz="780" b="1" dirty="0">
+                        <a:rPr lang="en-US" sz="760" b="1" dirty="0">
                           <a:solidFill>
                             <a:schemeClr val="accent1"/>
                           </a:solidFill>
@@ -3461,14 +3579,14 @@
                         </a:rPr>
                         <a:t>Gerencia de Cumplimiento</a:t>
                       </a:r>
-                      <a:endParaRPr lang="en-US" sz="780" dirty="0">
-                        <a:latin typeface="Calibri" charset="0"/>
-                        <a:ea typeface="Calibri" charset="0"/>
-                        <a:cs typeface="Calibri" charset="0"/>
-                      </a:endParaRPr>
-                    </a:p>
-                  </a:txBody>
-                  <a:tcPr marL="54864" marR="54864" marT="18288" marB="18288" anchor="ctr">
+                      <a:endParaRPr lang="en-US" sz="760" dirty="0">
+                        <a:latin typeface="Calibri" charset="0"/>
+                        <a:ea typeface="Calibri" charset="0"/>
+                        <a:cs typeface="Calibri" charset="0"/>
+                      </a:endParaRPr>
+                    </a:p>
+                  </a:txBody>
+                  <a:tcPr marL="54864" marR="54864" marT="13716" marB="13716" anchor="ctr">
                     <a:lnL w="0" cap="flat" cmpd="sng" algn="ctr">
                       <a:noFill/>
                     </a:lnL>
@@ -3500,24 +3618,24 @@
                         <a:buNone/>
                       </a:pPr>
                       <a:r>
-                        <a:rPr lang="en-US" sz="780" b="1" dirty="0">
-                          <a:solidFill>
-                            <a:schemeClr val="tx1"/>
-                          </a:solidFill>
-                          <a:latin typeface="Calibri" pitchFamily="34" charset="0"/>
-                          <a:ea typeface="Calibri" pitchFamily="34" charset="-122"/>
-                          <a:cs typeface="Calibri" pitchFamily="34" charset="-120"/>
-                        </a:rPr>
-                        <a:t>Limitante de Accesos a los Datos de COMEDICA, alojada en la Herramienta de Monitoreo.</a:t>
-                      </a:r>
-                      <a:endParaRPr lang="en-US" sz="780" dirty="0">
-                        <a:latin typeface="Calibri" charset="0"/>
-                        <a:ea typeface="Calibri" charset="0"/>
-                        <a:cs typeface="Calibri" charset="0"/>
-                      </a:endParaRPr>
-                    </a:p>
-                  </a:txBody>
-                  <a:tcPr marL="54864" marR="54864" marT="18288" marB="18288" anchor="ctr">
+                        <a:rPr lang="en-US" sz="760" b="1" dirty="0">
+                          <a:solidFill>
+                            <a:schemeClr val="tx1"/>
+                          </a:solidFill>
+                          <a:latin typeface="Calibri" pitchFamily="34" charset="0"/>
+                          <a:ea typeface="Calibri" pitchFamily="34" charset="-122"/>
+                          <a:cs typeface="Calibri" pitchFamily="34" charset="-120"/>
+                        </a:rPr>
+                        <a:t>B.12  Limitante de Accesos a los Datos de COMEDICA, alojada en la Herramienta de Monitoreo.</a:t>
+                      </a:r>
+                      <a:endParaRPr lang="en-US" sz="760" dirty="0">
+                        <a:latin typeface="Calibri" charset="0"/>
+                        <a:ea typeface="Calibri" charset="0"/>
+                        <a:cs typeface="Calibri" charset="0"/>
+                      </a:endParaRPr>
+                    </a:p>
+                  </a:txBody>
+                  <a:tcPr marL="54864" marR="54864" marT="13716" marB="13716" anchor="ctr">
                     <a:lnL w="0" cap="flat" cmpd="sng" algn="ctr">
                       <a:noFill/>
                     </a:lnL>
@@ -3550,7 +3668,7 @@
                         <a:buNone/>
                       </a:pPr>
                       <a:r>
-                        <a:rPr lang="en-US" sz="780" dirty="0">
+                        <a:rPr lang="en-US" sz="760" dirty="0">
                           <a:solidFill>
                             <a:schemeClr val="tx1"/>
                           </a:solidFill>
@@ -3560,35 +3678,35 @@
                         </a:rPr>
                         <a:t>Descargo</a:t>
                       </a:r>
-                      <a:endParaRPr lang="en-US" sz="780" dirty="0">
-                        <a:latin typeface="Calibri" charset="0"/>
-                        <a:ea typeface="Calibri" charset="0"/>
-                        <a:cs typeface="Calibri" charset="0"/>
-                      </a:endParaRPr>
-                    </a:p>
-                    <a:p>
-                      <a:pPr algn="just" indent="0" marL="0">
-                        <a:buNone/>
-                      </a:pPr>
-                      <a:r>
-                        <a:rPr lang="en-US" sz="780" dirty="0">
-                          <a:solidFill>
-                            <a:schemeClr val="tx1"/>
-                          </a:solidFill>
-                          <a:latin typeface="Calibri" pitchFamily="34" charset="0"/>
-                          <a:ea typeface="Calibri" pitchFamily="34" charset="-122"/>
-                          <a:cs typeface="Calibri" pitchFamily="34" charset="-120"/>
-                        </a:rPr>
-                        <a:t>Comentario CA: 14/10/2026 Compromiso</a:t>
-                      </a:r>
-                      <a:endParaRPr lang="en-US" sz="780" dirty="0">
-                        <a:latin typeface="Calibri" charset="0"/>
-                        <a:ea typeface="Calibri" charset="0"/>
-                        <a:cs typeface="Calibri" charset="0"/>
-                      </a:endParaRPr>
-                    </a:p>
-                  </a:txBody>
-                  <a:tcPr marL="54864" marR="54864" marT="18288" marB="18288" anchor="ctr">
+                      <a:endParaRPr lang="en-US" sz="760" dirty="0">
+                        <a:latin typeface="Calibri" charset="0"/>
+                        <a:ea typeface="Calibri" charset="0"/>
+                        <a:cs typeface="Calibri" charset="0"/>
+                      </a:endParaRPr>
+                    </a:p>
+                    <a:p>
+                      <a:pPr algn="just" indent="0" marL="0">
+                        <a:buNone/>
+                      </a:pPr>
+                      <a:r>
+                        <a:rPr lang="en-US" sz="760" dirty="0">
+                          <a:solidFill>
+                            <a:schemeClr val="tx1"/>
+                          </a:solidFill>
+                          <a:latin typeface="Calibri" pitchFamily="34" charset="0"/>
+                          <a:ea typeface="Calibri" pitchFamily="34" charset="-122"/>
+                          <a:cs typeface="Calibri" pitchFamily="34" charset="-120"/>
+                        </a:rPr>
+                        <a:t>Pendiente</a:t>
+                      </a:r>
+                      <a:endParaRPr lang="en-US" sz="760" dirty="0">
+                        <a:latin typeface="Calibri" charset="0"/>
+                        <a:ea typeface="Calibri" charset="0"/>
+                        <a:cs typeface="Calibri" charset="0"/>
+                      </a:endParaRPr>
+                    </a:p>
+                  </a:txBody>
+                  <a:tcPr marL="54864" marR="54864" marT="13716" marB="13716" anchor="ctr">
                     <a:lnL w="0" cap="flat" cmpd="sng" algn="ctr">
                       <a:noFill/>
                     </a:lnL>
@@ -3618,7 +3736,7 @@
                         <a:buNone/>
                       </a:pPr>
                       <a:r>
-                        <a:rPr lang="en-US" sz="780" b="1" dirty="0">
+                        <a:rPr lang="en-US" sz="760" b="1" dirty="0">
                           <a:solidFill>
                             <a:schemeClr val="accent1"/>
                           </a:solidFill>
@@ -3628,7 +3746,7 @@
                         </a:rPr>
                         <a:t>Gerencia de Cumplimiento</a:t>
                       </a:r>
-                      <a:endParaRPr lang="en-US" sz="780" dirty="0">
+                      <a:endParaRPr lang="en-US" sz="760" dirty="0">
                         <a:latin typeface="Calibri" charset="0"/>
                         <a:ea typeface="Calibri" charset="0"/>
                         <a:cs typeface="Calibri" charset="0"/>
@@ -3639,7 +3757,7 @@
                         <a:buNone/>
                       </a:pPr>
                       <a:r>
-                        <a:rPr lang="en-US" sz="780" b="1" dirty="0">
+                        <a:rPr lang="en-US" sz="760" b="1" dirty="0">
                           <a:solidFill>
                             <a:schemeClr val="accent1"/>
                           </a:solidFill>
@@ -3649,14 +3767,14 @@
                         </a:rPr>
                         <a:t>/ Seguridad de la información</a:t>
                       </a:r>
-                      <a:endParaRPr lang="en-US" sz="780" dirty="0">
-                        <a:latin typeface="Calibri" charset="0"/>
-                        <a:ea typeface="Calibri" charset="0"/>
-                        <a:cs typeface="Calibri" charset="0"/>
-                      </a:endParaRPr>
-                    </a:p>
-                  </a:txBody>
-                  <a:tcPr marL="54864" marR="54864" marT="18288" marB="18288" anchor="ctr">
+                      <a:endParaRPr lang="en-US" sz="760" dirty="0">
+                        <a:latin typeface="Calibri" charset="0"/>
+                        <a:ea typeface="Calibri" charset="0"/>
+                        <a:cs typeface="Calibri" charset="0"/>
+                      </a:endParaRPr>
+                    </a:p>
+                  </a:txBody>
+                  <a:tcPr marL="54864" marR="54864" marT="13716" marB="13716" anchor="ctr">
                     <a:lnL w="0" cap="flat" cmpd="sng" algn="ctr">
                       <a:noFill/>
                     </a:lnL>
@@ -3688,24 +3806,24 @@
                         <a:buNone/>
                       </a:pPr>
                       <a:r>
-                        <a:rPr lang="en-US" sz="780" b="1" dirty="0">
-                          <a:solidFill>
-                            <a:schemeClr val="tx1"/>
-                          </a:solidFill>
-                          <a:latin typeface="Calibri" pitchFamily="34" charset="0"/>
-                          <a:ea typeface="Calibri" pitchFamily="34" charset="-122"/>
-                          <a:cs typeface="Calibri" pitchFamily="34" charset="-120"/>
-                        </a:rPr>
-                        <a:t>Limitante para identificar la base de datos de CRM</a:t>
-                      </a:r>
-                      <a:endParaRPr lang="en-US" sz="780" dirty="0">
-                        <a:latin typeface="Calibri" charset="0"/>
-                        <a:ea typeface="Calibri" charset="0"/>
-                        <a:cs typeface="Calibri" charset="0"/>
-                      </a:endParaRPr>
-                    </a:p>
-                  </a:txBody>
-                  <a:tcPr marL="54864" marR="54864" marT="18288" marB="18288" anchor="ctr">
+                        <a:rPr lang="en-US" sz="760" b="1" dirty="0">
+                          <a:solidFill>
+                            <a:schemeClr val="tx1"/>
+                          </a:solidFill>
+                          <a:latin typeface="Calibri" pitchFamily="34" charset="0"/>
+                          <a:ea typeface="Calibri" pitchFamily="34" charset="-122"/>
+                          <a:cs typeface="Calibri" pitchFamily="34" charset="-120"/>
+                        </a:rPr>
+                        <a:t>B.13  Limitante para identificar la base de datos de CRM</a:t>
+                      </a:r>
+                      <a:endParaRPr lang="en-US" sz="760" dirty="0">
+                        <a:latin typeface="Calibri" charset="0"/>
+                        <a:ea typeface="Calibri" charset="0"/>
+                        <a:cs typeface="Calibri" charset="0"/>
+                      </a:endParaRPr>
+                    </a:p>
+                  </a:txBody>
+                  <a:tcPr marL="54864" marR="54864" marT="13716" marB="13716" anchor="ctr">
                     <a:lnL w="0" cap="flat" cmpd="sng" algn="ctr">
                       <a:noFill/>
                     </a:lnL>
@@ -3738,24 +3856,24 @@
                         <a:buNone/>
                       </a:pPr>
                       <a:r>
-                        <a:rPr lang="en-US" sz="780" dirty="0">
-                          <a:solidFill>
-                            <a:schemeClr val="tx1"/>
-                          </a:solidFill>
-                          <a:latin typeface="Calibri" pitchFamily="34" charset="0"/>
-                          <a:ea typeface="Calibri" pitchFamily="34" charset="-122"/>
-                          <a:cs typeface="Calibri" pitchFamily="34" charset="-120"/>
-                        </a:rPr>
-                        <a:t>Comentario CA: 14/10/2026 Compromiso</a:t>
-                      </a:r>
-                      <a:endParaRPr lang="en-US" sz="780" dirty="0">
-                        <a:latin typeface="Calibri" charset="0"/>
-                        <a:ea typeface="Calibri" charset="0"/>
-                        <a:cs typeface="Calibri" charset="0"/>
-                      </a:endParaRPr>
-                    </a:p>
-                  </a:txBody>
-                  <a:tcPr marL="54864" marR="54864" marT="18288" marB="18288" anchor="ctr">
+                        <a:rPr lang="en-US" sz="760" dirty="0">
+                          <a:solidFill>
+                            <a:schemeClr val="tx1"/>
+                          </a:solidFill>
+                          <a:latin typeface="Calibri" pitchFamily="34" charset="0"/>
+                          <a:ea typeface="Calibri" pitchFamily="34" charset="-122"/>
+                          <a:cs typeface="Calibri" pitchFamily="34" charset="-120"/>
+                        </a:rPr>
+                        <a:t>Pendiente</a:t>
+                      </a:r>
+                      <a:endParaRPr lang="en-US" sz="760" dirty="0">
+                        <a:latin typeface="Calibri" charset="0"/>
+                        <a:ea typeface="Calibri" charset="0"/>
+                        <a:cs typeface="Calibri" charset="0"/>
+                      </a:endParaRPr>
+                    </a:p>
+                  </a:txBody>
+                  <a:tcPr marL="54864" marR="54864" marT="13716" marB="13716" anchor="ctr">
                     <a:lnL w="0" cap="flat" cmpd="sng" algn="ctr">
                       <a:noFill/>
                     </a:lnL>
@@ -3785,7 +3903,7 @@
                         <a:buNone/>
                       </a:pPr>
                       <a:r>
-                        <a:rPr lang="en-US" sz="780" b="1" dirty="0">
+                        <a:rPr lang="en-US" sz="760" b="1" dirty="0">
                           <a:solidFill>
                             <a:schemeClr val="accent1"/>
                           </a:solidFill>
@@ -3795,7 +3913,7 @@
                         </a:rPr>
                         <a:t>Gerencia de Cumplimiento</a:t>
                       </a:r>
-                      <a:endParaRPr lang="en-US" sz="780" dirty="0">
+                      <a:endParaRPr lang="en-US" sz="760" dirty="0">
                         <a:latin typeface="Calibri" charset="0"/>
                         <a:ea typeface="Calibri" charset="0"/>
                         <a:cs typeface="Calibri" charset="0"/>
@@ -3806,7 +3924,7 @@
                         <a:buNone/>
                       </a:pPr>
                       <a:r>
-                        <a:rPr lang="en-US" sz="780" b="1" dirty="0">
+                        <a:rPr lang="en-US" sz="760" b="1" dirty="0">
                           <a:solidFill>
                             <a:schemeClr val="accent1"/>
                           </a:solidFill>
@@ -3816,14 +3934,14 @@
                         </a:rPr>
                         <a:t>/ Seguridad de la información</a:t>
                       </a:r>
-                      <a:endParaRPr lang="en-US" sz="780" dirty="0">
-                        <a:latin typeface="Calibri" charset="0"/>
-                        <a:ea typeface="Calibri" charset="0"/>
-                        <a:cs typeface="Calibri" charset="0"/>
-                      </a:endParaRPr>
-                    </a:p>
-                  </a:txBody>
-                  <a:tcPr marL="54864" marR="54864" marT="18288" marB="18288" anchor="ctr">
+                      <a:endParaRPr lang="en-US" sz="760" dirty="0">
+                        <a:latin typeface="Calibri" charset="0"/>
+                        <a:ea typeface="Calibri" charset="0"/>
+                        <a:cs typeface="Calibri" charset="0"/>
+                      </a:endParaRPr>
+                    </a:p>
+                  </a:txBody>
+                  <a:tcPr marL="54864" marR="54864" marT="13716" marB="13716" anchor="ctr">
                     <a:lnL w="0" cap="flat" cmpd="sng" algn="ctr">
                       <a:noFill/>
                     </a:lnL>
@@ -3855,24 +3973,24 @@
                         <a:buNone/>
                       </a:pPr>
                       <a:r>
-                        <a:rPr lang="en-US" sz="780" b="1" dirty="0">
-                          <a:solidFill>
-                            <a:schemeClr val="tx1"/>
-                          </a:solidFill>
-                          <a:latin typeface="Calibri" pitchFamily="34" charset="0"/>
-                          <a:ea typeface="Calibri" pitchFamily="34" charset="-122"/>
-                          <a:cs typeface="Calibri" pitchFamily="34" charset="-120"/>
-                        </a:rPr>
-                        <a:t>Falta de documentación que dé cumplimiento a lo requerido por el artículo 22 de la NRP-23 correspondiente a la adquisición del sistema CRM.</a:t>
-                      </a:r>
-                      <a:endParaRPr lang="en-US" sz="780" dirty="0">
-                        <a:latin typeface="Calibri" charset="0"/>
-                        <a:ea typeface="Calibri" charset="0"/>
-                        <a:cs typeface="Calibri" charset="0"/>
-                      </a:endParaRPr>
-                    </a:p>
-                  </a:txBody>
-                  <a:tcPr marL="54864" marR="54864" marT="18288" marB="18288" anchor="ctr">
+                        <a:rPr lang="en-US" sz="760" b="1" dirty="0">
+                          <a:solidFill>
+                            <a:schemeClr val="tx1"/>
+                          </a:solidFill>
+                          <a:latin typeface="Calibri" pitchFamily="34" charset="0"/>
+                          <a:ea typeface="Calibri" pitchFamily="34" charset="-122"/>
+                          <a:cs typeface="Calibri" pitchFamily="34" charset="-120"/>
+                        </a:rPr>
+                        <a:t>B.14  Falta de documentación que dé cumplimiento a lo requerido por el artículo 22 de la NRP-23 correspondiente a la adquisición del sistema CRM.</a:t>
+                      </a:r>
+                      <a:endParaRPr lang="en-US" sz="760" dirty="0">
+                        <a:latin typeface="Calibri" charset="0"/>
+                        <a:ea typeface="Calibri" charset="0"/>
+                        <a:cs typeface="Calibri" charset="0"/>
+                      </a:endParaRPr>
+                    </a:p>
+                  </a:txBody>
+                  <a:tcPr marL="54864" marR="54864" marT="13716" marB="13716" anchor="ctr">
                     <a:lnL w="0" cap="flat" cmpd="sng" algn="ctr">
                       <a:noFill/>
                     </a:lnL>
@@ -3905,7 +4023,7 @@
                         <a:buNone/>
                       </a:pPr>
                       <a:r>
-                        <a:rPr lang="en-US" sz="780" dirty="0">
+                        <a:rPr lang="en-US" sz="760" dirty="0">
                           <a:solidFill>
                             <a:schemeClr val="tx1"/>
                           </a:solidFill>
@@ -3915,35 +4033,35 @@
                         </a:rPr>
                         <a:t>Descargo</a:t>
                       </a:r>
-                      <a:endParaRPr lang="en-US" sz="780" dirty="0">
-                        <a:latin typeface="Calibri" charset="0"/>
-                        <a:ea typeface="Calibri" charset="0"/>
-                        <a:cs typeface="Calibri" charset="0"/>
-                      </a:endParaRPr>
-                    </a:p>
-                    <a:p>
-                      <a:pPr algn="just" indent="0" marL="0">
-                        <a:buNone/>
-                      </a:pPr>
-                      <a:r>
-                        <a:rPr lang="en-US" sz="780" dirty="0">
-                          <a:solidFill>
-                            <a:schemeClr val="tx1"/>
-                          </a:solidFill>
-                          <a:latin typeface="Calibri" pitchFamily="34" charset="0"/>
-                          <a:ea typeface="Calibri" pitchFamily="34" charset="-122"/>
-                          <a:cs typeface="Calibri" pitchFamily="34" charset="-120"/>
-                        </a:rPr>
-                        <a:t>Comentario CA: 14/10/2026 Compromiso</a:t>
-                      </a:r>
-                      <a:endParaRPr lang="en-US" sz="780" dirty="0">
-                        <a:latin typeface="Calibri" charset="0"/>
-                        <a:ea typeface="Calibri" charset="0"/>
-                        <a:cs typeface="Calibri" charset="0"/>
-                      </a:endParaRPr>
-                    </a:p>
-                  </a:txBody>
-                  <a:tcPr marL="54864" marR="54864" marT="18288" marB="18288" anchor="ctr">
+                      <a:endParaRPr lang="en-US" sz="760" dirty="0">
+                        <a:latin typeface="Calibri" charset="0"/>
+                        <a:ea typeface="Calibri" charset="0"/>
+                        <a:cs typeface="Calibri" charset="0"/>
+                      </a:endParaRPr>
+                    </a:p>
+                    <a:p>
+                      <a:pPr algn="just" indent="0" marL="0">
+                        <a:buNone/>
+                      </a:pPr>
+                      <a:r>
+                        <a:rPr lang="en-US" sz="760" dirty="0">
+                          <a:solidFill>
+                            <a:schemeClr val="tx1"/>
+                          </a:solidFill>
+                          <a:latin typeface="Calibri" pitchFamily="34" charset="0"/>
+                          <a:ea typeface="Calibri" pitchFamily="34" charset="-122"/>
+                          <a:cs typeface="Calibri" pitchFamily="34" charset="-120"/>
+                        </a:rPr>
+                        <a:t>Pendiente</a:t>
+                      </a:r>
+                      <a:endParaRPr lang="en-US" sz="760" dirty="0">
+                        <a:latin typeface="Calibri" charset="0"/>
+                        <a:ea typeface="Calibri" charset="0"/>
+                        <a:cs typeface="Calibri" charset="0"/>
+                      </a:endParaRPr>
+                    </a:p>
+                  </a:txBody>
+                  <a:tcPr marL="54864" marR="54864" marT="13716" marB="13716" anchor="ctr">
                     <a:lnL w="0" cap="flat" cmpd="sng" algn="ctr">
                       <a:noFill/>
                     </a:lnL>
@@ -3973,7 +4091,7 @@
                         <a:buNone/>
                       </a:pPr>
                       <a:r>
-                        <a:rPr lang="en-US" sz="780" b="1" dirty="0">
+                        <a:rPr lang="en-US" sz="760" b="1" dirty="0">
                           <a:solidFill>
                             <a:schemeClr val="accent1"/>
                           </a:solidFill>
@@ -3983,7 +4101,7 @@
                         </a:rPr>
                         <a:t>Gerencia de Cumplimiento</a:t>
                       </a:r>
-                      <a:endParaRPr lang="en-US" sz="780" dirty="0">
+                      <a:endParaRPr lang="en-US" sz="760" dirty="0">
                         <a:latin typeface="Calibri" charset="0"/>
                         <a:ea typeface="Calibri" charset="0"/>
                         <a:cs typeface="Calibri" charset="0"/>
@@ -3994,7 +4112,7 @@
                         <a:buNone/>
                       </a:pPr>
                       <a:r>
-                        <a:rPr lang="en-US" sz="780" b="1" dirty="0">
+                        <a:rPr lang="en-US" sz="760" b="1" dirty="0">
                           <a:solidFill>
                             <a:schemeClr val="accent1"/>
                           </a:solidFill>
@@ -4004,14 +4122,14 @@
                         </a:rPr>
                         <a:t>/Seguridad de la Información</a:t>
                       </a:r>
-                      <a:endParaRPr lang="en-US" sz="780" dirty="0">
-                        <a:latin typeface="Calibri" charset="0"/>
-                        <a:ea typeface="Calibri" charset="0"/>
-                        <a:cs typeface="Calibri" charset="0"/>
-                      </a:endParaRPr>
-                    </a:p>
-                  </a:txBody>
-                  <a:tcPr marL="54864" marR="54864" marT="18288" marB="18288" anchor="ctr">
+                      <a:endParaRPr lang="en-US" sz="760" dirty="0">
+                        <a:latin typeface="Calibri" charset="0"/>
+                        <a:ea typeface="Calibri" charset="0"/>
+                        <a:cs typeface="Calibri" charset="0"/>
+                      </a:endParaRPr>
+                    </a:p>
+                  </a:txBody>
+                  <a:tcPr marL="54864" marR="54864" marT="13716" marB="13716" anchor="ctr">
                     <a:lnL w="0" cap="flat" cmpd="sng" algn="ctr">
                       <a:noFill/>
                     </a:lnL>
@@ -4043,24 +4161,24 @@
                         <a:buNone/>
                       </a:pPr>
                       <a:r>
-                        <a:rPr lang="en-US" sz="780" b="1" dirty="0">
-                          <a:solidFill>
-                            <a:schemeClr val="tx1"/>
-                          </a:solidFill>
-                          <a:latin typeface="Calibri" pitchFamily="34" charset="0"/>
-                          <a:ea typeface="Calibri" pitchFamily="34" charset="-122"/>
-                          <a:cs typeface="Calibri" pitchFamily="34" charset="-120"/>
-                        </a:rPr>
-                        <a:t>Servicios tercerizados</a:t>
-                      </a:r>
-                      <a:endParaRPr lang="en-US" sz="780" dirty="0">
-                        <a:latin typeface="Calibri" charset="0"/>
-                        <a:ea typeface="Calibri" charset="0"/>
-                        <a:cs typeface="Calibri" charset="0"/>
-                      </a:endParaRPr>
-                    </a:p>
-                  </a:txBody>
-                  <a:tcPr marL="54864" marR="54864" marT="18288" marB="18288" anchor="ctr">
+                        <a:rPr lang="en-US" sz="760" b="1" dirty="0">
+                          <a:solidFill>
+                            <a:schemeClr val="tx1"/>
+                          </a:solidFill>
+                          <a:latin typeface="Calibri" pitchFamily="34" charset="0"/>
+                          <a:ea typeface="Calibri" pitchFamily="34" charset="-122"/>
+                          <a:cs typeface="Calibri" pitchFamily="34" charset="-120"/>
+                        </a:rPr>
+                        <a:t>B.15  Servicios tercerizados</a:t>
+                      </a:r>
+                      <a:endParaRPr lang="en-US" sz="760" dirty="0">
+                        <a:latin typeface="Calibri" charset="0"/>
+                        <a:ea typeface="Calibri" charset="0"/>
+                        <a:cs typeface="Calibri" charset="0"/>
+                      </a:endParaRPr>
+                    </a:p>
+                  </a:txBody>
+                  <a:tcPr marL="54864" marR="54864" marT="13716" marB="13716" anchor="ctr">
                     <a:lnL w="0" cap="flat" cmpd="sng" algn="ctr">
                       <a:noFill/>
                     </a:lnL>
@@ -4093,7 +4211,7 @@
                         <a:buNone/>
                       </a:pPr>
                       <a:r>
-                        <a:rPr lang="en-US" sz="780" dirty="0">
+                        <a:rPr lang="en-US" sz="760" dirty="0">
                           <a:solidFill>
                             <a:schemeClr val="tx1"/>
                           </a:solidFill>
@@ -4103,39 +4221,39 @@
                         </a:rPr>
                         <a:t>Plan de acción:</a:t>
                       </a:r>
-                      <a:endParaRPr lang="en-US" sz="780" dirty="0">
-                        <a:latin typeface="Calibri" charset="0"/>
-                        <a:ea typeface="Calibri" charset="0"/>
-                        <a:cs typeface="Calibri" charset="0"/>
-                      </a:endParaRPr>
-                    </a:p>
-                    <a:p>
-                      <a:pPr algn="just" indent="0" marL="0">
-                        <a:buNone/>
-                      </a:pPr>
-                      <a:r>
-                        <a:rPr lang="en-US" sz="780" dirty="0">
-                          <a:solidFill>
-                            <a:schemeClr val="tx1"/>
-                          </a:solidFill>
-                          <a:latin typeface="Calibri" pitchFamily="34" charset="0"/>
-                          <a:ea typeface="Calibri" pitchFamily="34" charset="-122"/>
-                          <a:cs typeface="Calibri" pitchFamily="34" charset="-120"/>
-                        </a:rPr>
-                        <a:t>Comentario CA: 14/10/2026 Compromiso</a:t>
-                      </a:r>
-                      <a:endParaRPr lang="en-US" sz="780" dirty="0">
-                        <a:latin typeface="Calibri" charset="0"/>
-                        <a:ea typeface="Calibri" charset="0"/>
-                        <a:cs typeface="Calibri" charset="0"/>
-                      </a:endParaRPr>
-                    </a:p>
-                    <a:p>
-                      <a:pPr algn="just" indent="0" marL="0">
-                        <a:buNone/>
-                      </a:pPr>
-                      <a:r>
-                        <a:rPr lang="en-US" sz="780" dirty="0">
+                      <a:endParaRPr lang="en-US" sz="760" dirty="0">
+                        <a:latin typeface="Calibri" charset="0"/>
+                        <a:ea typeface="Calibri" charset="0"/>
+                        <a:cs typeface="Calibri" charset="0"/>
+                      </a:endParaRPr>
+                    </a:p>
+                    <a:p>
+                      <a:pPr algn="just" indent="0" marL="0">
+                        <a:buNone/>
+                      </a:pPr>
+                      <a:r>
+                        <a:rPr lang="en-US" sz="760" dirty="0">
+                          <a:solidFill>
+                            <a:schemeClr val="tx1"/>
+                          </a:solidFill>
+                          <a:latin typeface="Calibri" pitchFamily="34" charset="0"/>
+                          <a:ea typeface="Calibri" pitchFamily="34" charset="-122"/>
+                          <a:cs typeface="Calibri" pitchFamily="34" charset="-120"/>
+                        </a:rPr>
+                        <a:t>Pendiente</a:t>
+                      </a:r>
+                      <a:endParaRPr lang="en-US" sz="760" dirty="0">
+                        <a:latin typeface="Calibri" charset="0"/>
+                        <a:ea typeface="Calibri" charset="0"/>
+                        <a:cs typeface="Calibri" charset="0"/>
+                      </a:endParaRPr>
+                    </a:p>
+                    <a:p>
+                      <a:pPr algn="just" indent="0" marL="0">
+                        <a:buNone/>
+                      </a:pPr>
+                      <a:r>
+                        <a:rPr lang="en-US" sz="760" dirty="0">
                           <a:solidFill>
                             <a:schemeClr val="tx1"/>
                           </a:solidFill>
@@ -4145,18 +4263,18 @@
                         </a:rPr>
                         <a:t>Comentario Licda. Bonilla: Como parte del fortalecimiento de los controles de seguridad asociados al servicio tercerizado del módulo ACRM, la Unidad de Seguridad de la Información y Ciberseguridad realizará una reevaluación de los riesgos de seguridad de la información y ciberseguridad, mediante la actualización de la matriz de riesgos y la revisión de los controles existentes, con el propósito de identificar oportunidades de mejora y definir las medidas adicionales de tratamiento que correspondan, en coordinación con el área responsable de la solución el proveedor.</a:t>
                       </a:r>
-                      <a:endParaRPr lang="en-US" sz="780" dirty="0">
-                        <a:latin typeface="Calibri" charset="0"/>
-                        <a:ea typeface="Calibri" charset="0"/>
-                        <a:cs typeface="Calibri" charset="0"/>
-                      </a:endParaRPr>
-                    </a:p>
-                    <a:p>
-                      <a:pPr algn="just" indent="0" marL="0">
-                        <a:buNone/>
-                      </a:pPr>
-                      <a:r>
-                        <a:rPr lang="en-US" sz="780" dirty="0">
+                      <a:endParaRPr lang="en-US" sz="760" dirty="0">
+                        <a:latin typeface="Calibri" charset="0"/>
+                        <a:ea typeface="Calibri" charset="0"/>
+                        <a:cs typeface="Calibri" charset="0"/>
+                      </a:endParaRPr>
+                    </a:p>
+                    <a:p>
+                      <a:pPr algn="just" indent="0" marL="0">
+                        <a:buNone/>
+                      </a:pPr>
+                      <a:r>
+                        <a:rPr lang="en-US" sz="760" dirty="0">
                           <a:solidFill>
                             <a:schemeClr val="tx1"/>
                           </a:solidFill>
@@ -4166,14 +4284,14 @@
                         </a:rPr>
                         <a:t>Fecha de cumplimiento: 30 de noviembre de 2026.</a:t>
                       </a:r>
-                      <a:endParaRPr lang="en-US" sz="780" dirty="0">
-                        <a:latin typeface="Calibri" charset="0"/>
-                        <a:ea typeface="Calibri" charset="0"/>
-                        <a:cs typeface="Calibri" charset="0"/>
-                      </a:endParaRPr>
-                    </a:p>
-                  </a:txBody>
-                  <a:tcPr marL="54864" marR="54864" marT="18288" marB="18288" anchor="ctr">
+                      <a:endParaRPr lang="en-US" sz="760" dirty="0">
+                        <a:latin typeface="Calibri" charset="0"/>
+                        <a:ea typeface="Calibri" charset="0"/>
+                        <a:cs typeface="Calibri" charset="0"/>
+                      </a:endParaRPr>
+                    </a:p>
+                  </a:txBody>
+                  <a:tcPr marL="54864" marR="54864" marT="13716" marB="13716" anchor="ctr">
                     <a:lnL w="0" cap="flat" cmpd="sng" algn="ctr">
                       <a:noFill/>
                     </a:lnL>
@@ -4203,7 +4321,7 @@
                         <a:buNone/>
                       </a:pPr>
                       <a:r>
-                        <a:rPr lang="en-US" sz="780" b="1" dirty="0">
+                        <a:rPr lang="en-US" sz="760" b="1" dirty="0">
                           <a:solidFill>
                             <a:schemeClr val="accent1"/>
                           </a:solidFill>
@@ -4213,7 +4331,7 @@
                         </a:rPr>
                         <a:t>Gerencia de Cumplimiento</a:t>
                       </a:r>
-                      <a:endParaRPr lang="en-US" sz="780" dirty="0">
+                      <a:endParaRPr lang="en-US" sz="760" dirty="0">
                         <a:latin typeface="Calibri" charset="0"/>
                         <a:ea typeface="Calibri" charset="0"/>
                         <a:cs typeface="Calibri" charset="0"/>
@@ -4224,7 +4342,7 @@
                         <a:buNone/>
                       </a:pPr>
                       <a:r>
-                        <a:rPr lang="en-US" sz="780" b="1" dirty="0">
+                        <a:rPr lang="en-US" sz="760" b="1" dirty="0">
                           <a:solidFill>
                             <a:schemeClr val="accent1"/>
                           </a:solidFill>
@@ -4234,14 +4352,14 @@
                         </a:rPr>
                         <a:t>/ Seguridad de la Información</a:t>
                       </a:r>
-                      <a:endParaRPr lang="en-US" sz="780" dirty="0">
-                        <a:latin typeface="Calibri" charset="0"/>
-                        <a:ea typeface="Calibri" charset="0"/>
-                        <a:cs typeface="Calibri" charset="0"/>
-                      </a:endParaRPr>
-                    </a:p>
-                  </a:txBody>
-                  <a:tcPr marL="54864" marR="54864" marT="18288" marB="18288" anchor="ctr">
+                      <a:endParaRPr lang="en-US" sz="760" dirty="0">
+                        <a:latin typeface="Calibri" charset="0"/>
+                        <a:ea typeface="Calibri" charset="0"/>
+                        <a:cs typeface="Calibri" charset="0"/>
+                      </a:endParaRPr>
+                    </a:p>
+                  </a:txBody>
+                  <a:tcPr marL="54864" marR="54864" marT="13716" marB="13716" anchor="ctr">
                     <a:lnL w="0" cap="flat" cmpd="sng" algn="ctr">
                       <a:noFill/>
                     </a:lnL>
@@ -4327,7 +4445,7 @@
                 <a:ea typeface="Cambria" pitchFamily="34" charset="-122"/>
                 <a:cs typeface="Cambria" pitchFamily="34" charset="-120"/>
               </a:rPr>
-              <a:t>Matriz de requerimientos DS-SABAO-BCS-BC-23486</a:t>
+              <a:t>Matriz de requerimientos DS-SABAO-BCS-BC-23486 · Gestión de Riesgo Específico</a:t>
             </a:r>
             <a:endParaRPr lang="en-US" sz="2000" dirty="0"/>
           </a:p>
@@ -4478,28 +4596,7 @@
                           <a:ea typeface="Calibri" pitchFamily="34" charset="-122"/>
                           <a:cs typeface="Calibri" pitchFamily="34" charset="-120"/>
                         </a:rPr>
-                        <a:t>Funcionario</a:t>
-                      </a:r>
-                      <a:endParaRPr lang="en-US" sz="900" dirty="0">
-                        <a:latin typeface="Calibri" charset="0"/>
-                        <a:ea typeface="Calibri" charset="0"/>
-                        <a:cs typeface="Calibri" charset="0"/>
-                      </a:endParaRPr>
-                    </a:p>
-                    <a:p>
-                      <a:pPr algn="just" indent="0" marL="0">
-                        <a:buNone/>
-                      </a:pPr>
-                      <a:r>
-                        <a:rPr lang="en-US" sz="900" b="1" dirty="0">
-                          <a:solidFill>
-                            <a:schemeClr val="bg1"/>
-                          </a:solidFill>
-                          <a:latin typeface="Calibri" pitchFamily="34" charset="0"/>
-                          <a:ea typeface="Calibri" pitchFamily="34" charset="-122"/>
-                          <a:cs typeface="Calibri" pitchFamily="34" charset="-120"/>
-                        </a:rPr>
-                        <a:t>Responsable</a:t>
+                        <a:t>Funcionario Responsable</a:t>
                       </a:r>
                       <a:endParaRPr lang="en-US" sz="900" dirty="0">
                         <a:latin typeface="Calibri" charset="0"/>

</xml_diff>

<commit_message>
Matrix 23486: teal color for section A to differ from table header
Co-Authored-By: Claude Opus 5.5 <noreply@anthropic.com>
Claude-Session: https://claude.ai/code/session_01F1WXR13Nv8neEtLhaK3ELa
</commit_message>
<xml_diff>
--- a/supervision-gobierno-corporativo/Matriz_Requerimientos_DS-SABAO-BCS-BC-23486.pptx
+++ b/supervision-gobierno-corporativo/Matriz_Requerimientos_DS-SABAO-BCS-BC-23486.pptx
@@ -1423,7 +1423,7 @@
                       <a:tailEnd type="none" w="med" len="med"/>
                     </a:lnB>
                     <a:solidFill>
-                      <a:schemeClr val="accent1"/>
+                      <a:srgbClr val="0E7490"/>
                     </a:solidFill>
                   </a:tcPr>
                 </a:tc>
@@ -1446,7 +1446,7 @@
                       <a:r>
                         <a:rPr lang="en-US" sz="1100" b="1" dirty="0">
                           <a:solidFill>
-                            <a:schemeClr val="accent1"/>
+                            <a:srgbClr val="0E7490"/>
                           </a:solidFill>
                           <a:latin typeface="Calibri" pitchFamily="34" charset="0"/>
                           <a:ea typeface="Calibri" pitchFamily="34" charset="-122"/>
@@ -1603,7 +1603,7 @@
                       <a:r>
                         <a:rPr lang="en-US" sz="1100" b="1" dirty="0">
                           <a:solidFill>
-                            <a:schemeClr val="accent1"/>
+                            <a:srgbClr val="0E7490"/>
                           </a:solidFill>
                           <a:latin typeface="Calibri" pitchFamily="34" charset="0"/>
                           <a:ea typeface="Calibri" pitchFamily="34" charset="-122"/>

</xml_diff>

<commit_message>
Add card-style deck for matrix 23486 matching GC supervision design
Co-Authored-By: Claude Opus 5.5 <noreply@anthropic.com>
Claude-Session: https://claude.ai/code/session_01F1WXR13Nv8neEtLhaK3ELa
</commit_message>
<xml_diff>
--- a/supervision-gobierno-corporativo/Matriz_Requerimientos_DS-SABAO-BCS-BC-23486.pptx
+++ b/supervision-gobierno-corporativo/Matriz_Requerimientos_DS-SABAO-BCS-BC-23486.pptx
@@ -1502,14 +1502,14 @@
           <p:nvPr>
             <p:extLst>
               <p:ext uri="{D42A27DB-BD31-4B8C-83A1-F6EECF244321}">
-                <p14:modId xmlns:p14="http://schemas.microsoft.com/office/powerpoint/2010/main" val="1522017504"/>
+                <p14:modId xmlns:p14="http://schemas.microsoft.com/office/powerpoint/2010/main" val="3879619768"/>
               </p:ext>
             </p:extLst>
           </p:nvPr>
         </p:nvGraphicFramePr>
         <p:xfrm>
           <a:off x="44116" y="1569069"/>
-          <a:ext cx="12103768" cy="5209032"/>
+          <a:ext cx="12103768" cy="5173964"/>
         </p:xfrm>
         <a:graphic>
           <a:graphicData uri="http://schemas.openxmlformats.org/drawingml/2006/table">
@@ -3455,18 +3455,18 @@
                           <a:ea typeface="Calibri" pitchFamily="34" charset="-122"/>
                           <a:cs typeface="Arial" panose="020B0604020202020204" pitchFamily="34" charset="0"/>
                         </a:rPr>
-                        <a:t>Descargo correos de </a:t>
-                      </a:r>
-                      <a:r>
-                        <a:rPr lang="es-SV" sz="800" noProof="0" dirty="0" err="1">
-                          <a:solidFill>
-                            <a:schemeClr val="tx1"/>
-                          </a:solidFill>
-                          <a:latin typeface="Arial" panose="020B0604020202020204" pitchFamily="34" charset="0"/>
-                          <a:ea typeface="Calibri" pitchFamily="34" charset="-122"/>
-                          <a:cs typeface="Arial" panose="020B0604020202020204" pitchFamily="34" charset="0"/>
-                        </a:rPr>
-                        <a:t>gestion</a:t>
+                        <a:t>Descargo correos </a:t>
+                      </a:r>
+                      <a:r>
+                        <a:rPr lang="es-SV" sz="800" noProof="0">
+                          <a:solidFill>
+                            <a:schemeClr val="tx1"/>
+                          </a:solidFill>
+                          <a:latin typeface="Arial" panose="020B0604020202020204" pitchFamily="34" charset="0"/>
+                          <a:ea typeface="Calibri" pitchFamily="34" charset="-122"/>
+                          <a:cs typeface="Arial" panose="020B0604020202020204" pitchFamily="34" charset="0"/>
+                        </a:rPr>
+                        <a:t>de gestión</a:t>
                       </a:r>
                       <a:endParaRPr lang="es-SV" sz="800" noProof="0" dirty="0">
                         <a:solidFill>
@@ -3662,30 +3662,6 @@
                           <a:ea typeface="Calibri" pitchFamily="34" charset="-122"/>
                           <a:cs typeface="Arial" panose="020B0604020202020204" pitchFamily="34" charset="0"/>
                         </a:rPr>
-                        <a:t>Descargo</a:t>
-                      </a:r>
-                      <a:endParaRPr lang="es-SV" sz="800" noProof="0" dirty="0">
-                        <a:solidFill>
-                          <a:schemeClr val="tx1"/>
-                        </a:solidFill>
-                        <a:latin typeface="Arial" panose="020B0604020202020204" pitchFamily="34" charset="0"/>
-                        <a:ea typeface="Calibri" charset="0"/>
-                        <a:cs typeface="Arial" panose="020B0604020202020204" pitchFamily="34" charset="0"/>
-                      </a:endParaRPr>
-                    </a:p>
-                    <a:p>
-                      <a:pPr marL="0" indent="0" algn="just">
-                        <a:buNone/>
-                      </a:pPr>
-                      <a:r>
-                        <a:rPr lang="es-SV" sz="800" noProof="0" dirty="0">
-                          <a:solidFill>
-                            <a:schemeClr val="tx1"/>
-                          </a:solidFill>
-                          <a:latin typeface="Arial" panose="020B0604020202020204" pitchFamily="34" charset="0"/>
-                          <a:ea typeface="Calibri" pitchFamily="34" charset="-122"/>
-                          <a:cs typeface="Arial" panose="020B0604020202020204" pitchFamily="34" charset="0"/>
-                        </a:rPr>
                         <a:t>Pendiente</a:t>
                       </a:r>
                       <a:endParaRPr lang="es-SV" sz="800" noProof="0" dirty="0">
@@ -3858,30 +3834,6 @@
                           <a:ea typeface="Calibri" pitchFamily="34" charset="-122"/>
                           <a:cs typeface="Arial" panose="020B0604020202020204" pitchFamily="34" charset="0"/>
                         </a:rPr>
-                        <a:t>Descargo</a:t>
-                      </a:r>
-                      <a:endParaRPr lang="es-SV" sz="800" noProof="0" dirty="0">
-                        <a:solidFill>
-                          <a:schemeClr val="tx1"/>
-                        </a:solidFill>
-                        <a:latin typeface="Arial" panose="020B0604020202020204" pitchFamily="34" charset="0"/>
-                        <a:ea typeface="Calibri" charset="0"/>
-                        <a:cs typeface="Arial" panose="020B0604020202020204" pitchFamily="34" charset="0"/>
-                      </a:endParaRPr>
-                    </a:p>
-                    <a:p>
-                      <a:pPr marL="0" indent="0" algn="just">
-                        <a:buNone/>
-                      </a:pPr>
-                      <a:r>
-                        <a:rPr lang="es-SV" sz="800" noProof="0" dirty="0">
-                          <a:solidFill>
-                            <a:schemeClr val="tx1"/>
-                          </a:solidFill>
-                          <a:latin typeface="Arial" panose="020B0604020202020204" pitchFamily="34" charset="0"/>
-                          <a:ea typeface="Calibri" pitchFamily="34" charset="-122"/>
-                          <a:cs typeface="Arial" panose="020B0604020202020204" pitchFamily="34" charset="0"/>
-                        </a:rPr>
                         <a:t>Pendiente</a:t>
                       </a:r>
                       <a:endParaRPr lang="es-SV" sz="800" noProof="0" dirty="0">
@@ -4268,30 +4220,6 @@
                           <a:ea typeface="Calibri" pitchFamily="34" charset="-122"/>
                           <a:cs typeface="Arial" panose="020B0604020202020204" pitchFamily="34" charset="0"/>
                         </a:rPr>
-                        <a:t>Descargo</a:t>
-                      </a:r>
-                      <a:endParaRPr lang="es-SV" sz="800" noProof="0" dirty="0">
-                        <a:solidFill>
-                          <a:schemeClr val="tx1"/>
-                        </a:solidFill>
-                        <a:latin typeface="Arial" panose="020B0604020202020204" pitchFamily="34" charset="0"/>
-                        <a:ea typeface="Calibri" charset="0"/>
-                        <a:cs typeface="Arial" panose="020B0604020202020204" pitchFamily="34" charset="0"/>
-                      </a:endParaRPr>
-                    </a:p>
-                    <a:p>
-                      <a:pPr marL="0" indent="0" algn="just">
-                        <a:buNone/>
-                      </a:pPr>
-                      <a:r>
-                        <a:rPr lang="es-SV" sz="800" noProof="0" dirty="0">
-                          <a:solidFill>
-                            <a:schemeClr val="tx1"/>
-                          </a:solidFill>
-                          <a:latin typeface="Arial" panose="020B0604020202020204" pitchFamily="34" charset="0"/>
-                          <a:ea typeface="Calibri" pitchFamily="34" charset="-122"/>
-                          <a:cs typeface="Arial" panose="020B0604020202020204" pitchFamily="34" charset="0"/>
-                        </a:rPr>
                         <a:t>Pendiente</a:t>
                       </a:r>
                       <a:endParaRPr lang="es-SV" sz="800" noProof="0" dirty="0">
@@ -4485,7 +4413,7 @@
                           <a:ea typeface="Calibri" pitchFamily="34" charset="-122"/>
                           <a:cs typeface="Arial" panose="020B0604020202020204" pitchFamily="34" charset="0"/>
                         </a:rPr>
-                        <a:t>Plan de acción:</a:t>
+                        <a:t>Como parte del fortalecimiento de los controles de seguridad asociados al servicio tercerizado del módulo ACRM, la Unidad de Seguridad de la Información y Ciberseguridad realizará una reevaluación de los riesgos de seguridad de la información y ciberseguridad, mediante la actualización de la matriz de riesgos y la revisión de los controles existentes, con el propósito de identificar oportunidades de mejora y definir las medidas adicionales de tratamiento que correspondan, en coordinación con el área responsable de la solución el proveedor.</a:t>
                       </a:r>
                       <a:endParaRPr lang="es-SV" sz="800" noProof="0" dirty="0">
                         <a:solidFill>
@@ -4509,7 +4437,7 @@
                           <a:ea typeface="Calibri" pitchFamily="34" charset="-122"/>
                           <a:cs typeface="Arial" panose="020B0604020202020204" pitchFamily="34" charset="0"/>
                         </a:rPr>
-                        <a:t>Pendiente</a:t>
+                        <a:t>Fecha de cumplimiento: 30 de noviembre de 2026.</a:t>
                       </a:r>
                       <a:endParaRPr lang="es-SV" sz="800" noProof="0" dirty="0">
                         <a:solidFill>
@@ -4520,54 +4448,6 @@
                         <a:cs typeface="Arial" panose="020B0604020202020204" pitchFamily="34" charset="0"/>
                       </a:endParaRPr>
                     </a:p>
-                    <a:p>
-                      <a:pPr marL="0" indent="0" algn="just">
-                        <a:buNone/>
-                      </a:pPr>
-                      <a:r>
-                        <a:rPr lang="es-SV" sz="800" noProof="0" dirty="0">
-                          <a:solidFill>
-                            <a:schemeClr val="tx1"/>
-                          </a:solidFill>
-                          <a:latin typeface="Arial" panose="020B0604020202020204" pitchFamily="34" charset="0"/>
-                          <a:ea typeface="Calibri" pitchFamily="34" charset="-122"/>
-                          <a:cs typeface="Arial" panose="020B0604020202020204" pitchFamily="34" charset="0"/>
-                        </a:rPr>
-                        <a:t>Comentario Licda. Bonilla: Como parte del fortalecimiento de los controles de seguridad asociados al servicio tercerizado del módulo ACRM, la Unidad de Seguridad de la Información y Ciberseguridad realizará una reevaluación de los riesgos de seguridad de la información y ciberseguridad, mediante la actualización de la matriz de riesgos y la revisión de los controles existentes, con el propósito de identificar oportunidades de mejora y definir las medidas adicionales de tratamiento que correspondan, en coordinación con el área responsable de la solución el proveedor.</a:t>
-                      </a:r>
-                      <a:endParaRPr lang="es-SV" sz="800" noProof="0" dirty="0">
-                        <a:solidFill>
-                          <a:schemeClr val="tx1"/>
-                        </a:solidFill>
-                        <a:latin typeface="Arial" panose="020B0604020202020204" pitchFamily="34" charset="0"/>
-                        <a:ea typeface="Calibri" charset="0"/>
-                        <a:cs typeface="Arial" panose="020B0604020202020204" pitchFamily="34" charset="0"/>
-                      </a:endParaRPr>
-                    </a:p>
-                    <a:p>
-                      <a:pPr marL="0" indent="0" algn="just">
-                        <a:buNone/>
-                      </a:pPr>
-                      <a:r>
-                        <a:rPr lang="es-SV" sz="800" noProof="0" dirty="0">
-                          <a:solidFill>
-                            <a:schemeClr val="tx1"/>
-                          </a:solidFill>
-                          <a:latin typeface="Arial" panose="020B0604020202020204" pitchFamily="34" charset="0"/>
-                          <a:ea typeface="Calibri" pitchFamily="34" charset="-122"/>
-                          <a:cs typeface="Arial" panose="020B0604020202020204" pitchFamily="34" charset="0"/>
-                        </a:rPr>
-                        <a:t>Fecha de cumplimiento: 30 de noviembre de 2026.</a:t>
-                      </a:r>
-                      <a:endParaRPr lang="es-SV" sz="800" noProof="0" dirty="0">
-                        <a:solidFill>
-                          <a:schemeClr val="tx1"/>
-                        </a:solidFill>
-                        <a:latin typeface="Arial" panose="020B0604020202020204" pitchFamily="34" charset="0"/>
-                        <a:ea typeface="Calibri" charset="0"/>
-                        <a:cs typeface="Arial" panose="020B0604020202020204" pitchFamily="34" charset="0"/>
-                      </a:endParaRPr>
-                    </a:p>
                   </a:txBody>
                   <a:tcPr marL="54864" marR="54864" marT="13716" marB="13716" anchor="ctr">
                     <a:lnL w="0" cap="flat" cmpd="sng" algn="ctr">
@@ -4613,28 +4493,7 @@
                           <a:ea typeface="Calibri" pitchFamily="34" charset="-122"/>
                           <a:cs typeface="Arial" panose="020B0604020202020204" pitchFamily="34" charset="0"/>
                         </a:rPr>
-                        <a:t>Gerencia de Cumplimiento</a:t>
-                      </a:r>
-                      <a:endParaRPr lang="es-SV" sz="800" noProof="0" dirty="0">
-                        <a:latin typeface="Arial" panose="020B0604020202020204" pitchFamily="34" charset="0"/>
-                        <a:ea typeface="Calibri" charset="0"/>
-                        <a:cs typeface="Arial" panose="020B0604020202020204" pitchFamily="34" charset="0"/>
-                      </a:endParaRPr>
-                    </a:p>
-                    <a:p>
-                      <a:pPr marL="0" indent="0" algn="l">
-                        <a:buNone/>
-                      </a:pPr>
-                      <a:r>
-                        <a:rPr lang="es-SV" sz="800" b="1" noProof="0" dirty="0">
-                          <a:solidFill>
-                            <a:schemeClr val="accent1"/>
-                          </a:solidFill>
-                          <a:latin typeface="Arial" panose="020B0604020202020204" pitchFamily="34" charset="0"/>
-                          <a:ea typeface="Calibri" pitchFamily="34" charset="-122"/>
-                          <a:cs typeface="Arial" panose="020B0604020202020204" pitchFamily="34" charset="0"/>
-                        </a:rPr>
-                        <a:t>/ Seguridad de la Información</a:t>
+                        <a:t>Seguridad de la Información</a:t>
                       </a:r>
                       <a:endParaRPr lang="es-SV" sz="800" noProof="0" dirty="0">
                         <a:latin typeface="Arial" panose="020B0604020202020204" pitchFamily="34" charset="0"/>
@@ -4696,7 +4555,7 @@
         </p:blipFill>
         <p:spPr>
           <a:xfrm>
-            <a:off x="9814255" y="109728"/>
+            <a:off x="9814560" y="0"/>
             <a:ext cx="1965960" cy="603504"/>
           </a:xfrm>
           <a:prstGeom prst="rect">
@@ -4785,13 +4644,13 @@
           <p:nvPr>
             <p:extLst>
               <p:ext uri="{D42A27DB-BD31-4B8C-83A1-F6EECF244321}">
-                <p14:modId xmlns:p14="http://schemas.microsoft.com/office/powerpoint/2010/main" val="852790113"/>
+                <p14:modId xmlns:p14="http://schemas.microsoft.com/office/powerpoint/2010/main" val="1314962269"/>
               </p:ext>
             </p:extLst>
           </p:nvPr>
         </p:nvGraphicFramePr>
         <p:xfrm>
-          <a:off x="112296" y="657726"/>
+          <a:off x="112296" y="559367"/>
           <a:ext cx="11983452" cy="6198290"/>
         </p:xfrm>
         <a:graphic>
@@ -6396,6 +6255,22 @@
                         <a:buNone/>
                       </a:pPr>
                       <a:r>
+                        <a:rPr lang="es-MX" sz="750" noProof="0" dirty="0">
+                          <a:solidFill>
+                            <a:schemeClr val="tx1"/>
+                          </a:solidFill>
+                          <a:latin typeface="Arial" panose="020B0604020202020204" pitchFamily="34" charset="0"/>
+                          <a:ea typeface="Calibri" pitchFamily="34" charset="-122"/>
+                          <a:cs typeface="Arial" panose="020B0604020202020204" pitchFamily="34" charset="0"/>
+                        </a:rPr>
+                        <a:t>Se gestionará con la Gerencia de Oficialía de Cumplimiento un nuevo Plan de Acción. Auditoría Interna dará seguimiento.</a:t>
+                      </a:r>
+                    </a:p>
+                    <a:p>
+                      <a:pPr marL="0" indent="0" algn="just">
+                        <a:buNone/>
+                      </a:pPr>
+                      <a:r>
                         <a:rPr lang="es-SV" sz="750" noProof="0" dirty="0">
                           <a:solidFill>
                             <a:schemeClr val="tx1"/>
@@ -6404,7 +6279,7 @@
                           <a:ea typeface="Calibri" pitchFamily="34" charset="-122"/>
                           <a:cs typeface="Arial" panose="020B0604020202020204" pitchFamily="34" charset="0"/>
                         </a:rPr>
-                        <a:t>Sin comentarios ni documentación</a:t>
+                        <a:t>Plazo: 30/11/2026</a:t>
                       </a:r>
                       <a:endParaRPr lang="es-SV" sz="750" noProof="0" dirty="0">
                         <a:latin typeface="Arial" panose="020B0604020202020204" pitchFamily="34" charset="0"/>
@@ -7660,7 +7535,7 @@
         </p:blipFill>
         <p:spPr>
           <a:xfrm>
-            <a:off x="9814255" y="109728"/>
+            <a:off x="9910813" y="-44137"/>
             <a:ext cx="1965960" cy="603504"/>
           </a:xfrm>
           <a:prstGeom prst="rect">

</xml_diff>